<commit_message>
docs: update presentation slides to match current platform architecture
</commit_message>
<xml_diff>
--- a/Beta-Cinemas-Presentation.pptx
+++ b/Beta-Cinemas-Presentation.pptx
@@ -369,7 +369,7 @@
             <a:pPr indent="0" algn="r">
               <a:buNone/>
             </a:pPr>
-            <a:fld id="{F7054B58-AE63-4F59-A05C-CCBCA8D9D6DC}" type="slidenum">
+            <a:fld id="{9D63A443-4DEE-4357-94D6-933CFBC67087}" type="slidenum">
               <a:rPr lang="en-US" sz="1400" b="0" u="none" strike="noStrike">
                 <a:solidFill>
                   <a:srgbClr val="000000"/>
@@ -416,7 +416,7 @@
       </p:grpSpPr>
       <p:sp>
         <p:nvSpPr>
-          <p:cNvPr id="163" name="PlaceHolder 1"/>
+          <p:cNvPr id="171" name="PlaceHolder 1"/>
           <p:cNvSpPr>
             <a:spLocks noGrp="1"/>
           </p:cNvSpPr>
@@ -439,7 +439,7 @@
       </p:sp>
       <p:sp>
         <p:nvSpPr>
-          <p:cNvPr id="164" name="PlaceHolder 2"/>
+          <p:cNvPr id="172" name="PlaceHolder 2"/>
           <p:cNvSpPr>
             <a:spLocks noGrp="1"/>
           </p:cNvSpPr>
@@ -481,7 +481,7 @@
       </p:sp>
       <p:sp>
         <p:nvSpPr>
-          <p:cNvPr id="165" name="PlaceHolder 3"/>
+          <p:cNvPr id="173" name="PlaceHolder 3"/>
           <p:cNvSpPr>
             <a:spLocks noGrp="1"/>
           </p:cNvSpPr>
@@ -530,7 +530,7 @@
               </a:lnSpc>
               <a:buNone/>
             </a:pPr>
-            <a:fld id="{7E5D649E-FC69-459C-ABC6-DB7653454678}" type="slidenum">
+            <a:fld id="{4DAB6A2F-EF74-490F-AB67-6340CC8189A8}" type="slidenum">
               <a:rPr lang="en-US" sz="1200" b="0" u="none" strike="noStrike">
                 <a:solidFill>
                   <a:schemeClr val="dk1"/>
@@ -577,7 +577,7 @@
       </p:grpSpPr>
       <p:sp>
         <p:nvSpPr>
-          <p:cNvPr id="166" name="PlaceHolder 1"/>
+          <p:cNvPr id="174" name="PlaceHolder 1"/>
           <p:cNvSpPr>
             <a:spLocks noGrp="1"/>
           </p:cNvSpPr>
@@ -600,7 +600,7 @@
       </p:sp>
       <p:sp>
         <p:nvSpPr>
-          <p:cNvPr id="167" name="PlaceHolder 2"/>
+          <p:cNvPr id="175" name="PlaceHolder 2"/>
           <p:cNvSpPr>
             <a:spLocks noGrp="1"/>
           </p:cNvSpPr>
@@ -642,7 +642,7 @@
       </p:sp>
       <p:sp>
         <p:nvSpPr>
-          <p:cNvPr id="168" name="PlaceHolder 3"/>
+          <p:cNvPr id="176" name="PlaceHolder 3"/>
           <p:cNvSpPr>
             <a:spLocks noGrp="1"/>
           </p:cNvSpPr>
@@ -691,7 +691,7 @@
               </a:lnSpc>
               <a:buNone/>
             </a:pPr>
-            <a:fld id="{D062E64F-DE60-4A52-8CA6-865C846D3836}" type="slidenum">
+            <a:fld id="{A260F96D-4FFA-4427-9922-7E5EBC2E56E7}" type="slidenum">
               <a:rPr lang="en-US" sz="1200" b="0" u="none" strike="noStrike">
                 <a:solidFill>
                   <a:schemeClr val="dk1"/>
@@ -738,7 +738,7 @@
       </p:grpSpPr>
       <p:sp>
         <p:nvSpPr>
-          <p:cNvPr id="169" name="PlaceHolder 1"/>
+          <p:cNvPr id="177" name="PlaceHolder 1"/>
           <p:cNvSpPr>
             <a:spLocks noGrp="1"/>
           </p:cNvSpPr>
@@ -761,7 +761,7 @@
       </p:sp>
       <p:sp>
         <p:nvSpPr>
-          <p:cNvPr id="170" name="PlaceHolder 2"/>
+          <p:cNvPr id="178" name="PlaceHolder 2"/>
           <p:cNvSpPr>
             <a:spLocks noGrp="1"/>
           </p:cNvSpPr>
@@ -803,7 +803,7 @@
       </p:sp>
       <p:sp>
         <p:nvSpPr>
-          <p:cNvPr id="171" name="PlaceHolder 3"/>
+          <p:cNvPr id="179" name="PlaceHolder 3"/>
           <p:cNvSpPr>
             <a:spLocks noGrp="1"/>
           </p:cNvSpPr>
@@ -852,7 +852,7 @@
               </a:lnSpc>
               <a:buNone/>
             </a:pPr>
-            <a:fld id="{10E47189-F45F-4D9B-8903-6415E7D57290}" type="slidenum">
+            <a:fld id="{CCD56766-836C-4E0D-A458-39E4A4CD0134}" type="slidenum">
               <a:rPr lang="en-US" sz="1200" b="0" u="none" strike="noStrike">
                 <a:solidFill>
                   <a:schemeClr val="dk1"/>
@@ -899,7 +899,7 @@
       </p:grpSpPr>
       <p:sp>
         <p:nvSpPr>
-          <p:cNvPr id="172" name="PlaceHolder 1"/>
+          <p:cNvPr id="180" name="PlaceHolder 1"/>
           <p:cNvSpPr>
             <a:spLocks noGrp="1"/>
           </p:cNvSpPr>
@@ -922,7 +922,7 @@
       </p:sp>
       <p:sp>
         <p:nvSpPr>
-          <p:cNvPr id="173" name="PlaceHolder 2"/>
+          <p:cNvPr id="181" name="PlaceHolder 2"/>
           <p:cNvSpPr>
             <a:spLocks noGrp="1"/>
           </p:cNvSpPr>
@@ -964,7 +964,7 @@
       </p:sp>
       <p:sp>
         <p:nvSpPr>
-          <p:cNvPr id="174" name="PlaceHolder 3"/>
+          <p:cNvPr id="182" name="PlaceHolder 3"/>
           <p:cNvSpPr>
             <a:spLocks noGrp="1"/>
           </p:cNvSpPr>
@@ -1013,7 +1013,7 @@
               </a:lnSpc>
               <a:buNone/>
             </a:pPr>
-            <a:fld id="{16FCFB95-A8AF-4AC1-90E5-96C187516507}" type="slidenum">
+            <a:fld id="{71237995-6AD7-470B-8152-5E22AE17B006}" type="slidenum">
               <a:rPr lang="en-US" sz="1200" b="0" u="none" strike="noStrike">
                 <a:solidFill>
                   <a:schemeClr val="dk1"/>
@@ -1060,7 +1060,7 @@
       </p:grpSpPr>
       <p:sp>
         <p:nvSpPr>
-          <p:cNvPr id="175" name="PlaceHolder 1"/>
+          <p:cNvPr id="183" name="PlaceHolder 1"/>
           <p:cNvSpPr>
             <a:spLocks noGrp="1"/>
           </p:cNvSpPr>
@@ -1083,7 +1083,7 @@
       </p:sp>
       <p:sp>
         <p:nvSpPr>
-          <p:cNvPr id="176" name="PlaceHolder 2"/>
+          <p:cNvPr id="184" name="PlaceHolder 2"/>
           <p:cNvSpPr>
             <a:spLocks noGrp="1"/>
           </p:cNvSpPr>
@@ -1125,7 +1125,7 @@
       </p:sp>
       <p:sp>
         <p:nvSpPr>
-          <p:cNvPr id="177" name="PlaceHolder 3"/>
+          <p:cNvPr id="185" name="PlaceHolder 3"/>
           <p:cNvSpPr>
             <a:spLocks noGrp="1"/>
           </p:cNvSpPr>
@@ -1174,7 +1174,7 @@
               </a:lnSpc>
               <a:buNone/>
             </a:pPr>
-            <a:fld id="{AC6E2C87-48F8-4010-96A2-5CA6553EF412}" type="slidenum">
+            <a:fld id="{FD55C911-AB4F-4B1C-92CE-207DE3E01748}" type="slidenum">
               <a:rPr lang="en-US" sz="1200" b="0" u="none" strike="noStrike">
                 <a:solidFill>
                   <a:schemeClr val="dk1"/>
@@ -1221,7 +1221,7 @@
       </p:grpSpPr>
       <p:sp>
         <p:nvSpPr>
-          <p:cNvPr id="178" name="PlaceHolder 1"/>
+          <p:cNvPr id="186" name="PlaceHolder 1"/>
           <p:cNvSpPr>
             <a:spLocks noGrp="1"/>
           </p:cNvSpPr>
@@ -1244,7 +1244,7 @@
       </p:sp>
       <p:sp>
         <p:nvSpPr>
-          <p:cNvPr id="179" name="PlaceHolder 2"/>
+          <p:cNvPr id="187" name="PlaceHolder 2"/>
           <p:cNvSpPr>
             <a:spLocks noGrp="1"/>
           </p:cNvSpPr>
@@ -1286,7 +1286,7 @@
       </p:sp>
       <p:sp>
         <p:nvSpPr>
-          <p:cNvPr id="180" name="PlaceHolder 3"/>
+          <p:cNvPr id="188" name="PlaceHolder 3"/>
           <p:cNvSpPr>
             <a:spLocks noGrp="1"/>
           </p:cNvSpPr>
@@ -1335,7 +1335,7 @@
               </a:lnSpc>
               <a:buNone/>
             </a:pPr>
-            <a:fld id="{99B52EBD-B0D3-4F96-A12A-95F0A5E1365E}" type="slidenum">
+            <a:fld id="{6A6DD724-924B-4E22-A7E3-1C53985AD740}" type="slidenum">
               <a:rPr lang="en-US" sz="1200" b="0" u="none" strike="noStrike">
                 <a:solidFill>
                   <a:schemeClr val="dk1"/>
@@ -2427,7 +2427,7 @@
                 <a:uFillTx/>
                 <a:latin typeface="Arial"/>
               </a:rPr>
-              <a:t>Giúp khán giả tra cứu phim, lịch chiếu và đặt vé trực tuyến trong một trải nghiệm liền mạch.</a:t>
+              <a:t>Hệ thống đặt vé xem phim trực tuyến hiện đại (12 trang MPA), tối ưu trải nghiệm trên Mobile &amp; Desktop, tích hợp REST API và Vercel Serverless.</a:t>
             </a:r>
             <a:endParaRPr lang="en-US" sz="1600" b="0" u="none" strike="noStrike">
               <a:solidFill>
@@ -2595,7 +2595,7 @@
                 <a:uFillTx/>
                 <a:latin typeface="Arial"/>
               </a:rPr>
-              <a:t>Tra cứu, chọn suất và đặt vé còn rời rạc</a:t>
+              <a:t>Tra cứu, chọn suất và đặt vé còn rời rạc; thiếu tính minh bạch về giá vé &amp; ưu đãi.</a:t>
             </a:r>
             <a:endParaRPr lang="en-US" sz="1200" b="0" u="none" strike="noStrike">
               <a:solidFill>
@@ -2763,7 +2763,7 @@
                 <a:uFillTx/>
                 <a:latin typeface="Arial"/>
               </a:rPr>
-              <a:t>Khán giả xem phim · nhân viên quản trị</a:t>
+              <a:t>Khán giả xem phim · nhân viên quản lý &amp; soát vé rạp.</a:t>
             </a:r>
             <a:endParaRPr lang="en-US" sz="1200" b="0" u="none" strike="noStrike">
               <a:solidFill>
@@ -3316,7 +3316,7 @@
                 <a:uFillTx/>
                 <a:latin typeface="Arial"/>
               </a:rPr>
-              <a:t>Những gì nhóm đã xây dựng.</a:t>
+              <a:t>Hệ thống 12 trang MPA hoàn chỉnh từ khám phá đến quản trị.</a:t>
             </a:r>
             <a:endParaRPr lang="en-US" sz="3100" b="0" u="none" strike="noStrike">
               <a:solidFill>
@@ -3484,7 +3484,7 @@
                 <a:uFillTx/>
                 <a:latin typeface="Arial"/>
               </a:rPr>
-              <a:t>Khám phá phim</a:t>
+              <a:t>Khám phá &amp; Trailer</a:t>
             </a:r>
             <a:endParaRPr lang="en-US" sz="1500" b="0" u="none" strike="noStrike">
               <a:solidFill>
@@ -3544,7 +3544,7 @@
                 <a:uFillTx/>
                 <a:latin typeface="Arial"/>
               </a:rPr>
-              <a:t>Phim đang chiếu, sắp chiếu, suất đặc biệt</a:t>
+              <a:t>Phim đang chiếu, sắp chiếu, xem trailer YouTube trực tiếp</a:t>
             </a:r>
             <a:endParaRPr lang="en-US" sz="1000" b="0" u="none" strike="noStrike">
               <a:solidFill>
@@ -3712,7 +3712,7 @@
                 <a:uFillTx/>
                 <a:latin typeface="Arial"/>
               </a:rPr>
-              <a:t>Tìm kiếm &amp; lọc</a:t>
+              <a:t>Tìm kiếm &amp; Lọc</a:t>
             </a:r>
             <a:endParaRPr lang="en-US" sz="1500" b="0" u="none" strike="noStrike">
               <a:solidFill>
@@ -3772,7 +3772,7 @@
                 <a:uFillTx/>
                 <a:latin typeface="Arial"/>
               </a:rPr>
-              <a:t>Tên, thể loại, định dạng, độ tuổi</a:t>
+              <a:t>Tìm theo tên, thể loại, định dạng 2D/3D, độ tuổi</a:t>
             </a:r>
             <a:endParaRPr lang="en-US" sz="1000" b="0" u="none" strike="noStrike">
               <a:solidFill>
@@ -3940,7 +3940,7 @@
                 <a:uFillTx/>
                 <a:latin typeface="Arial"/>
               </a:rPr>
-              <a:t>Lịch chiếu</a:t>
+              <a:t>Lịch chiếu theo rạp</a:t>
             </a:r>
             <a:endParaRPr lang="en-US" sz="1500" b="0" u="none" strike="noStrike">
               <a:solidFill>
@@ -4000,7 +4000,7 @@
                 <a:uFillTx/>
                 <a:latin typeface="Arial"/>
               </a:rPr>
-              <a:t>Chọn cụm rạp, ngày và suất chiếu</a:t>
+              <a:t>10 cụm rạp Beta toàn quốc, chọn ngày và suất chiếu linh hoạt</a:t>
             </a:r>
             <a:endParaRPr lang="en-US" sz="1000" b="0" u="none" strike="noStrike">
               <a:solidFill>
@@ -4168,7 +4168,7 @@
                 <a:uFillTx/>
                 <a:latin typeface="Arial"/>
               </a:rPr>
-              <a:t>Chọn ghế</a:t>
+              <a:t>Sơ đồ ghế 164 chỗ</a:t>
             </a:r>
             <a:endParaRPr lang="en-US" sz="1500" b="0" u="none" strike="noStrike">
               <a:solidFill>
@@ -4228,7 +4228,7 @@
                 <a:uFillTx/>
                 <a:latin typeface="Arial"/>
               </a:rPr>
-              <a:t>Standard, VIP, ghế đôi; giữ ghế 5 phút</a:t>
+              <a:t>12 hàng ghế A-M, Standard/VIP/Sweetbox; giữ ghế 5 phút</a:t>
             </a:r>
             <a:endParaRPr lang="en-US" sz="1000" b="0" u="none" strike="noStrike">
               <a:solidFill>
@@ -4396,7 +4396,7 @@
                 <a:uFillTx/>
                 <a:latin typeface="Arial"/>
               </a:rPr>
-              <a:t>Combo &amp; voucher</a:t>
+              <a:t>Combo &amp; Voucher</a:t>
             </a:r>
             <a:endParaRPr lang="en-US" sz="1500" b="0" u="none" strike="noStrike">
               <a:solidFill>
@@ -4456,7 +4456,7 @@
                 <a:uFillTx/>
                 <a:latin typeface="Arial"/>
               </a:rPr>
-              <a:t>Chọn đồ ăn, áp mã, tính lại tổng tiền</a:t>
+              <a:t>Chọn bắp nước, áp mã giảm giá (BETA10/50), tự tính tổng</a:t>
             </a:r>
             <a:endParaRPr lang="en-US" sz="1000" b="0" u="none" strike="noStrike">
               <a:solidFill>
@@ -4624,7 +4624,7 @@
                 <a:uFillTx/>
                 <a:latin typeface="Arial"/>
               </a:rPr>
-              <a:t>Thanh toán &amp; vé QR</a:t>
+              <a:t>Thanh toán &amp; Vé QR</a:t>
             </a:r>
             <a:endParaRPr lang="en-US" sz="1500" b="0" u="none" strike="noStrike">
               <a:solidFill>
@@ -4684,7 +4684,7 @@
                 <a:uFillTx/>
                 <a:latin typeface="Arial"/>
               </a:rPr>
-              <a:t>Thanh toán mô phỏng, xuất vé điện tử</a:t>
+              <a:t>Thanh toán mô phỏng VNPAY/MoMo, tạo vé QR Code check-in</a:t>
             </a:r>
             <a:endParaRPr lang="en-US" sz="1000" b="0" u="none" strike="noStrike">
               <a:solidFill>
@@ -4852,7 +4852,7 @@
                 <a:uFillTx/>
                 <a:latin typeface="Arial"/>
               </a:rPr>
-              <a:t>Tài khoản &amp; Admin</a:t>
+              <a:t>Bảng giá &amp; Tin tức</a:t>
             </a:r>
             <a:endParaRPr lang="en-US" sz="1500" b="0" u="none" strike="noStrike">
               <a:solidFill>
@@ -4912,7 +4912,463 @@
                 <a:uFillTx/>
                 <a:latin typeface="Arial"/>
               </a:rPr>
-              <a:t>Hồ sơ, lịch sử vé, quản trị nội dung</a:t>
+              <a:t>Bảng giá vé theo rạp/ngày/ghế, chuyên trang tin tức &amp; ưu đãi</a:t>
+            </a:r>
+            <a:endParaRPr lang="en-US" sz="1000" b="0" u="none" strike="noStrike">
+              <a:solidFill>
+                <a:srgbClr val="000000"/>
+              </a:solidFill>
+              <a:effectLst/>
+              <a:uFillTx/>
+              <a:latin typeface="Arial"/>
+            </a:endParaRPr>
+          </a:p>
+        </p:txBody>
+      </p:sp>
+      <p:sp>
+        <p:nvSpPr>
+          <p:cNvPr id="62" name="Shape 34"/>
+          <p:cNvSpPr/>
+          <p:nvPr/>
+        </p:nvSpPr>
+        <p:spPr>
+          <a:xfrm>
+            <a:off x="4325040" y="5431680"/>
+            <a:ext cx="3492720" cy="1298160"/>
+          </a:xfrm>
+          <a:prstGeom prst="roundRect">
+            <a:avLst>
+              <a:gd name="adj" fmla="val 5634"/>
+            </a:avLst>
+          </a:prstGeom>
+          <a:solidFill>
+            <a:srgbClr val="FFFFFF"/>
+          </a:solidFill>
+          <a:ln w="12600">
+            <a:solidFill>
+              <a:srgbClr val="E8E6E2"/>
+            </a:solidFill>
+            <a:round/>
+          </a:ln>
+        </p:spPr>
+        <p:style>
+          <a:lnRef idx="0"/>
+          <a:fillRef idx="0"/>
+          <a:effectRef idx="0"/>
+          <a:fontRef idx="minor"/>
+        </p:style>
+        <p:txBody>
+          <a:bodyPr lIns="90000" tIns="45000" rIns="90000" bIns="45000" anchor="t">
+            <a:noAutofit/>
+          </a:bodyPr>
+          <a:p>
+            <a:endParaRPr lang="en-US" sz="1800" b="0" u="none" strike="noStrike">
+              <a:solidFill>
+                <a:srgbClr val="000000"/>
+              </a:solidFill>
+              <a:effectLst/>
+              <a:uFillTx/>
+              <a:latin typeface="Arial"/>
+            </a:endParaRPr>
+          </a:p>
+        </p:txBody>
+      </p:sp>
+      <p:sp>
+        <p:nvSpPr>
+          <p:cNvPr id="63" name="Text 35"/>
+          <p:cNvSpPr/>
+          <p:nvPr/>
+        </p:nvSpPr>
+        <p:spPr>
+          <a:xfrm>
+            <a:off x="4507920" y="5586840"/>
+            <a:ext cx="365400" cy="182520"/>
+          </a:xfrm>
+          <a:prstGeom prst="rect">
+            <a:avLst/>
+          </a:prstGeom>
+          <a:noFill/>
+          <a:ln w="0">
+            <a:noFill/>
+          </a:ln>
+        </p:spPr>
+        <p:style>
+          <a:lnRef idx="0"/>
+          <a:fillRef idx="0"/>
+          <a:effectRef idx="0"/>
+          <a:fontRef idx="minor"/>
+        </p:style>
+        <p:txBody>
+          <a:bodyPr lIns="0" tIns="0" rIns="0" bIns="0" anchor="ctr">
+            <a:noAutofit/>
+          </a:bodyPr>
+          <a:p>
+            <a:pPr defTabSz="914400">
+              <a:lnSpc>
+                <a:spcPct val="100000"/>
+              </a:lnSpc>
+              <a:tabLst>
+                <a:tab pos="0" algn="l"/>
+              </a:tabLst>
+            </a:pPr>
+            <a:r>
+              <a:rPr lang="en-US" sz="1000" b="1" u="none" strike="noStrike">
+                <a:solidFill>
+                  <a:srgbClr val="E51D2A"/>
+                </a:solidFill>
+                <a:effectLst/>
+                <a:uFillTx/>
+                <a:latin typeface="Arial"/>
+              </a:rPr>
+              <a:t>08</a:t>
+            </a:r>
+            <a:endParaRPr lang="en-US" sz="1000" b="0" u="none" strike="noStrike">
+              <a:solidFill>
+                <a:srgbClr val="000000"/>
+              </a:solidFill>
+              <a:effectLst/>
+              <a:uFillTx/>
+              <a:latin typeface="Arial"/>
+            </a:endParaRPr>
+          </a:p>
+        </p:txBody>
+      </p:sp>
+      <p:sp>
+        <p:nvSpPr>
+          <p:cNvPr id="64" name="Text 36"/>
+          <p:cNvSpPr/>
+          <p:nvPr/>
+        </p:nvSpPr>
+        <p:spPr>
+          <a:xfrm>
+            <a:off x="4507920" y="5906880"/>
+            <a:ext cx="3062880" cy="273960"/>
+          </a:xfrm>
+          <a:prstGeom prst="rect">
+            <a:avLst/>
+          </a:prstGeom>
+          <a:noFill/>
+          <a:ln w="0">
+            <a:noFill/>
+          </a:ln>
+        </p:spPr>
+        <p:style>
+          <a:lnRef idx="0"/>
+          <a:fillRef idx="0"/>
+          <a:effectRef idx="0"/>
+          <a:fontRef idx="minor"/>
+        </p:style>
+        <p:txBody>
+          <a:bodyPr lIns="0" tIns="0" rIns="0" bIns="0" anchor="ctr">
+            <a:normAutofit/>
+          </a:bodyPr>
+          <a:p>
+            <a:pPr defTabSz="914400">
+              <a:lnSpc>
+                <a:spcPct val="100000"/>
+              </a:lnSpc>
+              <a:tabLst>
+                <a:tab pos="0" algn="l"/>
+              </a:tabLst>
+            </a:pPr>
+            <a:r>
+              <a:rPr lang="en-US" sz="1500" b="1" u="none" strike="noStrike">
+                <a:solidFill>
+                  <a:srgbClr val="171923"/>
+                </a:solidFill>
+                <a:effectLst/>
+                <a:uFillTx/>
+                <a:latin typeface="Arial"/>
+              </a:rPr>
+              <a:t>Tài khoản &amp; Hồ sơ</a:t>
+            </a:r>
+            <a:endParaRPr lang="en-US" sz="1500" b="0" u="none" strike="noStrike">
+              <a:solidFill>
+                <a:srgbClr val="000000"/>
+              </a:solidFill>
+              <a:effectLst/>
+              <a:uFillTx/>
+              <a:latin typeface="Arial"/>
+            </a:endParaRPr>
+          </a:p>
+        </p:txBody>
+      </p:sp>
+      <p:sp>
+        <p:nvSpPr>
+          <p:cNvPr id="65" name="Text 37"/>
+          <p:cNvSpPr/>
+          <p:nvPr/>
+        </p:nvSpPr>
+        <p:spPr>
+          <a:xfrm>
+            <a:off x="4507920" y="6254640"/>
+            <a:ext cx="3062880" cy="319680"/>
+          </a:xfrm>
+          <a:prstGeom prst="rect">
+            <a:avLst/>
+          </a:prstGeom>
+          <a:noFill/>
+          <a:ln w="0">
+            <a:noFill/>
+          </a:ln>
+        </p:spPr>
+        <p:style>
+          <a:lnRef idx="0"/>
+          <a:fillRef idx="0"/>
+          <a:effectRef idx="0"/>
+          <a:fontRef idx="minor"/>
+        </p:style>
+        <p:txBody>
+          <a:bodyPr lIns="0" tIns="0" rIns="0" bIns="0" anchor="ctr">
+            <a:normAutofit/>
+          </a:bodyPr>
+          <a:p>
+            <a:pPr defTabSz="914400">
+              <a:lnSpc>
+                <a:spcPct val="100000"/>
+              </a:lnSpc>
+              <a:tabLst>
+                <a:tab pos="0" algn="l"/>
+              </a:tabLst>
+            </a:pPr>
+            <a:r>
+              <a:rPr lang="en-US" sz="1000" b="0" u="none" strike="noStrike">
+                <a:solidFill>
+                  <a:srgbClr val="747985"/>
+                </a:solidFill>
+                <a:effectLst/>
+                <a:uFillTx/>
+                <a:latin typeface="Arial"/>
+              </a:rPr>
+              <a:t>Hồ sơ VIP, tích lũy điểm thưởng, lưu và xem lại vé QR</a:t>
+            </a:r>
+            <a:endParaRPr lang="en-US" sz="1000" b="0" u="none" strike="noStrike">
+              <a:solidFill>
+                <a:srgbClr val="000000"/>
+              </a:solidFill>
+              <a:effectLst/>
+              <a:uFillTx/>
+              <a:latin typeface="Arial"/>
+            </a:endParaRPr>
+          </a:p>
+        </p:txBody>
+      </p:sp>
+      <p:sp>
+        <p:nvSpPr>
+          <p:cNvPr id="66" name="Shape 38"/>
+          <p:cNvSpPr/>
+          <p:nvPr/>
+        </p:nvSpPr>
+        <p:spPr>
+          <a:xfrm>
+            <a:off x="8055720" y="5431680"/>
+            <a:ext cx="3492720" cy="1298160"/>
+          </a:xfrm>
+          <a:prstGeom prst="roundRect">
+            <a:avLst>
+              <a:gd name="adj" fmla="val 5634"/>
+            </a:avLst>
+          </a:prstGeom>
+          <a:solidFill>
+            <a:srgbClr val="FFFFFF"/>
+          </a:solidFill>
+          <a:ln w="12600">
+            <a:solidFill>
+              <a:srgbClr val="E8E6E2"/>
+            </a:solidFill>
+            <a:round/>
+          </a:ln>
+        </p:spPr>
+        <p:style>
+          <a:lnRef idx="0"/>
+          <a:fillRef idx="0"/>
+          <a:effectRef idx="0"/>
+          <a:fontRef idx="minor"/>
+        </p:style>
+        <p:txBody>
+          <a:bodyPr lIns="90000" tIns="45000" rIns="90000" bIns="45000" anchor="t">
+            <a:noAutofit/>
+          </a:bodyPr>
+          <a:p>
+            <a:endParaRPr lang="en-US" sz="1800" b="0" u="none" strike="noStrike">
+              <a:solidFill>
+                <a:srgbClr val="000000"/>
+              </a:solidFill>
+              <a:effectLst/>
+              <a:uFillTx/>
+              <a:latin typeface="Arial"/>
+            </a:endParaRPr>
+          </a:p>
+        </p:txBody>
+      </p:sp>
+      <p:sp>
+        <p:nvSpPr>
+          <p:cNvPr id="67" name="Text 39"/>
+          <p:cNvSpPr/>
+          <p:nvPr/>
+        </p:nvSpPr>
+        <p:spPr>
+          <a:xfrm>
+            <a:off x="8238600" y="5586840"/>
+            <a:ext cx="365400" cy="182520"/>
+          </a:xfrm>
+          <a:prstGeom prst="rect">
+            <a:avLst/>
+          </a:prstGeom>
+          <a:noFill/>
+          <a:ln w="0">
+            <a:noFill/>
+          </a:ln>
+        </p:spPr>
+        <p:style>
+          <a:lnRef idx="0"/>
+          <a:fillRef idx="0"/>
+          <a:effectRef idx="0"/>
+          <a:fontRef idx="minor"/>
+        </p:style>
+        <p:txBody>
+          <a:bodyPr lIns="0" tIns="0" rIns="0" bIns="0" anchor="ctr">
+            <a:noAutofit/>
+          </a:bodyPr>
+          <a:p>
+            <a:pPr defTabSz="914400">
+              <a:lnSpc>
+                <a:spcPct val="100000"/>
+              </a:lnSpc>
+              <a:tabLst>
+                <a:tab pos="0" algn="l"/>
+              </a:tabLst>
+            </a:pPr>
+            <a:r>
+              <a:rPr lang="en-US" sz="1000" b="1" u="none" strike="noStrike">
+                <a:solidFill>
+                  <a:srgbClr val="E51D2A"/>
+                </a:solidFill>
+                <a:effectLst/>
+                <a:uFillTx/>
+                <a:latin typeface="Arial"/>
+              </a:rPr>
+              <a:t>09</a:t>
+            </a:r>
+            <a:endParaRPr lang="en-US" sz="1000" b="0" u="none" strike="noStrike">
+              <a:solidFill>
+                <a:srgbClr val="000000"/>
+              </a:solidFill>
+              <a:effectLst/>
+              <a:uFillTx/>
+              <a:latin typeface="Arial"/>
+            </a:endParaRPr>
+          </a:p>
+        </p:txBody>
+      </p:sp>
+      <p:sp>
+        <p:nvSpPr>
+          <p:cNvPr id="68" name="Text 40"/>
+          <p:cNvSpPr/>
+          <p:nvPr/>
+        </p:nvSpPr>
+        <p:spPr>
+          <a:xfrm>
+            <a:off x="8238600" y="5906880"/>
+            <a:ext cx="3062880" cy="273960"/>
+          </a:xfrm>
+          <a:prstGeom prst="rect">
+            <a:avLst/>
+          </a:prstGeom>
+          <a:noFill/>
+          <a:ln w="0">
+            <a:noFill/>
+          </a:ln>
+        </p:spPr>
+        <p:style>
+          <a:lnRef idx="0"/>
+          <a:fillRef idx="0"/>
+          <a:effectRef idx="0"/>
+          <a:fontRef idx="minor"/>
+        </p:style>
+        <p:txBody>
+          <a:bodyPr lIns="0" tIns="0" rIns="0" bIns="0" anchor="ctr">
+            <a:normAutofit/>
+          </a:bodyPr>
+          <a:p>
+            <a:pPr defTabSz="914400">
+              <a:lnSpc>
+                <a:spcPct val="100000"/>
+              </a:lnSpc>
+              <a:tabLst>
+                <a:tab pos="0" algn="l"/>
+              </a:tabLst>
+            </a:pPr>
+            <a:r>
+              <a:rPr lang="en-US" sz="1500" b="1" u="none" strike="noStrike">
+                <a:solidFill>
+                  <a:srgbClr val="171923"/>
+                </a:solidFill>
+                <a:effectLst/>
+                <a:uFillTx/>
+                <a:latin typeface="Arial"/>
+              </a:rPr>
+              <a:t>Cổng Quản Trị (Admin)</a:t>
+            </a:r>
+            <a:endParaRPr lang="en-US" sz="1500" b="0" u="none" strike="noStrike">
+              <a:solidFill>
+                <a:srgbClr val="000000"/>
+              </a:solidFill>
+              <a:effectLst/>
+              <a:uFillTx/>
+              <a:latin typeface="Arial"/>
+            </a:endParaRPr>
+          </a:p>
+        </p:txBody>
+      </p:sp>
+      <p:sp>
+        <p:nvSpPr>
+          <p:cNvPr id="69" name="Text 41"/>
+          <p:cNvSpPr/>
+          <p:nvPr/>
+        </p:nvSpPr>
+        <p:spPr>
+          <a:xfrm>
+            <a:off x="8238600" y="6254640"/>
+            <a:ext cx="3062880" cy="319680"/>
+          </a:xfrm>
+          <a:prstGeom prst="rect">
+            <a:avLst/>
+          </a:prstGeom>
+          <a:noFill/>
+          <a:ln w="0">
+            <a:noFill/>
+          </a:ln>
+        </p:spPr>
+        <p:style>
+          <a:lnRef idx="0"/>
+          <a:fillRef idx="0"/>
+          <a:effectRef idx="0"/>
+          <a:fontRef idx="minor"/>
+        </p:style>
+        <p:txBody>
+          <a:bodyPr lIns="0" tIns="0" rIns="0" bIns="0" anchor="ctr">
+            <a:normAutofit/>
+          </a:bodyPr>
+          <a:p>
+            <a:pPr defTabSz="914400">
+              <a:lnSpc>
+                <a:spcPct val="100000"/>
+              </a:lnSpc>
+              <a:tabLst>
+                <a:tab pos="0" algn="l"/>
+              </a:tabLst>
+            </a:pPr>
+            <a:r>
+              <a:rPr lang="en-US" sz="1000" b="0" u="none" strike="noStrike">
+                <a:solidFill>
+                  <a:srgbClr val="747985"/>
+                </a:solidFill>
+                <a:effectLst/>
+                <a:uFillTx/>
+                <a:latin typeface="Arial"/>
+              </a:rPr>
+              <a:t>Auth Gate bảo mật, Dashboard KPI doanh thu, Full CRUD dữ liệu</a:t>
             </a:r>
             <a:endParaRPr lang="en-US" sz="1000" b="0" u="none" strike="noStrike">
               <a:solidFill>
@@ -4964,7 +5420,7 @@
       </p:grpSpPr>
       <p:sp>
         <p:nvSpPr>
-          <p:cNvPr id="62" name="Shape 0"/>
+          <p:cNvPr id="70" name="Shape 0"/>
           <p:cNvSpPr/>
           <p:nvPr/>
         </p:nvSpPr>
@@ -5012,7 +5468,7 @@
       </p:sp>
       <p:sp>
         <p:nvSpPr>
-          <p:cNvPr id="63" name="Text 1"/>
+          <p:cNvPr id="71" name="Text 1"/>
           <p:cNvSpPr/>
           <p:nvPr/>
         </p:nvSpPr>
@@ -5072,7 +5528,7 @@
       </p:sp>
       <p:sp>
         <p:nvSpPr>
-          <p:cNvPr id="64" name="Text 2"/>
+          <p:cNvPr id="72" name="Text 2"/>
           <p:cNvSpPr/>
           <p:nvPr/>
         </p:nvSpPr>
@@ -5132,7 +5588,7 @@
       </p:sp>
       <p:sp>
         <p:nvSpPr>
-          <p:cNvPr id="65" name="Text 3"/>
+          <p:cNvPr id="73" name="Text 3"/>
           <p:cNvSpPr/>
           <p:nvPr/>
         </p:nvSpPr>
@@ -5192,7 +5648,7 @@
       </p:sp>
       <p:sp>
         <p:nvSpPr>
-          <p:cNvPr id="66" name="Text 4"/>
+          <p:cNvPr id="74" name="Text 4"/>
           <p:cNvSpPr/>
           <p:nvPr/>
         </p:nvSpPr>
@@ -5252,7 +5708,7 @@
       </p:sp>
       <p:sp>
         <p:nvSpPr>
-          <p:cNvPr id="67" name="Text 5"/>
+          <p:cNvPr id="75" name="Text 5"/>
           <p:cNvSpPr/>
           <p:nvPr/>
         </p:nvSpPr>
@@ -5297,7 +5753,7 @@
                 <a:uFillTx/>
                 <a:latin typeface="Arial"/>
               </a:rPr>
-              <a:t>Hoàn thành 100% chức năng MVP &amp; tích hợp Backend.</a:t>
+              <a:t>Hoàn thành 100% chức năng MVP, tích hợp Backend &amp; kiểm thử tự động.</a:t>
             </a:r>
             <a:endParaRPr lang="en-US" sz="3100" b="0" u="none" strike="noStrike">
               <a:solidFill>
@@ -5312,7 +5768,7 @@
       </p:sp>
       <p:sp>
         <p:nvSpPr>
-          <p:cNvPr id="68" name="Shape 6"/>
+          <p:cNvPr id="76" name="Shape 6"/>
           <p:cNvSpPr/>
           <p:nvPr/>
         </p:nvSpPr>
@@ -5360,7 +5816,7 @@
       </p:sp>
       <p:sp>
         <p:nvSpPr>
-          <p:cNvPr id="69" name="Text 7"/>
+          <p:cNvPr id="77" name="Text 7"/>
           <p:cNvSpPr/>
           <p:nvPr/>
         </p:nvSpPr>
@@ -5405,7 +5861,7 @@
                 <a:uFillTx/>
                 <a:latin typeface="Arial"/>
               </a:rPr>
-              <a:t>ĐÃ HOÀN THÀNH (MVP &amp; BACKEND)</a:t>
+              <a:t>ĐÃ HOÀN THÀNH (12 TRANG MPA &amp; TÍNH NĂNG)</a:t>
             </a:r>
             <a:endParaRPr lang="en-US" sz="1400" b="0" u="none" strike="noStrike">
               <a:solidFill>
@@ -5420,7 +5876,7 @@
       </p:sp>
       <p:sp>
         <p:nvSpPr>
-          <p:cNvPr id="70" name="Text 8"/>
+          <p:cNvPr id="78" name="Text 8"/>
           <p:cNvSpPr/>
           <p:nvPr/>
         </p:nvSpPr>
@@ -5480,7 +5936,7 @@
       </p:sp>
       <p:sp>
         <p:nvSpPr>
-          <p:cNvPr id="71" name="Text 9"/>
+          <p:cNvPr id="79" name="Text 9"/>
           <p:cNvSpPr/>
           <p:nvPr/>
         </p:nvSpPr>
@@ -5525,7 +5981,7 @@
                 <a:uFillTx/>
                 <a:latin typeface="Arial"/>
               </a:rPr>
-              <a:t>Khám phá, tìm kiếm, lọc, chi tiết phim &amp; trailer</a:t>
+              <a:t>Khám phá, tìm kiếm, lọc phim, trailer YouTube modal</a:t>
             </a:r>
             <a:endParaRPr lang="en-US" sz="1050" b="0" u="none" strike="noStrike">
               <a:solidFill>
@@ -5540,7 +5996,7 @@
       </p:sp>
       <p:sp>
         <p:nvSpPr>
-          <p:cNvPr id="72" name="Text 10"/>
+          <p:cNvPr id="80" name="Text 10"/>
           <p:cNvSpPr/>
           <p:nvPr/>
         </p:nvSpPr>
@@ -5600,7 +6056,7 @@
       </p:sp>
       <p:sp>
         <p:nvSpPr>
-          <p:cNvPr id="73" name="Text 11"/>
+          <p:cNvPr id="81" name="Text 11"/>
           <p:cNvSpPr/>
           <p:nvPr/>
         </p:nvSpPr>
@@ -5645,7 +6101,7 @@
                 <a:uFillTx/>
                 <a:latin typeface="Arial"/>
               </a:rPr>
-              <a:t>Lịch chiếu, sơ đồ chọn ghế, đồng hồ giữ ghế 5 phút</a:t>
+              <a:t>Lịch chiếu 10 rạp, sơ đồ 164 ghế A-M, giữ ghế 5 phút</a:t>
             </a:r>
             <a:endParaRPr lang="en-US" sz="1050" b="0" u="none" strike="noStrike">
               <a:solidFill>
@@ -5660,7 +6116,7 @@
       </p:sp>
       <p:sp>
         <p:nvSpPr>
-          <p:cNvPr id="74" name="Text 12"/>
+          <p:cNvPr id="82" name="Text 12"/>
           <p:cNvSpPr/>
           <p:nvPr/>
         </p:nvSpPr>
@@ -5720,7 +6176,7 @@
       </p:sp>
       <p:sp>
         <p:nvSpPr>
-          <p:cNvPr id="75" name="Text 13"/>
+          <p:cNvPr id="83" name="Text 13"/>
           <p:cNvSpPr/>
           <p:nvPr/>
         </p:nvSpPr>
@@ -5765,7 +6221,7 @@
                 <a:uFillTx/>
                 <a:latin typeface="Arial"/>
               </a:rPr>
-              <a:t>Combo bắp nước, mã giảm giá voucher, thanh toán mô phỏng</a:t>
+              <a:t>Bắp nước, mã giảm giá voucher, thanh toán mô phỏng, vé QR</a:t>
             </a:r>
             <a:endParaRPr lang="en-US" sz="1050" b="0" u="none" strike="noStrike">
               <a:solidFill>
@@ -5780,7 +6236,7 @@
       </p:sp>
       <p:sp>
         <p:nvSpPr>
-          <p:cNvPr id="76" name="Text 14"/>
+          <p:cNvPr id="84" name="Text 14"/>
           <p:cNvSpPr/>
           <p:nvPr/>
         </p:nvSpPr>
@@ -5840,7 +6296,7 @@
       </p:sp>
       <p:sp>
         <p:nvSpPr>
-          <p:cNvPr id="77" name="Text 15"/>
+          <p:cNvPr id="85" name="Text 15"/>
           <p:cNvSpPr/>
           <p:nvPr/>
         </p:nvSpPr>
@@ -5885,7 +6341,7 @@
                 <a:uFillTx/>
                 <a:latin typeface="Arial"/>
               </a:rPr>
-              <a:t>Vé điện tử QR code, quản lý hồ sơ và lịch sử đặt vé</a:t>
+              <a:t>Bảng giá vé theo rạp/ngày/ghế, trang tin tức &amp; ưu đãi</a:t>
             </a:r>
             <a:endParaRPr lang="en-US" sz="1050" b="0" u="none" strike="noStrike">
               <a:solidFill>
@@ -5900,7 +6356,7 @@
       </p:sp>
       <p:sp>
         <p:nvSpPr>
-          <p:cNvPr id="78" name="Text 16"/>
+          <p:cNvPr id="86" name="Text 16"/>
           <p:cNvSpPr/>
           <p:nvPr/>
         </p:nvSpPr>
@@ -5960,7 +6416,7 @@
       </p:sp>
       <p:sp>
         <p:nvSpPr>
-          <p:cNvPr id="79" name="Text 17"/>
+          <p:cNvPr id="87" name="Text 17"/>
           <p:cNvSpPr/>
           <p:nvPr/>
         </p:nvSpPr>
@@ -6005,7 +6461,7 @@
                 <a:uFillTx/>
                 <a:latin typeface="Arial"/>
               </a:rPr>
-              <a:t>Backend json-server: Full CRUD phim, lịch chiếu, combo, đơn vé</a:t>
+              <a:t>Cổng Admin: Auth Gate bảo mật, Dashboard KPI, Full CRUD</a:t>
             </a:r>
             <a:endParaRPr lang="en-US" sz="1050" b="0" u="none" strike="noStrike">
               <a:solidFill>
@@ -6020,7 +6476,7 @@
       </p:sp>
       <p:sp>
         <p:nvSpPr>
-          <p:cNvPr id="80" name="Shape 18"/>
+          <p:cNvPr id="88" name="Shape 18"/>
           <p:cNvSpPr/>
           <p:nvPr/>
         </p:nvSpPr>
@@ -6068,7 +6524,7 @@
       </p:sp>
       <p:sp>
         <p:nvSpPr>
-          <p:cNvPr id="81" name="Text 19"/>
+          <p:cNvPr id="89" name="Text 19"/>
           <p:cNvSpPr/>
           <p:nvPr/>
         </p:nvSpPr>
@@ -6113,7 +6569,7 @@
                 <a:uFillTx/>
                 <a:latin typeface="Arial"/>
               </a:rPr>
-              <a:t>ĐÃ TÍCH HỢP &amp; GIAI ĐOẠN TIẾP THEO</a:t>
+              <a:t>BACKEND, DEPLOYMENT &amp; KIỂM THỬ</a:t>
             </a:r>
             <a:endParaRPr lang="en-US" sz="1400" b="0" u="none" strike="noStrike">
               <a:solidFill>
@@ -6128,7 +6584,7 @@
       </p:sp>
       <p:sp>
         <p:nvSpPr>
-          <p:cNvPr id="82" name="Text 20"/>
+          <p:cNvPr id="90" name="Text 20"/>
           <p:cNvSpPr/>
           <p:nvPr/>
         </p:nvSpPr>
@@ -6188,7 +6644,7 @@
       </p:sp>
       <p:sp>
         <p:nvSpPr>
-          <p:cNvPr id="83" name="Text 21"/>
+          <p:cNvPr id="91" name="Text 21"/>
           <p:cNvSpPr/>
           <p:nvPr/>
         </p:nvSpPr>
@@ -6248,7 +6704,7 @@
       </p:sp>
       <p:sp>
         <p:nvSpPr>
-          <p:cNvPr id="84" name="Text 22"/>
+          <p:cNvPr id="92" name="Text 22"/>
           <p:cNvSpPr/>
           <p:nvPr/>
         </p:nvSpPr>
@@ -6308,7 +6764,7 @@
       </p:sp>
       <p:sp>
         <p:nvSpPr>
-          <p:cNvPr id="85" name="Text 23"/>
+          <p:cNvPr id="93" name="Text 23"/>
           <p:cNvSpPr/>
           <p:nvPr/>
         </p:nvSpPr>
@@ -6353,7 +6809,7 @@
                 <a:uFillTx/>
                 <a:latin typeface="Arial"/>
               </a:rPr>
-              <a:t>Bun Runtime: Tối ưu hóa tốc độ build và thực thi cực nhanh</a:t>
+              <a:t>Bun Runtime &amp; Vite MPA: Tối ưu build 500ms, hỗ trợ Vercel Serverless</a:t>
             </a:r>
             <a:endParaRPr lang="en-US" sz="1100" b="0" u="none" strike="noStrike">
               <a:solidFill>
@@ -6368,7 +6824,7 @@
       </p:sp>
       <p:sp>
         <p:nvSpPr>
-          <p:cNvPr id="86" name="Text 24"/>
+          <p:cNvPr id="94" name="Text 24"/>
           <p:cNvSpPr/>
           <p:nvPr/>
         </p:nvSpPr>
@@ -6428,7 +6884,7 @@
       </p:sp>
       <p:sp>
         <p:nvSpPr>
-          <p:cNvPr id="87" name="Text 25"/>
+          <p:cNvPr id="95" name="Text 25"/>
           <p:cNvSpPr/>
           <p:nvPr/>
         </p:nvSpPr>
@@ -6473,7 +6929,7 @@
                 <a:uFillTx/>
                 <a:latin typeface="Arial"/>
               </a:rPr>
-              <a:t>Kiểm thử toàn diện: Bộ test tự động 26/26 use case đạt 100% PASS</a:t>
+              <a:t>Kiểm thử toàn diện: Bộ test tự động 28/28 use case đạt 100% PASS</a:t>
             </a:r>
             <a:endParaRPr lang="en-US" sz="1100" b="0" u="none" strike="noStrike">
               <a:solidFill>
@@ -6488,7 +6944,7 @@
       </p:sp>
       <p:sp>
         <p:nvSpPr>
-          <p:cNvPr id="88" name="Text 26"/>
+          <p:cNvPr id="96" name="Text 26"/>
           <p:cNvSpPr/>
           <p:nvPr/>
         </p:nvSpPr>
@@ -6548,7 +7004,7 @@
       </p:sp>
       <p:sp>
         <p:nvSpPr>
-          <p:cNvPr id="89" name="Text 27"/>
+          <p:cNvPr id="97" name="Text 27"/>
           <p:cNvSpPr/>
           <p:nvPr/>
         </p:nvSpPr>
@@ -6593,7 +7049,7 @@
                 <a:uFillTx/>
                 <a:latin typeface="Arial"/>
               </a:rPr>
-              <a:t>Tiếp theo: Tích hợp cổng thanh toán Sandbox thực tế (VNPAY/MoMo)</a:t>
+              <a:t>Hệ thống xử lý lỗi: Tự động điều hướng và hiển thị trang 404 &amp; Error</a:t>
             </a:r>
             <a:endParaRPr lang="en-US" sz="1100" b="0" u="none" strike="noStrike">
               <a:solidFill>
@@ -6608,7 +7064,7 @@
       </p:sp>
       <p:sp>
         <p:nvSpPr>
-          <p:cNvPr id="90" name="Text 28"/>
+          <p:cNvPr id="98" name="Text 28"/>
           <p:cNvSpPr/>
           <p:nvPr/>
         </p:nvSpPr>
@@ -6653,7 +7109,7 @@
                 <a:uFillTx/>
                 <a:latin typeface="Arial"/>
               </a:rPr>
-              <a:t>Toàn bộ đầu việc đã hoàn thành xuất sắc và refactor thành công sang json-server + json-server-auth trên Bun.</a:t>
+              <a:t>Hệ thống hoàn thành 100% tiến độ, chuẩn kiến trúc MPA, sẵn sàng demo và đưa vào sử dụng.</a:t>
             </a:r>
             <a:endParaRPr lang="en-US" sz="900" b="0" u="none" strike="noStrike">
               <a:solidFill>
@@ -6705,7 +7161,7 @@
       </p:grpSpPr>
       <p:sp>
         <p:nvSpPr>
-          <p:cNvPr id="91" name="Shape 0"/>
+          <p:cNvPr id="99" name="Shape 0"/>
           <p:cNvSpPr/>
           <p:nvPr/>
         </p:nvSpPr>
@@ -6753,7 +7209,7 @@
       </p:sp>
       <p:sp>
         <p:nvSpPr>
-          <p:cNvPr id="92" name="Text 1"/>
+          <p:cNvPr id="100" name="Text 1"/>
           <p:cNvSpPr/>
           <p:nvPr/>
         </p:nvSpPr>
@@ -6813,7 +7269,7 @@
       </p:sp>
       <p:sp>
         <p:nvSpPr>
-          <p:cNvPr id="93" name="Text 2"/>
+          <p:cNvPr id="101" name="Text 2"/>
           <p:cNvSpPr/>
           <p:nvPr/>
         </p:nvSpPr>
@@ -6873,7 +7329,7 @@
       </p:sp>
       <p:sp>
         <p:nvSpPr>
-          <p:cNvPr id="94" name="Text 3"/>
+          <p:cNvPr id="102" name="Text 3"/>
           <p:cNvSpPr/>
           <p:nvPr/>
         </p:nvSpPr>
@@ -6933,7 +7389,7 @@
       </p:sp>
       <p:sp>
         <p:nvSpPr>
-          <p:cNvPr id="95" name="Text 4"/>
+          <p:cNvPr id="103" name="Text 4"/>
           <p:cNvSpPr/>
           <p:nvPr/>
         </p:nvSpPr>
@@ -6993,7 +7449,7 @@
       </p:sp>
       <p:sp>
         <p:nvSpPr>
-          <p:cNvPr id="96" name="Text 5"/>
+          <p:cNvPr id="104" name="Text 5"/>
           <p:cNvSpPr/>
           <p:nvPr/>
         </p:nvSpPr>
@@ -7038,7 +7494,7 @@
                 <a:uFillTx/>
                 <a:latin typeface="Arial"/>
               </a:rPr>
-              <a:t>Kiến trúc kết hợp Vite MPA, json-server CRUD và json-server-auth.</a:t>
+              <a:t>Kiến trúc hiện đại kết hợp Vite MPA, Bun Runtime, REST API và Vercel.</a:t>
             </a:r>
             <a:endParaRPr lang="en-US" sz="3100" b="0" u="none" strike="noStrike">
               <a:solidFill>
@@ -7053,7 +7509,7 @@
       </p:sp>
       <p:sp>
         <p:nvSpPr>
-          <p:cNvPr id="97" name="Shape 6"/>
+          <p:cNvPr id="105" name="Shape 6"/>
           <p:cNvSpPr/>
           <p:nvPr/>
         </p:nvSpPr>
@@ -7101,7 +7557,7 @@
       </p:sp>
       <p:sp>
         <p:nvSpPr>
-          <p:cNvPr id="98" name="Text 7"/>
+          <p:cNvPr id="106" name="Text 7"/>
           <p:cNvSpPr/>
           <p:nvPr/>
         </p:nvSpPr>
@@ -7161,7 +7617,7 @@
       </p:sp>
       <p:sp>
         <p:nvSpPr>
-          <p:cNvPr id="99" name="Text 8"/>
+          <p:cNvPr id="107" name="Text 8"/>
           <p:cNvSpPr/>
           <p:nvPr/>
         </p:nvSpPr>
@@ -7206,7 +7662,7 @@
                 <a:uFillTx/>
                 <a:latin typeface="Arial"/>
               </a:rPr>
-              <a:t>Giao diện đa trang (MPA), responsive Mobile/PC</a:t>
+              <a:t>Giao diện 12 trang (MPA), SCSS module hóa, responsive Mobile/PC</a:t>
             </a:r>
             <a:endParaRPr lang="en-US" sz="900" b="0" u="none" strike="noStrike">
               <a:solidFill>
@@ -7221,7 +7677,7 @@
       </p:sp>
       <p:sp>
         <p:nvSpPr>
-          <p:cNvPr id="100" name="Shape 9"/>
+          <p:cNvPr id="108" name="Shape 9"/>
           <p:cNvSpPr/>
           <p:nvPr/>
         </p:nvSpPr>
@@ -7269,7 +7725,7 @@
       </p:sp>
       <p:sp>
         <p:nvSpPr>
-          <p:cNvPr id="101" name="Text 10"/>
+          <p:cNvPr id="109" name="Text 10"/>
           <p:cNvSpPr/>
           <p:nvPr/>
         </p:nvSpPr>
@@ -7329,7 +7785,7 @@
       </p:sp>
       <p:sp>
         <p:nvSpPr>
-          <p:cNvPr id="102" name="Text 11"/>
+          <p:cNvPr id="110" name="Text 11"/>
           <p:cNvSpPr/>
           <p:nvPr/>
         </p:nvSpPr>
@@ -7374,7 +7830,7 @@
                 <a:uFillTx/>
                 <a:latin typeface="Arial"/>
               </a:rPr>
-              <a:t>Module tương tác luồng đặt vé, chạy trên Bun siêu tốc</a:t>
+              <a:t>Xử lý luồng đặt vé không phụ thuộc framework cồng kềnh, chạy trên Bun</a:t>
             </a:r>
             <a:endParaRPr lang="en-US" sz="900" b="0" u="none" strike="noStrike">
               <a:solidFill>
@@ -7389,7 +7845,7 @@
       </p:sp>
       <p:sp>
         <p:nvSpPr>
-          <p:cNvPr id="103" name="Shape 12"/>
+          <p:cNvPr id="111" name="Shape 12"/>
           <p:cNvSpPr/>
           <p:nvPr/>
         </p:nvSpPr>
@@ -7437,7 +7893,7 @@
       </p:sp>
       <p:sp>
         <p:nvSpPr>
-          <p:cNvPr id="104" name="Text 13"/>
+          <p:cNvPr id="112" name="Text 13"/>
           <p:cNvSpPr/>
           <p:nvPr/>
         </p:nvSpPr>
@@ -7497,7 +7953,7 @@
       </p:sp>
       <p:sp>
         <p:nvSpPr>
-          <p:cNvPr id="105" name="Text 14"/>
+          <p:cNvPr id="113" name="Text 14"/>
           <p:cNvSpPr/>
           <p:nvPr/>
         </p:nvSpPr>
@@ -7542,7 +7998,7 @@
                 <a:uFillTx/>
                 <a:latin typeface="Arial"/>
               </a:rPr>
-              <a:t>REST API CRUD: phim, lịch chiếu, combo, đơn vé</a:t>
+              <a:t>REST API CRUD: phim, lịch chiếu, combo, đơn vé, tin tức</a:t>
             </a:r>
             <a:endParaRPr lang="en-US" sz="900" b="0" u="none" strike="noStrike">
               <a:solidFill>
@@ -7557,7 +8013,7 @@
       </p:sp>
       <p:sp>
         <p:nvSpPr>
-          <p:cNvPr id="106" name="Shape 15"/>
+          <p:cNvPr id="114" name="Shape 15"/>
           <p:cNvSpPr/>
           <p:nvPr/>
         </p:nvSpPr>
@@ -7605,7 +8061,7 @@
       </p:sp>
       <p:sp>
         <p:nvSpPr>
-          <p:cNvPr id="107" name="Text 16"/>
+          <p:cNvPr id="115" name="Text 16"/>
           <p:cNvSpPr/>
           <p:nvPr/>
         </p:nvSpPr>
@@ -7665,7 +8121,7 @@
       </p:sp>
       <p:sp>
         <p:nvSpPr>
-          <p:cNvPr id="108" name="Text 17"/>
+          <p:cNvPr id="116" name="Text 17"/>
           <p:cNvSpPr/>
           <p:nvPr/>
         </p:nvSpPr>
@@ -7725,7 +8181,7 @@
       </p:sp>
       <p:sp>
         <p:nvSpPr>
-          <p:cNvPr id="109" name="Text 20"/>
+          <p:cNvPr id="117" name="Text 20"/>
           <p:cNvSpPr/>
           <p:nvPr/>
         </p:nvSpPr>
@@ -7770,7 +8226,7 @@
                 <a:uFillTx/>
                 <a:latin typeface="Arial"/>
               </a:rPr>
-              <a:t>MODULES</a:t>
+              <a:t>MODULES &amp; PAGES</a:t>
             </a:r>
             <a:endParaRPr lang="en-US" sz="900" b="0" u="none" strike="noStrike">
               <a:solidFill>
@@ -7785,7 +8241,7 @@
       </p:sp>
       <p:sp>
         <p:nvSpPr>
-          <p:cNvPr id="110" name="Text 21"/>
+          <p:cNvPr id="118" name="Text 21"/>
           <p:cNvSpPr/>
           <p:nvPr/>
         </p:nvSpPr>
@@ -7830,7 +8286,7 @@
                 <a:uFillTx/>
                 <a:latin typeface="Arial"/>
               </a:rPr>
-              <a:t>Home · movies · movie detail · schedule · booking · checkout · profile · admin</a:t>
+              <a:t>Home · movies · movie-detail · schedule · booking · checkout · profile · pricing · news · admin · 404 · error (12 trang)</a:t>
             </a:r>
             <a:endParaRPr lang="en-US" sz="1200" b="0" u="none" strike="noStrike">
               <a:solidFill>
@@ -7845,7 +8301,7 @@
       </p:sp>
       <p:sp>
         <p:nvSpPr>
-          <p:cNvPr id="111" name="Shape 22"/>
+          <p:cNvPr id="119" name="Shape 22"/>
           <p:cNvSpPr/>
           <p:nvPr/>
         </p:nvSpPr>
@@ -7888,7 +8344,7 @@
       </p:sp>
       <p:sp>
         <p:nvSpPr>
-          <p:cNvPr id="112" name="Text 23"/>
+          <p:cNvPr id="120" name="Text 23"/>
           <p:cNvSpPr/>
           <p:nvPr/>
         </p:nvSpPr>
@@ -7933,7 +8389,7 @@
                 <a:uFillTx/>
                 <a:latin typeface="Arial"/>
               </a:rPr>
-              <a:t>DATA</a:t>
+              <a:t>DATABASE (DB.JSON TẬP TRUNG)</a:t>
             </a:r>
             <a:endParaRPr lang="en-US" sz="900" b="0" u="none" strike="noStrike">
               <a:solidFill>
@@ -7948,7 +8404,7 @@
       </p:sp>
       <p:sp>
         <p:nvSpPr>
-          <p:cNvPr id="113" name="Text 24"/>
+          <p:cNvPr id="121" name="Text 24"/>
           <p:cNvSpPr/>
           <p:nvPr/>
         </p:nvSpPr>
@@ -7993,7 +8449,7 @@
                 <a:uFillTx/>
                 <a:latin typeface="Arial"/>
               </a:rPr>
-              <a:t>db.json tập trung: movies · cinemas · showtimes · concessions · bookings</a:t>
+              <a:t>movies (11 phim) · cinemas (10 rạp) · showtimes · concessions · bookings · promotions · pricing · users</a:t>
             </a:r>
             <a:endParaRPr lang="en-US" sz="1200" b="0" u="none" strike="noStrike">
               <a:solidFill>
@@ -8008,7 +8464,7 @@
       </p:sp>
       <p:sp>
         <p:nvSpPr>
-          <p:cNvPr id="114" name="Shape 25"/>
+          <p:cNvPr id="122" name="Shape 25"/>
           <p:cNvSpPr/>
           <p:nvPr/>
         </p:nvSpPr>
@@ -8051,7 +8507,7 @@
       </p:sp>
       <p:sp>
         <p:nvSpPr>
-          <p:cNvPr id="115" name="Text 26"/>
+          <p:cNvPr id="123" name="Text 26"/>
           <p:cNvSpPr/>
           <p:nvPr/>
         </p:nvSpPr>
@@ -8096,7 +8552,7 @@
                 <a:uFillTx/>
                 <a:latin typeface="Arial"/>
               </a:rPr>
-              <a:t>LOGIN / ADMIN</a:t>
+              <a:t>LOGIN / ADMIN &amp; DEPLOYMENT</a:t>
             </a:r>
             <a:endParaRPr lang="en-US" sz="900" b="0" u="none" strike="noStrike">
               <a:solidFill>
@@ -8111,7 +8567,7 @@
       </p:sp>
       <p:sp>
         <p:nvSpPr>
-          <p:cNvPr id="116" name="Text 27"/>
+          <p:cNvPr id="124" name="Text 27"/>
           <p:cNvSpPr/>
           <p:nvPr/>
         </p:nvSpPr>
@@ -8156,7 +8612,7 @@
                 <a:uFillTx/>
                 <a:latin typeface="Arial"/>
               </a:rPr>
-              <a:t>Xác thực JWT token, phiên làm việc an toàn. Admin Full CRUD đồng bộ REST API và thống kê doanh thu.</a:t>
+              <a:t>Admin Security Gateway, Dashboard KPI doanh thu, Full CRUD quản lý &amp; soát vé QR. Hỗ trợ Bun và Vercel Serverless.</a:t>
             </a:r>
             <a:endParaRPr lang="en-US" sz="1200" b="0" u="none" strike="noStrike">
               <a:solidFill>
@@ -8171,7 +8627,7 @@
       </p:sp>
       <p:sp>
         <p:nvSpPr>
-          <p:cNvPr id="117" name="Shape 28"/>
+          <p:cNvPr id="125" name="Shape 28"/>
           <p:cNvSpPr/>
           <p:nvPr/>
         </p:nvSpPr>
@@ -8251,7 +8707,7 @@
       </p:grpSpPr>
       <p:sp>
         <p:nvSpPr>
-          <p:cNvPr id="118" name="Shape 0"/>
+          <p:cNvPr id="126" name="Shape 0"/>
           <p:cNvSpPr/>
           <p:nvPr/>
         </p:nvSpPr>
@@ -8299,7 +8755,7 @@
       </p:sp>
       <p:sp>
         <p:nvSpPr>
-          <p:cNvPr id="119" name="Text 1"/>
+          <p:cNvPr id="127" name="Text 1"/>
           <p:cNvSpPr/>
           <p:nvPr/>
         </p:nvSpPr>
@@ -8359,7 +8815,7 @@
       </p:sp>
       <p:sp>
         <p:nvSpPr>
-          <p:cNvPr id="120" name="Text 2"/>
+          <p:cNvPr id="128" name="Text 2"/>
           <p:cNvSpPr/>
           <p:nvPr/>
         </p:nvSpPr>
@@ -8419,7 +8875,7 @@
       </p:sp>
       <p:sp>
         <p:nvSpPr>
-          <p:cNvPr id="121" name="Text 3"/>
+          <p:cNvPr id="129" name="Text 3"/>
           <p:cNvSpPr/>
           <p:nvPr/>
         </p:nvSpPr>
@@ -8479,7 +8935,7 @@
       </p:sp>
       <p:sp>
         <p:nvSpPr>
-          <p:cNvPr id="122" name="Text 4"/>
+          <p:cNvPr id="130" name="Text 4"/>
           <p:cNvSpPr/>
           <p:nvPr/>
         </p:nvSpPr>
@@ -8539,7 +8995,7 @@
       </p:sp>
       <p:sp>
         <p:nvSpPr>
-          <p:cNvPr id="123" name="Text 5"/>
+          <p:cNvPr id="131" name="Text 5"/>
           <p:cNvSpPr/>
           <p:nvPr/>
         </p:nvSpPr>
@@ -8584,7 +9040,7 @@
                 <a:uFillTx/>
                 <a:latin typeface="Arial"/>
               </a:rPr>
-              <a:t>Chọn phim → chọn ghế → nhận vé QR.</a:t>
+              <a:t>Khách đặt vé → Nhận vé QR → Admin kiểm tra &amp; soát vé.</a:t>
             </a:r>
             <a:endParaRPr lang="en-US" sz="3100" b="0" u="none" strike="noStrike">
               <a:solidFill>
@@ -8599,7 +9055,7 @@
       </p:sp>
       <p:sp>
         <p:nvSpPr>
-          <p:cNvPr id="124" name="Shape 6"/>
+          <p:cNvPr id="132" name="Shape 6"/>
           <p:cNvSpPr/>
           <p:nvPr/>
         </p:nvSpPr>
@@ -8647,7 +9103,7 @@
       </p:sp>
       <p:sp>
         <p:nvSpPr>
-          <p:cNvPr id="125" name="Text 7"/>
+          <p:cNvPr id="133" name="Text 7"/>
           <p:cNvSpPr/>
           <p:nvPr/>
         </p:nvSpPr>
@@ -8707,7 +9163,7 @@
       </p:sp>
       <p:sp>
         <p:nvSpPr>
-          <p:cNvPr id="126" name="Text 8"/>
+          <p:cNvPr id="134" name="Text 8"/>
           <p:cNvSpPr/>
           <p:nvPr/>
         </p:nvSpPr>
@@ -8752,7 +9208,7 @@
                 <a:uFillTx/>
                 <a:latin typeface="Arial"/>
               </a:rPr>
-              <a:t>Chọn phim đang chiếu và suất chiếu tại rạp</a:t>
+              <a:t>Duyệt phim đang chiếu, xem trailer và chọn suất chiếu tại rạp</a:t>
             </a:r>
             <a:endParaRPr lang="en-US" sz="1300" b="0" u="none" strike="noStrike">
               <a:solidFill>
@@ -8767,7 +9223,7 @@
       </p:sp>
       <p:sp>
         <p:nvSpPr>
-          <p:cNvPr id="127" name="Shape 9"/>
+          <p:cNvPr id="135" name="Shape 9"/>
           <p:cNvSpPr/>
           <p:nvPr/>
         </p:nvSpPr>
@@ -8815,7 +9271,7 @@
       </p:sp>
       <p:sp>
         <p:nvSpPr>
-          <p:cNvPr id="128" name="Text 10"/>
+          <p:cNvPr id="136" name="Text 10"/>
           <p:cNvSpPr/>
           <p:nvPr/>
         </p:nvSpPr>
@@ -8875,7 +9331,7 @@
       </p:sp>
       <p:sp>
         <p:nvSpPr>
-          <p:cNvPr id="129" name="Text 11"/>
+          <p:cNvPr id="137" name="Text 11"/>
           <p:cNvSpPr/>
           <p:nvPr/>
         </p:nvSpPr>
@@ -8900,7 +9356,7 @@
         </p:style>
         <p:txBody>
           <a:bodyPr lIns="0" tIns="0" rIns="0" bIns="0" anchor="ctr">
-            <a:normAutofit/>
+            <a:normAutofit fontScale="92500" lnSpcReduction="9999"/>
           </a:bodyPr>
           <a:p>
             <a:pPr defTabSz="914400">
@@ -8920,7 +9376,7 @@
                 <a:uFillTx/>
                 <a:latin typeface="Arial"/>
               </a:rPr>
-              <a:t>Chọn ghế; đồng hồ giữ ghế bắt đầu đếm ngược</a:t>
+              <a:t>Chọn ghế 164 chỗ (Standard/VIP/Sweetbox); kích hoạt giữ ghế 5 phút</a:t>
             </a:r>
             <a:endParaRPr lang="en-US" sz="1300" b="0" u="none" strike="noStrike">
               <a:solidFill>
@@ -8935,7 +9391,7 @@
       </p:sp>
       <p:sp>
         <p:nvSpPr>
-          <p:cNvPr id="130" name="Shape 12"/>
+          <p:cNvPr id="138" name="Shape 12"/>
           <p:cNvSpPr/>
           <p:nvPr/>
         </p:nvSpPr>
@@ -8983,7 +9439,7 @@
       </p:sp>
       <p:sp>
         <p:nvSpPr>
-          <p:cNvPr id="131" name="Text 13"/>
+          <p:cNvPr id="139" name="Text 13"/>
           <p:cNvSpPr/>
           <p:nvPr/>
         </p:nvSpPr>
@@ -9043,7 +9499,7 @@
       </p:sp>
       <p:sp>
         <p:nvSpPr>
-          <p:cNvPr id="132" name="Text 14"/>
+          <p:cNvPr id="140" name="Text 14"/>
           <p:cNvSpPr/>
           <p:nvPr/>
         </p:nvSpPr>
@@ -9068,7 +9524,7 @@
         </p:style>
         <p:txBody>
           <a:bodyPr lIns="0" tIns="0" rIns="0" bIns="0" anchor="ctr">
-            <a:normAutofit/>
+            <a:normAutofit fontScale="92500" lnSpcReduction="9999"/>
           </a:bodyPr>
           <a:p>
             <a:pPr defTabSz="914400">
@@ -9088,7 +9544,7 @@
                 <a:uFillTx/>
                 <a:latin typeface="Arial"/>
               </a:rPr>
-              <a:t>Thêm combo, nhập voucher; kiểm tra tổng tiền</a:t>
+              <a:t>Chọn combo bắp nước, nhập mã voucher giảm giá; tự tính lại tổng tiền</a:t>
             </a:r>
             <a:endParaRPr lang="en-US" sz="1300" b="0" u="none" strike="noStrike">
               <a:solidFill>
@@ -9103,7 +9559,7 @@
       </p:sp>
       <p:sp>
         <p:nvSpPr>
-          <p:cNvPr id="133" name="Shape 15"/>
+          <p:cNvPr id="141" name="Shape 15"/>
           <p:cNvSpPr/>
           <p:nvPr/>
         </p:nvSpPr>
@@ -9151,7 +9607,7 @@
       </p:sp>
       <p:sp>
         <p:nvSpPr>
-          <p:cNvPr id="134" name="Text 16"/>
+          <p:cNvPr id="142" name="Text 16"/>
           <p:cNvSpPr/>
           <p:nvPr/>
         </p:nvSpPr>
@@ -9211,7 +9667,7 @@
       </p:sp>
       <p:sp>
         <p:nvSpPr>
-          <p:cNvPr id="135" name="Text 17"/>
+          <p:cNvPr id="143" name="Text 17"/>
           <p:cNvSpPr/>
           <p:nvPr/>
         </p:nvSpPr>
@@ -9256,7 +9712,7 @@
                 <a:uFillTx/>
                 <a:latin typeface="Arial"/>
               </a:rPr>
-              <a:t>Xác nhận thanh toán mô phỏng, mở vé điện tử QR</a:t>
+              <a:t>Xác nhận thanh toán mô phỏng, xuất vé điện tử QR Code check-in</a:t>
             </a:r>
             <a:endParaRPr lang="en-US" sz="1300" b="0" u="none" strike="noStrike">
               <a:solidFill>
@@ -9271,7 +9727,7 @@
       </p:sp>
       <p:sp>
         <p:nvSpPr>
-          <p:cNvPr id="136" name="Text 18"/>
+          <p:cNvPr id="144" name="Text 18"/>
           <p:cNvSpPr/>
           <p:nvPr/>
         </p:nvSpPr>
@@ -9331,7 +9787,7 @@
       </p:sp>
       <p:sp>
         <p:nvSpPr>
-          <p:cNvPr id="137" name="Text 19"/>
+          <p:cNvPr id="145" name="Text 19"/>
           <p:cNvSpPr/>
           <p:nvPr/>
         </p:nvSpPr>
@@ -9391,7 +9847,7 @@
       </p:sp>
       <p:sp>
         <p:nvSpPr>
-          <p:cNvPr id="138" name="Text 20"/>
+          <p:cNvPr id="146" name="Text 20"/>
           <p:cNvSpPr/>
           <p:nvPr/>
         </p:nvSpPr>
@@ -9436,7 +9892,7 @@
                 <a:uFillTx/>
                 <a:latin typeface="Arial"/>
               </a:rPr>
-              <a:t>Điểm nhấn nếu còn thời gian: lọc phim hoặc đổi số lượng ghế/combo để thấy tổng tiền cập nhật. Kết thúc ở vé QR để chứng minh luồng MVP chạy xuyên suốt.</a:t>
+              <a:t>Mở rộng: Tra cứu bảng giá vé (/pricing), xem tin tức ưu đãi (/news), đăng nhập Cổng Admin (/admin) bằng tài khoản admin để xem KPI Doanh thu và soát vé QR vừa tạo.</a:t>
             </a:r>
             <a:endParaRPr lang="en-US" sz="1200" b="0" u="none" strike="noStrike">
               <a:solidFill>
@@ -9488,7 +9944,7 @@
       </p:grpSpPr>
       <p:sp>
         <p:nvSpPr>
-          <p:cNvPr id="139" name="Shape 0"/>
+          <p:cNvPr id="147" name="Shape 0"/>
           <p:cNvSpPr/>
           <p:nvPr/>
         </p:nvSpPr>
@@ -9536,7 +9992,7 @@
       </p:sp>
       <p:sp>
         <p:nvSpPr>
-          <p:cNvPr id="140" name="Text 1"/>
+          <p:cNvPr id="148" name="Text 1"/>
           <p:cNvSpPr/>
           <p:nvPr/>
         </p:nvSpPr>
@@ -9596,7 +10052,7 @@
       </p:sp>
       <p:sp>
         <p:nvSpPr>
-          <p:cNvPr id="141" name="Text 2"/>
+          <p:cNvPr id="149" name="Text 2"/>
           <p:cNvSpPr/>
           <p:nvPr/>
         </p:nvSpPr>
@@ -9656,7 +10112,7 @@
       </p:sp>
       <p:sp>
         <p:nvSpPr>
-          <p:cNvPr id="142" name="Text 3"/>
+          <p:cNvPr id="150" name="Text 3"/>
           <p:cNvSpPr/>
           <p:nvPr/>
         </p:nvSpPr>
@@ -9716,7 +10172,7 @@
       </p:sp>
       <p:sp>
         <p:nvSpPr>
-          <p:cNvPr id="143" name="Text 4"/>
+          <p:cNvPr id="151" name="Text 4"/>
           <p:cNvSpPr/>
           <p:nvPr/>
         </p:nvSpPr>
@@ -9776,7 +10232,7 @@
       </p:sp>
       <p:sp>
         <p:nvSpPr>
-          <p:cNvPr id="144" name="Text 5"/>
+          <p:cNvPr id="152" name="Text 5"/>
           <p:cNvSpPr/>
           <p:nvPr/>
         </p:nvSpPr>
@@ -9821,7 +10277,7 @@
                 <a:uFillTx/>
                 <a:latin typeface="Arial"/>
               </a:rPr>
-              <a:t>Phân công theo module, cùng hoàn thiện MVP.</a:t>
+              <a:t>Phối hợp hiệu quả theo module, hoàn thành 100% backlog.</a:t>
             </a:r>
             <a:endParaRPr lang="en-US" sz="3100" b="0" u="none" strike="noStrike">
               <a:solidFill>
@@ -9836,7 +10292,7 @@
       </p:sp>
       <p:sp>
         <p:nvSpPr>
-          <p:cNvPr id="145" name="Shape 6"/>
+          <p:cNvPr id="153" name="Shape 6"/>
           <p:cNvSpPr/>
           <p:nvPr/>
         </p:nvSpPr>
@@ -9884,7 +10340,7 @@
       </p:sp>
       <p:sp>
         <p:nvSpPr>
-          <p:cNvPr id="146" name="Text 7"/>
+          <p:cNvPr id="154" name="Text 7"/>
           <p:cNvSpPr/>
           <p:nvPr/>
         </p:nvSpPr>
@@ -9944,7 +10400,7 @@
       </p:sp>
       <p:sp>
         <p:nvSpPr>
-          <p:cNvPr id="147" name="Text 8"/>
+          <p:cNvPr id="155" name="Text 8"/>
           <p:cNvSpPr/>
           <p:nvPr/>
         </p:nvSpPr>
@@ -10004,7 +10460,7 @@
       </p:sp>
       <p:sp>
         <p:nvSpPr>
-          <p:cNvPr id="148" name="Text 9"/>
+          <p:cNvPr id="156" name="Text 9"/>
           <p:cNvSpPr/>
           <p:nvPr/>
         </p:nvSpPr>
@@ -10049,7 +10505,7 @@
                 <a:uFillTx/>
                 <a:latin typeface="Arial"/>
               </a:rPr>
-              <a:t>Nguyễn Văn Trọng — UI chính, phim/lịch/ghế, JSON &amp; localStorage</a:t>
+              <a:t>Nguyễn Văn Trọng — Lead Architecture, UI chính, phim/lịch/ghế, JSON-Server API, Bun runtime, Vercel Serverless</a:t>
             </a:r>
             <a:endParaRPr lang="en-US" sz="1100" b="0" u="none" strike="noStrike">
               <a:solidFill>
@@ -10064,7 +10520,7 @@
       </p:sp>
       <p:sp>
         <p:nvSpPr>
-          <p:cNvPr id="149" name="Text 10"/>
+          <p:cNvPr id="157" name="Text 10"/>
           <p:cNvSpPr/>
           <p:nvPr/>
         </p:nvSpPr>
@@ -10124,7 +10580,7 @@
       </p:sp>
       <p:sp>
         <p:nvSpPr>
-          <p:cNvPr id="150" name="Text 11"/>
+          <p:cNvPr id="158" name="Text 11"/>
           <p:cNvSpPr/>
           <p:nvPr/>
         </p:nvSpPr>
@@ -10169,7 +10625,7 @@
                 <a:uFillTx/>
                 <a:latin typeface="Arial"/>
               </a:rPr>
-              <a:t>Vũ Tiến Lập — checkout, combo, hồ sơ, Admin, kiểm thử, GitHub Pages</a:t>
+              <a:t>Vũ Tiến Lập — Checkout, combo bắp nước, bảng giá vé (pricing), tin tức (news), Admin Portal, test suite</a:t>
             </a:r>
             <a:endParaRPr lang="en-US" sz="1100" b="0" u="none" strike="noStrike">
               <a:solidFill>
@@ -10184,7 +10640,7 @@
       </p:sp>
       <p:sp>
         <p:nvSpPr>
-          <p:cNvPr id="151" name="Text 12"/>
+          <p:cNvPr id="159" name="Text 12"/>
           <p:cNvSpPr/>
           <p:nvPr/>
         </p:nvSpPr>
@@ -10244,7 +10700,7 @@
       </p:sp>
       <p:sp>
         <p:nvSpPr>
-          <p:cNvPr id="152" name="Text 13"/>
+          <p:cNvPr id="160" name="Text 13"/>
           <p:cNvSpPr/>
           <p:nvPr/>
         </p:nvSpPr>
@@ -10289,7 +10745,7 @@
                 <a:uFillTx/>
                 <a:latin typeface="Arial"/>
               </a:rPr>
-              <a:t>Phạm Anh Duy — voucher, booking, thanh toán mô phỏng, vé QR, auth</a:t>
+              <a:t>Phạm Anh Duy — Voucher giảm giá, booking flow, sơ đồ 164 ghế, thanh toán mô phỏng, vé QR, auth (JWT)</a:t>
             </a:r>
             <a:endParaRPr lang="en-US" sz="1100" b="0" u="none" strike="noStrike">
               <a:solidFill>
@@ -10304,7 +10760,7 @@
       </p:sp>
       <p:sp>
         <p:nvSpPr>
-          <p:cNvPr id="153" name="Text 14"/>
+          <p:cNvPr id="161" name="Text 14"/>
           <p:cNvSpPr/>
           <p:nvPr/>
         </p:nvSpPr>
@@ -10364,9 +10820,7 @@
       </p:sp>
       <p:sp>
         <p:nvSpPr>
-          <p:cNvPr id="154" name="Text 15">
-            <a:hlinkClick r:id="rId1"/>
-          </p:cNvPr>
+          <p:cNvPr id="162" name="Text 15"/>
           <p:cNvSpPr/>
           <p:nvPr/>
         </p:nvSpPr>
@@ -10410,7 +10864,7 @@
                 <a:effectLst/>
                 <a:uFillTx/>
                 <a:latin typeface="Arial"/>
-                <a:hlinkClick r:id="rId2"/>
+                <a:hlinkClick r:id="rId1"/>
               </a:rPr>
               <a:t>github.com/AsakiYuki/web2064-fa26</a:t>
             </a:r>
@@ -10427,7 +10881,7 @@
       </p:sp>
       <p:sp>
         <p:nvSpPr>
-          <p:cNvPr id="155" name="Shape 16"/>
+          <p:cNvPr id="163" name="Shape 16"/>
           <p:cNvSpPr/>
           <p:nvPr/>
         </p:nvSpPr>
@@ -10475,7 +10929,7 @@
       </p:sp>
       <p:sp>
         <p:nvSpPr>
-          <p:cNvPr id="156" name="Text 17"/>
+          <p:cNvPr id="164" name="Text 17"/>
           <p:cNvSpPr/>
           <p:nvPr/>
         </p:nvSpPr>
@@ -10535,7 +10989,7 @@
       </p:sp>
       <p:sp>
         <p:nvSpPr>
-          <p:cNvPr id="157" name="Text 18"/>
+          <p:cNvPr id="165" name="Text 18"/>
           <p:cNvSpPr/>
           <p:nvPr/>
         </p:nvSpPr>
@@ -10595,7 +11049,7 @@
       </p:sp>
       <p:sp>
         <p:nvSpPr>
-          <p:cNvPr id="158" name="Text 19"/>
+          <p:cNvPr id="166" name="Text 19"/>
           <p:cNvSpPr/>
           <p:nvPr/>
         </p:nvSpPr>
@@ -10640,7 +11094,7 @@
                 <a:uFillTx/>
                 <a:latin typeface="Arial"/>
               </a:rPr>
-              <a:t>Khó khăn: Đồng bộ trạng thái real-time giữa REST API json-server và giao diện phía client.</a:t>
+              <a:t>Khó khăn: Đồng bộ trạng thái real-time giữa REST API json-server, cache client và môi trường Serverless trên Vercel.</a:t>
             </a:r>
             <a:endParaRPr lang="en-US" sz="1100" b="0" u="none" strike="noStrike">
               <a:solidFill>
@@ -10655,7 +11109,7 @@
       </p:sp>
       <p:sp>
         <p:nvSpPr>
-          <p:cNvPr id="159" name="Text 20"/>
+          <p:cNvPr id="167" name="Text 20"/>
           <p:cNvSpPr/>
           <p:nvPr/>
         </p:nvSpPr>
@@ -10715,7 +11169,7 @@
       </p:sp>
       <p:sp>
         <p:nvSpPr>
-          <p:cNvPr id="160" name="Text 21"/>
+          <p:cNvPr id="168" name="Text 21"/>
           <p:cNvSpPr/>
           <p:nvPr/>
         </p:nvSpPr>
@@ -10760,7 +11214,7 @@
                 <a:uFillTx/>
                 <a:latin typeface="Arial"/>
               </a:rPr>
-              <a:t>Cách xử lý: Xây dựng module api.js kết hợp storage.js làm cầu nối cache và xác thực Bearer token.</a:t>
+              <a:t>Cách xử lý: Xây dựng module api.js kết hợp storage.js, cơ chế clone database tạm (/tmp) cho Vercel, cấp JWT Bearer Token.</a:t>
             </a:r>
             <a:endParaRPr lang="en-US" sz="1100" b="0" u="none" strike="noStrike">
               <a:solidFill>
@@ -10775,7 +11229,7 @@
       </p:sp>
       <p:sp>
         <p:nvSpPr>
-          <p:cNvPr id="161" name="Text 22"/>
+          <p:cNvPr id="169" name="Text 22"/>
           <p:cNvSpPr/>
           <p:nvPr/>
         </p:nvSpPr>
@@ -10835,7 +11289,7 @@
       </p:sp>
       <p:sp>
         <p:nvSpPr>
-          <p:cNvPr id="162" name="Text 23"/>
+          <p:cNvPr id="170" name="Text 23"/>
           <p:cNvSpPr/>
           <p:nvPr/>
         </p:nvSpPr>
@@ -10880,7 +11334,7 @@
                 <a:uFillTx/>
                 <a:latin typeface="Arial"/>
               </a:rPr>
-              <a:t>Kết quả: Hoàn thành 100% backlog, tích hợp json-server + auth, vượt qua 26/26 use case tests.</a:t>
+              <a:t>Kết quả: Hoàn thành 100% backlog (12 trang MPA), vượt qua 28/28 use case tests, hỗ trợ chạy mượt cả Local và Cloud.</a:t>
             </a:r>
             <a:endParaRPr lang="en-US" sz="1100" b="0" u="none" strike="noStrike">
               <a:solidFill>

</xml_diff>

<commit_message>
docs(presentation): embed UI preview mockups and streamline text content
</commit_message>
<xml_diff>
--- a/Beta-Cinemas-Presentation.pptx
+++ b/Beta-Cinemas-Presentation.pptx
@@ -369,7 +369,7 @@
             <a:pPr indent="0" algn="r">
               <a:buNone/>
             </a:pPr>
-            <a:fld id="{E3FF95C1-8486-4943-9249-9B69D3570483}" type="slidenum">
+            <a:fld id="{A5B6F242-FF54-4324-8EFE-E4A3A9C3355E}" type="slidenum">
               <a:rPr lang="en-US" sz="1400" b="0" u="none" strike="noStrike">
                 <a:solidFill>
                   <a:srgbClr val="000000"/>
@@ -416,7 +416,7 @@
       </p:grpSpPr>
       <p:sp>
         <p:nvSpPr>
-          <p:cNvPr id="150" name="PlaceHolder 1"/>
+          <p:cNvPr id="155" name="PlaceHolder 1"/>
           <p:cNvSpPr>
             <a:spLocks noGrp="1"/>
           </p:cNvSpPr>
@@ -439,7 +439,7 @@
       </p:sp>
       <p:sp>
         <p:nvSpPr>
-          <p:cNvPr id="151" name="PlaceHolder 2"/>
+          <p:cNvPr id="156" name="PlaceHolder 2"/>
           <p:cNvSpPr>
             <a:spLocks noGrp="1"/>
           </p:cNvSpPr>
@@ -481,7 +481,7 @@
       </p:sp>
       <p:sp>
         <p:nvSpPr>
-          <p:cNvPr id="152" name="PlaceHolder 3"/>
+          <p:cNvPr id="157" name="PlaceHolder 3"/>
           <p:cNvSpPr>
             <a:spLocks noGrp="1"/>
           </p:cNvSpPr>
@@ -530,7 +530,7 @@
               </a:lnSpc>
               <a:buNone/>
             </a:pPr>
-            <a:fld id="{2843F715-51F7-4C1B-B1FF-A1A9943715F0}" type="slidenum">
+            <a:fld id="{764BB3F0-DFB8-4EC8-A502-9BA7B84BAAE4}" type="slidenum">
               <a:rPr lang="en-US" sz="1200" b="0" u="none" strike="noStrike">
                 <a:solidFill>
                   <a:schemeClr val="dk1"/>
@@ -577,7 +577,7 @@
       </p:grpSpPr>
       <p:sp>
         <p:nvSpPr>
-          <p:cNvPr id="153" name="PlaceHolder 1"/>
+          <p:cNvPr id="158" name="PlaceHolder 1"/>
           <p:cNvSpPr>
             <a:spLocks noGrp="1"/>
           </p:cNvSpPr>
@@ -600,7 +600,7 @@
       </p:sp>
       <p:sp>
         <p:nvSpPr>
-          <p:cNvPr id="154" name="PlaceHolder 2"/>
+          <p:cNvPr id="159" name="PlaceHolder 2"/>
           <p:cNvSpPr>
             <a:spLocks noGrp="1"/>
           </p:cNvSpPr>
@@ -642,7 +642,7 @@
       </p:sp>
       <p:sp>
         <p:nvSpPr>
-          <p:cNvPr id="155" name="PlaceHolder 3"/>
+          <p:cNvPr id="160" name="PlaceHolder 3"/>
           <p:cNvSpPr>
             <a:spLocks noGrp="1"/>
           </p:cNvSpPr>
@@ -691,7 +691,7 @@
               </a:lnSpc>
               <a:buNone/>
             </a:pPr>
-            <a:fld id="{485FC590-F98B-4B87-BA41-F5429F91720B}" type="slidenum">
+            <a:fld id="{96D8554F-290E-459C-8ABF-4C4543C325B6}" type="slidenum">
               <a:rPr lang="en-US" sz="1200" b="0" u="none" strike="noStrike">
                 <a:solidFill>
                   <a:schemeClr val="dk1"/>
@@ -738,7 +738,7 @@
       </p:grpSpPr>
       <p:sp>
         <p:nvSpPr>
-          <p:cNvPr id="156" name="PlaceHolder 1"/>
+          <p:cNvPr id="161" name="PlaceHolder 1"/>
           <p:cNvSpPr>
             <a:spLocks noGrp="1"/>
           </p:cNvSpPr>
@@ -761,7 +761,7 @@
       </p:sp>
       <p:sp>
         <p:nvSpPr>
-          <p:cNvPr id="157" name="PlaceHolder 2"/>
+          <p:cNvPr id="162" name="PlaceHolder 2"/>
           <p:cNvSpPr>
             <a:spLocks noGrp="1"/>
           </p:cNvSpPr>
@@ -803,7 +803,7 @@
       </p:sp>
       <p:sp>
         <p:nvSpPr>
-          <p:cNvPr id="158" name="PlaceHolder 3"/>
+          <p:cNvPr id="163" name="PlaceHolder 3"/>
           <p:cNvSpPr>
             <a:spLocks noGrp="1"/>
           </p:cNvSpPr>
@@ -852,7 +852,7 @@
               </a:lnSpc>
               <a:buNone/>
             </a:pPr>
-            <a:fld id="{A0F6A12F-F561-457E-991F-B88194512A29}" type="slidenum">
+            <a:fld id="{AF9AA06D-8C98-4471-BFF9-EBF975B23CC3}" type="slidenum">
               <a:rPr lang="en-US" sz="1200" b="0" u="none" strike="noStrike">
                 <a:solidFill>
                   <a:schemeClr val="dk1"/>
@@ -899,7 +899,7 @@
       </p:grpSpPr>
       <p:sp>
         <p:nvSpPr>
-          <p:cNvPr id="159" name="PlaceHolder 1"/>
+          <p:cNvPr id="164" name="PlaceHolder 1"/>
           <p:cNvSpPr>
             <a:spLocks noGrp="1"/>
           </p:cNvSpPr>
@@ -922,7 +922,7 @@
       </p:sp>
       <p:sp>
         <p:nvSpPr>
-          <p:cNvPr id="160" name="PlaceHolder 2"/>
+          <p:cNvPr id="165" name="PlaceHolder 2"/>
           <p:cNvSpPr>
             <a:spLocks noGrp="1"/>
           </p:cNvSpPr>
@@ -964,7 +964,7 @@
       </p:sp>
       <p:sp>
         <p:nvSpPr>
-          <p:cNvPr id="161" name="PlaceHolder 3"/>
+          <p:cNvPr id="166" name="PlaceHolder 3"/>
           <p:cNvSpPr>
             <a:spLocks noGrp="1"/>
           </p:cNvSpPr>
@@ -1013,7 +1013,7 @@
               </a:lnSpc>
               <a:buNone/>
             </a:pPr>
-            <a:fld id="{DB18CD3C-7993-4754-937C-96379454B463}" type="slidenum">
+            <a:fld id="{227BA09B-14E5-43F6-AA97-548E6E67522B}" type="slidenum">
               <a:rPr lang="en-US" sz="1200" b="0" u="none" strike="noStrike">
                 <a:solidFill>
                   <a:schemeClr val="dk1"/>
@@ -1060,7 +1060,7 @@
       </p:grpSpPr>
       <p:sp>
         <p:nvSpPr>
-          <p:cNvPr id="162" name="PlaceHolder 1"/>
+          <p:cNvPr id="167" name="PlaceHolder 1"/>
           <p:cNvSpPr>
             <a:spLocks noGrp="1"/>
           </p:cNvSpPr>
@@ -1083,7 +1083,7 @@
       </p:sp>
       <p:sp>
         <p:nvSpPr>
-          <p:cNvPr id="163" name="PlaceHolder 2"/>
+          <p:cNvPr id="168" name="PlaceHolder 2"/>
           <p:cNvSpPr>
             <a:spLocks noGrp="1"/>
           </p:cNvSpPr>
@@ -1125,7 +1125,7 @@
       </p:sp>
       <p:sp>
         <p:nvSpPr>
-          <p:cNvPr id="164" name="PlaceHolder 3"/>
+          <p:cNvPr id="169" name="PlaceHolder 3"/>
           <p:cNvSpPr>
             <a:spLocks noGrp="1"/>
           </p:cNvSpPr>
@@ -1174,7 +1174,7 @@
               </a:lnSpc>
               <a:buNone/>
             </a:pPr>
-            <a:fld id="{09D51D67-1925-4C32-BCE6-82AE9666F8AA}" type="slidenum">
+            <a:fld id="{3A8FEFF1-EB9B-4557-8E40-466FC6DE3405}" type="slidenum">
               <a:rPr lang="en-US" sz="1200" b="0" u="none" strike="noStrike">
                 <a:solidFill>
                   <a:schemeClr val="dk1"/>
@@ -1221,7 +1221,7 @@
       </p:grpSpPr>
       <p:sp>
         <p:nvSpPr>
-          <p:cNvPr id="165" name="PlaceHolder 1"/>
+          <p:cNvPr id="170" name="PlaceHolder 1"/>
           <p:cNvSpPr>
             <a:spLocks noGrp="1"/>
           </p:cNvSpPr>
@@ -1244,7 +1244,7 @@
       </p:sp>
       <p:sp>
         <p:nvSpPr>
-          <p:cNvPr id="166" name="PlaceHolder 2"/>
+          <p:cNvPr id="171" name="PlaceHolder 2"/>
           <p:cNvSpPr>
             <a:spLocks noGrp="1"/>
           </p:cNvSpPr>
@@ -1286,7 +1286,7 @@
       </p:sp>
       <p:sp>
         <p:nvSpPr>
-          <p:cNvPr id="167" name="PlaceHolder 3"/>
+          <p:cNvPr id="172" name="PlaceHolder 3"/>
           <p:cNvSpPr>
             <a:spLocks noGrp="1"/>
           </p:cNvSpPr>
@@ -1335,7 +1335,7 @@
               </a:lnSpc>
               <a:buNone/>
             </a:pPr>
-            <a:fld id="{44664104-47E5-4326-BA65-48A6EADF76EE}" type="slidenum">
+            <a:fld id="{6A609C72-D2FA-4DD3-B6DA-C60AF192DD4F}" type="slidenum">
               <a:rPr lang="en-US" sz="1200" b="0" u="none" strike="noStrike">
                 <a:solidFill>
                   <a:schemeClr val="dk1"/>
@@ -2240,7 +2240,7 @@
         <p:spPr>
           <a:xfrm>
             <a:off x="685800" y="1234440"/>
-            <a:ext cx="6400440" cy="219240"/>
+            <a:ext cx="5400000" cy="219240"/>
           </a:xfrm>
           <a:prstGeom prst="rect">
             <a:avLst/>
@@ -2300,7 +2300,96 @@
         <p:spPr>
           <a:xfrm>
             <a:off x="640080" y="1645920"/>
-            <a:ext cx="8869320" cy="1462680"/>
+            <a:ext cx="5400000" cy="1008000"/>
+          </a:xfrm>
+          <a:prstGeom prst="rect">
+            <a:avLst/>
+          </a:prstGeom>
+          <a:noFill/>
+          <a:ln w="0">
+            <a:noFill/>
+          </a:ln>
+        </p:spPr>
+        <p:style>
+          <a:lnRef idx="0"/>
+          <a:fillRef idx="0"/>
+          <a:effectRef idx="0"/>
+          <a:fontRef idx="minor"/>
+        </p:style>
+        <p:txBody>
+          <a:bodyPr lIns="0" tIns="0" rIns="0" bIns="0" anchor="ctr">
+            <a:normAutofit fontScale="85000" lnSpcReduction="9999"/>
+          </a:bodyPr>
+          <a:p>
+            <a:pPr defTabSz="914400">
+              <a:lnSpc>
+                <a:spcPct val="100000"/>
+              </a:lnSpc>
+              <a:tabLst>
+                <a:tab pos="0" algn="l"/>
+              </a:tabLst>
+            </a:pPr>
+            <a:r>
+              <a:rPr lang="en-US" sz="4200" b="1" u="none" spc="-99" strike="noStrike">
+                <a:solidFill>
+                  <a:srgbClr val="171923"/>
+                </a:solidFill>
+                <a:effectLst/>
+                <a:uFillTx/>
+                <a:latin typeface="Arial"/>
+              </a:rPr>
+              <a:t>Beta Cinemas</a:t>
+            </a:r>
+            <a:endParaRPr lang="en-US" sz="4200" b="0" u="none" strike="noStrike">
+              <a:solidFill>
+                <a:srgbClr val="000000"/>
+              </a:solidFill>
+              <a:effectLst/>
+              <a:uFillTx/>
+              <a:latin typeface="Arial"/>
+            </a:endParaRPr>
+          </a:p>
+          <a:p>
+            <a:pPr defTabSz="914400">
+              <a:lnSpc>
+                <a:spcPct val="100000"/>
+              </a:lnSpc>
+              <a:tabLst>
+                <a:tab pos="0" algn="l"/>
+              </a:tabLst>
+            </a:pPr>
+            <a:r>
+              <a:rPr lang="en-US" sz="4200" b="1" u="none" spc="-99" strike="noStrike">
+                <a:solidFill>
+                  <a:srgbClr val="171923"/>
+                </a:solidFill>
+                <a:effectLst/>
+                <a:uFillTx/>
+                <a:latin typeface="Arial"/>
+              </a:rPr>
+              <a:t>Đặt vé gọn. Đi xem vui.</a:t>
+            </a:r>
+            <a:endParaRPr lang="en-US" sz="4200" b="0" u="none" strike="noStrike">
+              <a:solidFill>
+                <a:srgbClr val="000000"/>
+              </a:solidFill>
+              <a:effectLst/>
+              <a:uFillTx/>
+              <a:latin typeface="Arial"/>
+            </a:endParaRPr>
+          </a:p>
+        </p:txBody>
+      </p:sp>
+      <p:sp>
+        <p:nvSpPr>
+          <p:cNvPr id="18" name="Text 6"/>
+          <p:cNvSpPr/>
+          <p:nvPr/>
+        </p:nvSpPr>
+        <p:spPr>
+          <a:xfrm>
+            <a:off x="685800" y="2700000"/>
+            <a:ext cx="5400000" cy="792000"/>
           </a:xfrm>
           <a:prstGeom prst="rect">
             <a:avLst/>
@@ -2330,95 +2419,6 @@
               </a:tabLst>
             </a:pPr>
             <a:r>
-              <a:rPr lang="en-US" sz="4200" b="1" u="none" spc="-99" strike="noStrike">
-                <a:solidFill>
-                  <a:srgbClr val="171923"/>
-                </a:solidFill>
-                <a:effectLst/>
-                <a:uFillTx/>
-                <a:latin typeface="Arial"/>
-              </a:rPr>
-              <a:t>Beta Cinemas</a:t>
-            </a:r>
-            <a:endParaRPr lang="en-US" sz="4200" b="0" u="none" strike="noStrike">
-              <a:solidFill>
-                <a:srgbClr val="000000"/>
-              </a:solidFill>
-              <a:effectLst/>
-              <a:uFillTx/>
-              <a:latin typeface="Arial"/>
-            </a:endParaRPr>
-          </a:p>
-          <a:p>
-            <a:pPr defTabSz="914400">
-              <a:lnSpc>
-                <a:spcPct val="100000"/>
-              </a:lnSpc>
-              <a:tabLst>
-                <a:tab pos="0" algn="l"/>
-              </a:tabLst>
-            </a:pPr>
-            <a:r>
-              <a:rPr lang="en-US" sz="4200" b="1" u="none" spc="-99" strike="noStrike">
-                <a:solidFill>
-                  <a:srgbClr val="171923"/>
-                </a:solidFill>
-                <a:effectLst/>
-                <a:uFillTx/>
-                <a:latin typeface="Arial"/>
-              </a:rPr>
-              <a:t>Đặt vé gọn. Đi xem vui.</a:t>
-            </a:r>
-            <a:endParaRPr lang="en-US" sz="4200" b="0" u="none" strike="noStrike">
-              <a:solidFill>
-                <a:srgbClr val="000000"/>
-              </a:solidFill>
-              <a:effectLst/>
-              <a:uFillTx/>
-              <a:latin typeface="Arial"/>
-            </a:endParaRPr>
-          </a:p>
-        </p:txBody>
-      </p:sp>
-      <p:sp>
-        <p:nvSpPr>
-          <p:cNvPr id="18" name="Text 6"/>
-          <p:cNvSpPr/>
-          <p:nvPr/>
-        </p:nvSpPr>
-        <p:spPr>
-          <a:xfrm>
-            <a:off x="685800" y="3337560"/>
-            <a:ext cx="7772040" cy="648000"/>
-          </a:xfrm>
-          <a:prstGeom prst="rect">
-            <a:avLst/>
-          </a:prstGeom>
-          <a:noFill/>
-          <a:ln w="0">
-            <a:noFill/>
-          </a:ln>
-        </p:spPr>
-        <p:style>
-          <a:lnRef idx="0"/>
-          <a:fillRef idx="0"/>
-          <a:effectRef idx="0"/>
-          <a:fontRef idx="minor"/>
-        </p:style>
-        <p:txBody>
-          <a:bodyPr lIns="0" tIns="0" rIns="0" bIns="0" anchor="ctr">
-            <a:normAutofit/>
-          </a:bodyPr>
-          <a:p>
-            <a:pPr defTabSz="914400">
-              <a:lnSpc>
-                <a:spcPct val="100000"/>
-              </a:lnSpc>
-              <a:tabLst>
-                <a:tab pos="0" algn="l"/>
-              </a:tabLst>
-            </a:pPr>
-            <a:r>
               <a:rPr lang="en-US" sz="1600" b="0" u="none" strike="noStrike">
                 <a:solidFill>
                   <a:srgbClr val="555B67"/>
@@ -2427,7 +2427,7 @@
                 <a:uFillTx/>
                 <a:latin typeface="Arial"/>
               </a:rPr>
-              <a:t>Hệ thống website đặt vé xem phim trực tuyến hiện đại (14 trang MPA), tối ưu trải nghiệm trên Mobile &amp; Desktop, tích hợp REST API và triển khai trên Vercel.</a:t>
+              <a:t>Nền tảng đặt vé xem phim trực tuyến hiện đại (14 trang MPA), tối ưu Mobile &amp; Desktop, tích hợp REST API và triển khai trên Vercel.</a:t>
             </a:r>
             <a:endParaRPr lang="en-US" sz="1600" b="0" u="none" strike="noStrike">
               <a:solidFill>
@@ -2448,8 +2448,8 @@
         </p:nvSpPr>
         <p:spPr>
           <a:xfrm>
-            <a:off x="685800" y="4617720"/>
-            <a:ext cx="27000" cy="1440000"/>
+            <a:off x="685800" y="4500000"/>
+            <a:ext cx="27000" cy="1260000"/>
           </a:xfrm>
           <a:prstGeom prst="rect">
             <a:avLst/>
@@ -2496,7 +2496,7 @@
         </p:nvSpPr>
         <p:spPr>
           <a:xfrm>
-            <a:off x="831960" y="4617720"/>
+            <a:off x="831960" y="4500000"/>
             <a:ext cx="3200040" cy="182520"/>
           </a:xfrm>
           <a:prstGeom prst="rect">
@@ -2556,8 +2556,8 @@
         </p:nvSpPr>
         <p:spPr>
           <a:xfrm>
-            <a:off x="831960" y="4860000"/>
-            <a:ext cx="3291480" cy="1296000"/>
+            <a:off x="831960" y="4752000"/>
+            <a:ext cx="3291480" cy="1080000"/>
           </a:xfrm>
           <a:noFill/>
           <a:ln w="0">
@@ -2592,7 +2592,7 @@
                 <a:uFillTx/>
                 <a:latin typeface="Arial"/>
               </a:rPr>
-              <a:t>Khán giả gặp bất tiện khi tra cứu lịch, rạp &amp; chọn ghế phân tán; quy trình thanh toán phức tạp; thiếu minh bạch về giá vé, khuyến mãi và quyền lợi thành viên.</a:t>
+              <a:t>• Tra cứu lịch, rạp &amp; chọn ghế còn phân tán.</a:t>
             </a:r>
             <a:endParaRPr lang="en-US" sz="1500" b="0" u="none" strike="noStrike">
               <a:solidFill>
@@ -2603,6 +2603,35 @@
               <a:latin typeface="Arial"/>
             </a:endParaRPr>
           </a:p>
+          <a:p>
+            <a:pPr defTabSz="914400">
+              <a:lnSpc>
+                <a:spcPct val="100000"/>
+              </a:lnSpc>
+              <a:tabLst>
+                <a:tab pos="0" algn="l"/>
+              </a:tabLst>
+            </a:pPr>
+            <a:r>
+              <a:rPr lang="en-US" sz="1500" b="1" u="none" strike="noStrike">
+                <a:solidFill>
+                  <a:srgbClr val="171923"/>
+                </a:solidFill>
+                <a:effectLst/>
+                <a:uFillTx/>
+                <a:latin typeface="Arial"/>
+              </a:rPr>
+              <a:t>• Thanh toán rườm rà, thiếu minh bạch ưu đãi &amp; điểm thành viên.</a:t>
+            </a:r>
+            <a:endParaRPr lang="en-US" sz="1500" b="0" u="none" strike="noStrike">
+              <a:solidFill>
+                <a:srgbClr val="000000"/>
+              </a:solidFill>
+              <a:effectLst/>
+              <a:uFillTx/>
+              <a:latin typeface="Arial"/>
+            </a:endParaRPr>
+          </a:p>
         </p:txBody>
       </p:sp>
       <p:sp>
@@ -2613,8 +2642,8 @@
         </p:nvSpPr>
         <p:spPr>
           <a:xfrm>
-            <a:off x="4389120" y="4617720"/>
-            <a:ext cx="27000" cy="1440000"/>
+            <a:off x="4389120" y="4500000"/>
+            <a:ext cx="27000" cy="1260000"/>
           </a:xfrm>
           <a:prstGeom prst="rect">
             <a:avLst/>
@@ -2661,7 +2690,7 @@
         </p:nvSpPr>
         <p:spPr>
           <a:xfrm>
-            <a:off x="4535280" y="4617720"/>
+            <a:off x="4535280" y="4500000"/>
             <a:ext cx="3200040" cy="182520"/>
           </a:xfrm>
           <a:prstGeom prst="rect">
@@ -2721,8 +2750,8 @@
         </p:nvSpPr>
         <p:spPr>
           <a:xfrm>
-            <a:off x="4535280" y="4860000"/>
-            <a:ext cx="3291480" cy="1296000"/>
+            <a:off x="4535280" y="4752000"/>
+            <a:ext cx="3291480" cy="1080000"/>
           </a:xfrm>
           <a:noFill/>
           <a:ln w="0">
@@ -2757,7 +2786,7 @@
                 <a:uFillTx/>
                 <a:latin typeface="Arial"/>
               </a:rPr>
-              <a:t>• Khán giả xem phim: Học sinh, sinh viên, đại chúng cần trải nghiệm đặt vé nhanh chóng, tiện lợi.</a:t>
+              <a:t>• Khán giả: Học sinh, sinh viên, người yêu điện ảnh cần đặt vé nhanh.</a:t>
             </a:r>
             <a:endParaRPr lang="en-US" sz="1500" b="0" u="none" strike="noStrike">
               <a:solidFill>
@@ -2786,7 +2815,7 @@
                 <a:uFillTx/>
                 <a:latin typeface="Arial"/>
               </a:rPr>
-              <a:t>• Nhân viên &amp; Quản trị rạp: Soát vé QR check-in tại quầy, quản lý đơn vé và giám sát KPI doanh thu.</a:t>
+              <a:t>• Nhân viên rạp: Soát vé QR check-in tại quầy &amp; theo dõi doanh thu.</a:t>
             </a:r>
             <a:endParaRPr lang="en-US" sz="1500" b="0" u="none" strike="noStrike">
               <a:solidFill>
@@ -2807,8 +2836,8 @@
         </p:nvSpPr>
         <p:spPr>
           <a:xfrm>
-            <a:off x="8092440" y="4617720"/>
-            <a:ext cx="27000" cy="1440000"/>
+            <a:off x="8092440" y="4500000"/>
+            <a:ext cx="27000" cy="1260000"/>
           </a:xfrm>
           <a:prstGeom prst="rect">
             <a:avLst/>
@@ -2855,7 +2884,7 @@
         </p:nvSpPr>
         <p:spPr>
           <a:xfrm>
-            <a:off x="8238600" y="4617720"/>
+            <a:off x="8238600" y="4500000"/>
             <a:ext cx="3200040" cy="182520"/>
           </a:xfrm>
           <a:prstGeom prst="rect">
@@ -2915,8 +2944,8 @@
         </p:nvSpPr>
         <p:spPr>
           <a:xfrm>
-            <a:off x="8238600" y="4860000"/>
-            <a:ext cx="3291480" cy="1296000"/>
+            <a:off x="8238600" y="4752000"/>
+            <a:ext cx="3291480" cy="1080000"/>
           </a:xfrm>
           <a:noFill/>
           <a:ln w="0">
@@ -2931,7 +2960,7 @@
         </p:style>
         <p:txBody>
           <a:bodyPr lIns="0" tIns="0" rIns="0" bIns="0" anchor="ctr">
-            <a:normAutofit fontScale="85000" lnSpcReduction="19999"/>
+            <a:normAutofit fontScale="85000" lnSpcReduction="9999"/>
           </a:bodyPr>
           <a:p>
             <a:pPr defTabSz="914400">
@@ -2951,7 +2980,7 @@
                 <a:uFillTx/>
                 <a:latin typeface="Arial"/>
               </a:rPr>
-              <a:t>• Nguyễn Văn Trọng: Leader &amp; Architect (Core UI, Router, REST API, Bun/Vercel)</a:t>
+              <a:t>• Nguyễn Văn Trọng: Leader &amp; Architect (UI, Router, API, Vercel)</a:t>
             </a:r>
             <a:endParaRPr lang="en-US" sz="1500" b="0" u="none" strike="noStrike">
               <a:solidFill>
@@ -2980,7 +3009,7 @@
                 <a:uFillTx/>
                 <a:latin typeface="Arial"/>
               </a:rPr>
-              <a:t>• Vũ Tiến Lập: Frontend &amp; QA Lead (Checkout, Bắp nước, Cụm rạp, Test 56/56)</a:t>
+              <a:t>• Vũ Tiến Lập: Frontend &amp; QA Lead (Checkout, Rạp, Test 56/56)</a:t>
             </a:r>
             <a:endParaRPr lang="en-US" sz="1500" b="0" u="none" strike="noStrike">
               <a:solidFill>
@@ -3009,7 +3038,7 @@
                 <a:uFillTx/>
                 <a:latin typeface="Arial"/>
               </a:rPr>
-              <a:t>• Phạm Anh Duy: Feature Integrator (Ghế &amp; Timer 5p, Voucher, Member 3D, Admin QR)</a:t>
+              <a:t>• Phạm Anh Duy: Feature Lead (Ghế 164, Voucher, Member 3D, Admin)</a:t>
             </a:r>
             <a:endParaRPr lang="en-US" sz="1500" b="0" u="none" strike="noStrike">
               <a:solidFill>
@@ -3022,6 +3051,83 @@
           </a:p>
         </p:txBody>
       </p:sp>
+      <p:sp>
+        <p:nvSpPr>
+          <p:cNvPr id="28" name="CardPreviewHome"/>
+          <p:cNvSpPr/>
+          <p:nvPr/>
+        </p:nvSpPr>
+        <p:spPr>
+          <a:xfrm>
+            <a:off x="6300000" y="1152000"/>
+            <a:ext cx="5328000" cy="3024000"/>
+          </a:xfrm>
+          <a:prstGeom prst="roundRect">
+            <a:avLst>
+              <a:gd name="adj" fmla="val 5634"/>
+            </a:avLst>
+          </a:prstGeom>
+          <a:solidFill>
+            <a:srgbClr val="FFFFFF"/>
+          </a:solidFill>
+          <a:ln w="12600">
+            <a:solidFill>
+              <a:srgbClr val="E8E6E2"/>
+            </a:solidFill>
+            <a:round/>
+          </a:ln>
+        </p:spPr>
+        <p:style>
+          <a:lnRef idx="0"/>
+          <a:fillRef idx="0"/>
+          <a:effectRef idx="0"/>
+          <a:fontRef idx="minor"/>
+        </p:style>
+        <p:txBody>
+          <a:bodyPr lIns="90000" tIns="45000" rIns="90000" bIns="45000" anchor="t">
+            <a:noAutofit/>
+          </a:bodyPr>
+          <a:p>
+            <a:endParaRPr lang="en-US" sz="1800" b="0" u="none" strike="noStrike">
+              <a:solidFill>
+                <a:srgbClr val="000000"/>
+              </a:solidFill>
+              <a:effectLst/>
+              <a:uFillTx/>
+              <a:latin typeface="Arial"/>
+            </a:endParaRPr>
+          </a:p>
+        </p:txBody>
+      </p:sp>
+      <p:pic>
+        <p:nvPicPr>
+          <p:cNvPr id="29" name="PreviewHome"/>
+          <p:cNvPicPr/>
+          <p:nvPr/>
+        </p:nvPicPr>
+        <p:blipFill>
+          <a:blip r:embed="rId1"/>
+          <a:stretch/>
+        </p:blipFill>
+        <p:spPr>
+          <a:xfrm>
+            <a:off x="6408000" y="1242000"/>
+            <a:ext cx="5112000" cy="2844000"/>
+          </a:xfrm>
+          <a:prstGeom prst="rect">
+            <a:avLst/>
+          </a:prstGeom>
+          <a:solidFill>
+            <a:srgbClr val="FFFFFF"/>
+          </a:solidFill>
+          <a:ln w="12600">
+            <a:solidFill>
+              <a:srgbClr val="E8E6E2"/>
+            </a:solidFill>
+            <a:round/>
+          </a:ln>
+        </p:spPr>
+      </p:pic>
     </p:spTree>
   </p:cSld>
   <mc:AlternateContent>
@@ -3054,7 +3160,7 @@
       </p:grpSpPr>
       <p:sp>
         <p:nvSpPr>
-          <p:cNvPr id="28" name="Shape 0"/>
+          <p:cNvPr id="30" name="Shape 0"/>
           <p:cNvSpPr/>
           <p:nvPr/>
         </p:nvSpPr>
@@ -3102,7 +3208,7 @@
       </p:sp>
       <p:sp>
         <p:nvSpPr>
-          <p:cNvPr id="29" name="Text 1"/>
+          <p:cNvPr id="31" name="Text 1"/>
           <p:cNvSpPr/>
           <p:nvPr/>
         </p:nvSpPr>
@@ -3162,7 +3268,7 @@
       </p:sp>
       <p:sp>
         <p:nvSpPr>
-          <p:cNvPr id="30" name="Text 2"/>
+          <p:cNvPr id="32" name="Text 2"/>
           <p:cNvSpPr/>
           <p:nvPr/>
         </p:nvSpPr>
@@ -3222,7 +3328,7 @@
       </p:sp>
       <p:sp>
         <p:nvSpPr>
-          <p:cNvPr id="31" name="Text 3"/>
+          <p:cNvPr id="33" name="Text 3"/>
           <p:cNvSpPr/>
           <p:nvPr/>
         </p:nvSpPr>
@@ -3282,7 +3388,7 @@
       </p:sp>
       <p:sp>
         <p:nvSpPr>
-          <p:cNvPr id="32" name="Text 4"/>
+          <p:cNvPr id="34" name="Text 4"/>
           <p:cNvSpPr/>
           <p:nvPr/>
         </p:nvSpPr>
@@ -3342,7 +3448,7 @@
       </p:sp>
       <p:sp>
         <p:nvSpPr>
-          <p:cNvPr id="33" name="Text 5"/>
+          <p:cNvPr id="35" name="Text 5"/>
           <p:cNvSpPr/>
           <p:nvPr/>
         </p:nvSpPr>
@@ -3402,7 +3508,7 @@
       </p:sp>
       <p:sp>
         <p:nvSpPr>
-          <p:cNvPr id="34" name="Card 01"/>
+          <p:cNvPr id="36" name="Card 01"/>
           <p:cNvSpPr/>
           <p:nvPr/>
         </p:nvSpPr>
@@ -3450,7 +3556,7 @@
       </p:sp>
       <p:sp>
         <p:nvSpPr>
-          <p:cNvPr id="35" name="Num 01"/>
+          <p:cNvPr id="37" name="Num 01"/>
           <p:cNvSpPr/>
           <p:nvPr/>
         </p:nvSpPr>
@@ -3510,7 +3616,7 @@
       </p:sp>
       <p:sp>
         <p:nvSpPr>
-          <p:cNvPr id="36" name="Title 01"/>
+          <p:cNvPr id="38" name="Title 01"/>
           <p:cNvSpPr/>
           <p:nvPr/>
         </p:nvSpPr>
@@ -3570,7 +3676,7 @@
       </p:sp>
       <p:sp>
         <p:nvSpPr>
-          <p:cNvPr id="37" name="Desc 01"/>
+          <p:cNvPr id="39" name="Desc 01"/>
           <p:cNvSpPr/>
           <p:nvPr/>
         </p:nvSpPr>
@@ -3615,7 +3721,7 @@
                 <a:uFillTx/>
                 <a:latin typeface="Arial"/>
               </a:rPr>
-              <a:t>Duyệt danh sách phim Đang chiếu &amp; Sắp chiếu; bộ lọc tìm kiếm theo thể loại, định dạng 2D/3D; xem trailer YouTube trực tiếp trong modal.</a:t>
+              <a:t>Duyệt phim Đang chiếu &amp; Sắp chiếu; bộ lọc tìm kiếm theo thể loại &amp; 2D/3D; xem trailer YouTube modal trực tiếp.</a:t>
             </a:r>
             <a:endParaRPr lang="en-US" sz="1050" b="0" u="none" strike="noStrike">
               <a:solidFill>
@@ -3630,7 +3736,7 @@
       </p:sp>
       <p:sp>
         <p:nvSpPr>
-          <p:cNvPr id="38" name="Card 02"/>
+          <p:cNvPr id="40" name="Card 02"/>
           <p:cNvSpPr/>
           <p:nvPr/>
         </p:nvSpPr>
@@ -3678,7 +3784,7 @@
       </p:sp>
       <p:sp>
         <p:nvSpPr>
-          <p:cNvPr id="39" name="Num 02"/>
+          <p:cNvPr id="41" name="Num 02"/>
           <p:cNvSpPr/>
           <p:nvPr/>
         </p:nvSpPr>
@@ -3738,7 +3844,7 @@
       </p:sp>
       <p:sp>
         <p:nvSpPr>
-          <p:cNvPr id="40" name="Title 02"/>
+          <p:cNvPr id="42" name="Title 02"/>
           <p:cNvSpPr/>
           <p:nvPr/>
         </p:nvSpPr>
@@ -3798,7 +3904,7 @@
       </p:sp>
       <p:sp>
         <p:nvSpPr>
-          <p:cNvPr id="41" name="Desc 02"/>
+          <p:cNvPr id="43" name="Desc 02"/>
           <p:cNvSpPr/>
           <p:nvPr/>
         </p:nvSpPr>
@@ -3843,7 +3949,7 @@
                 <a:uFillTx/>
                 <a:latin typeface="Arial"/>
               </a:rPr>
-              <a:t>Tra cứu suất chiếu theo ngày và 10 cụm rạp Beta toàn quốc; lọc nhanh theo định dạng phòng chiếu (2D Lồng tiếng/Phụ đề) theo thời gian thực.</a:t>
+              <a:t>Tra cứu suất chiếu theo ngày tại 10 rạp Beta toàn quốc; lọc nhanh theo định dạng phòng chiếu (2D Lồng tiếng/Phụ đề).</a:t>
             </a:r>
             <a:endParaRPr lang="en-US" sz="1050" b="0" u="none" strike="noStrike">
               <a:solidFill>
@@ -3858,7 +3964,7 @@
       </p:sp>
       <p:sp>
         <p:nvSpPr>
-          <p:cNvPr id="42" name="Card 03"/>
+          <p:cNvPr id="44" name="Card 03"/>
           <p:cNvSpPr/>
           <p:nvPr/>
         </p:nvSpPr>
@@ -3906,7 +4012,7 @@
       </p:sp>
       <p:sp>
         <p:nvSpPr>
-          <p:cNvPr id="43" name="Num 03"/>
+          <p:cNvPr id="45" name="Num 03"/>
           <p:cNvSpPr/>
           <p:nvPr/>
         </p:nvSpPr>
@@ -3966,7 +4072,7 @@
       </p:sp>
       <p:sp>
         <p:nvSpPr>
-          <p:cNvPr id="44" name="Title 03"/>
+          <p:cNvPr id="46" name="Title 03"/>
           <p:cNvSpPr/>
           <p:nvPr/>
         </p:nvSpPr>
@@ -4026,7 +4132,7 @@
       </p:sp>
       <p:sp>
         <p:nvSpPr>
-          <p:cNvPr id="45" name="Desc 03"/>
+          <p:cNvPr id="47" name="Desc 03"/>
           <p:cNvSpPr/>
           <p:nvPr/>
         </p:nvSpPr>
@@ -4071,7 +4177,7 @@
                 <a:uFillTx/>
                 <a:latin typeface="Arial"/>
               </a:rPr>
-              <a:t>Sơ đồ 12 hàng A-M phân loại Standard, VIP, Sweetbox đôi; tự động kích hoạt đồng hồ đếm ngược giữ ghế 5 phút chống đặt trùng ghế.</a:t>
+              <a:t>12 hàng ghế A-M (Standard, VIP, Sweetbox đôi); tự động kích hoạt đếm ngược 5 phút chống đặt trùng ghế.</a:t>
             </a:r>
             <a:endParaRPr lang="en-US" sz="1050" b="0" u="none" strike="noStrike">
               <a:solidFill>
@@ -4086,7 +4192,7 @@
       </p:sp>
       <p:sp>
         <p:nvSpPr>
-          <p:cNvPr id="46" name="Card 04"/>
+          <p:cNvPr id="48" name="Card 04"/>
           <p:cNvSpPr/>
           <p:nvPr/>
         </p:nvSpPr>
@@ -4134,7 +4240,7 @@
       </p:sp>
       <p:sp>
         <p:nvSpPr>
-          <p:cNvPr id="47" name="Num 04"/>
+          <p:cNvPr id="49" name="Num 04"/>
           <p:cNvSpPr/>
           <p:nvPr/>
         </p:nvSpPr>
@@ -4194,7 +4300,7 @@
       </p:sp>
       <p:sp>
         <p:nvSpPr>
-          <p:cNvPr id="48" name="Title 04"/>
+          <p:cNvPr id="50" name="Title 04"/>
           <p:cNvSpPr/>
           <p:nvPr/>
         </p:nvSpPr>
@@ -4254,7 +4360,7 @@
       </p:sp>
       <p:sp>
         <p:nvSpPr>
-          <p:cNvPr id="49" name="Desc 04"/>
+          <p:cNvPr id="51" name="Desc 04"/>
           <p:cNvSpPr/>
           <p:nvPr/>
         </p:nvSpPr>
@@ -4299,7 +4405,7 @@
                 <a:uFillTx/>
                 <a:latin typeface="Arial"/>
               </a:rPr>
-              <a:t>Chọn combo bắp nước đi kèm; tự động kiểm tra điều kiện áp mã (BETA10, BETA50, SV20) và chiết khấu tổng tiền tức thì.</a:t>
+              <a:t>Chọn combo bắp nước đi kèm; tự động kiểm tra điều kiện áp mã (BETA10, BETA50, SV20) và chiết khấu tức thì.</a:t>
             </a:r>
             <a:endParaRPr lang="en-US" sz="1050" b="0" u="none" strike="noStrike">
               <a:solidFill>
@@ -4314,7 +4420,7 @@
       </p:sp>
       <p:sp>
         <p:nvSpPr>
-          <p:cNvPr id="50" name="Card 05"/>
+          <p:cNvPr id="52" name="Card 05"/>
           <p:cNvSpPr/>
           <p:nvPr/>
         </p:nvSpPr>
@@ -4362,7 +4468,7 @@
       </p:sp>
       <p:sp>
         <p:nvSpPr>
-          <p:cNvPr id="51" name="Num 05"/>
+          <p:cNvPr id="53" name="Num 05"/>
           <p:cNvSpPr/>
           <p:nvPr/>
         </p:nvSpPr>
@@ -4422,7 +4528,7 @@
       </p:sp>
       <p:sp>
         <p:nvSpPr>
-          <p:cNvPr id="52" name="Title 05"/>
+          <p:cNvPr id="54" name="Title 05"/>
           <p:cNvSpPr/>
           <p:nvPr/>
         </p:nvSpPr>
@@ -4482,7 +4588,7 @@
       </p:sp>
       <p:sp>
         <p:nvSpPr>
-          <p:cNvPr id="53" name="Desc 05"/>
+          <p:cNvPr id="55" name="Desc 05"/>
           <p:cNvSpPr/>
           <p:nvPr/>
         </p:nvSpPr>
@@ -4527,7 +4633,7 @@
                 <a:uFillTx/>
                 <a:latin typeface="Arial"/>
               </a:rPr>
-              <a:t>Quy trình thanh toán mô phỏng VNPAY/MoMo/Thẻ ngân hàng; tự động sinh vé điện tử có mã QR Code định danh duy nhất phục vụ check-in.</a:t>
+              <a:t>Thanh toán mô phỏng VNPAY/MoMo/Thẻ ngân hàng; tự động sinh vé điện tử có mã QR Code check-in tại quầy.</a:t>
             </a:r>
             <a:endParaRPr lang="en-US" sz="1050" b="0" u="none" strike="noStrike">
               <a:solidFill>
@@ -4542,7 +4648,7 @@
       </p:sp>
       <p:sp>
         <p:nvSpPr>
-          <p:cNvPr id="54" name="Card 06"/>
+          <p:cNvPr id="56" name="Card 06"/>
           <p:cNvSpPr/>
           <p:nvPr/>
         </p:nvSpPr>
@@ -4590,7 +4696,7 @@
       </p:sp>
       <p:sp>
         <p:nvSpPr>
-          <p:cNvPr id="55" name="Num 06"/>
+          <p:cNvPr id="57" name="Num 06"/>
           <p:cNvSpPr/>
           <p:nvPr/>
         </p:nvSpPr>
@@ -4650,7 +4756,7 @@
       </p:sp>
       <p:sp>
         <p:nvSpPr>
-          <p:cNvPr id="56" name="Title 06"/>
+          <p:cNvPr id="58" name="Title 06"/>
           <p:cNvSpPr/>
           <p:nvPr/>
         </p:nvSpPr>
@@ -4710,7 +4816,7 @@
       </p:sp>
       <p:sp>
         <p:nvSpPr>
-          <p:cNvPr id="57" name="Desc 06"/>
+          <p:cNvPr id="59" name="Desc 06"/>
           <p:cNvSpPr/>
           <p:nvPr/>
         </p:nvSpPr>
@@ -4755,7 +4861,7 @@
                 <a:uFillTx/>
                 <a:latin typeface="Arial"/>
               </a:rPr>
-              <a:t>Thẻ hội viên hiệu ứng 3D Gyroscope/Tilt, theo dõi điểm thưởng, đổi voucher; Cổng Admin bảo mật Auth Gate, Dashboard KPI &amp; Soát vé QR.</a:t>
+              <a:t>Thẻ hội viên 3D interactive, đổi voucher bằng điểm; Cổng Admin bảo mật Auth Gate, Dashboard KPI &amp; Soát vé QR.</a:t>
             </a:r>
             <a:endParaRPr lang="en-US" sz="1050" b="0" u="none" strike="noStrike">
               <a:solidFill>
@@ -4800,7 +4906,7 @@
       </p:grpSpPr>
       <p:sp>
         <p:nvSpPr>
-          <p:cNvPr id="58" name="Shape 0"/>
+          <p:cNvPr id="60" name="Shape 0"/>
           <p:cNvSpPr/>
           <p:nvPr/>
         </p:nvSpPr>
@@ -4848,7 +4954,7 @@
       </p:sp>
       <p:sp>
         <p:nvSpPr>
-          <p:cNvPr id="59" name="Text 1"/>
+          <p:cNvPr id="61" name="Text 1"/>
           <p:cNvSpPr/>
           <p:nvPr/>
         </p:nvSpPr>
@@ -4908,7 +5014,7 @@
       </p:sp>
       <p:sp>
         <p:nvSpPr>
-          <p:cNvPr id="60" name="Text 2"/>
+          <p:cNvPr id="62" name="Text 2"/>
           <p:cNvSpPr/>
           <p:nvPr/>
         </p:nvSpPr>
@@ -4968,7 +5074,7 @@
       </p:sp>
       <p:sp>
         <p:nvSpPr>
-          <p:cNvPr id="61" name="Text 3"/>
+          <p:cNvPr id="63" name="Text 3"/>
           <p:cNvSpPr/>
           <p:nvPr/>
         </p:nvSpPr>
@@ -5028,7 +5134,7 @@
       </p:sp>
       <p:sp>
         <p:nvSpPr>
-          <p:cNvPr id="62" name="Text 4"/>
+          <p:cNvPr id="64" name="Text 4"/>
           <p:cNvSpPr/>
           <p:nvPr/>
         </p:nvSpPr>
@@ -5088,7 +5194,7 @@
       </p:sp>
       <p:sp>
         <p:nvSpPr>
-          <p:cNvPr id="63" name="Text 5"/>
+          <p:cNvPr id="65" name="Text 5"/>
           <p:cNvSpPr/>
           <p:nvPr/>
         </p:nvSpPr>
@@ -5148,7 +5254,7 @@
       </p:sp>
       <p:sp>
         <p:nvSpPr>
-          <p:cNvPr id="64" name="Card Must Have"/>
+          <p:cNvPr id="66" name="Card Must Have"/>
           <p:cNvSpPr/>
           <p:nvPr/>
         </p:nvSpPr>
@@ -5196,7 +5302,7 @@
       </p:sp>
       <p:sp>
         <p:nvSpPr>
-          <p:cNvPr id="65" name="Title Must Have"/>
+          <p:cNvPr id="67" name="Title Must Have"/>
           <p:cNvSpPr/>
           <p:nvPr/>
         </p:nvSpPr>
@@ -5256,7 +5362,7 @@
       </p:sp>
       <p:sp>
         <p:nvSpPr>
-          <p:cNvPr id="66" name="Body Must Have"/>
+          <p:cNvPr id="68" name="Body Must Have"/>
           <p:cNvSpPr/>
           <p:nvPr/>
         </p:nvSpPr>
@@ -5265,9 +5371,6 @@
             <a:off x="813960" y="2862000"/>
             <a:ext cx="4910040" cy="1116000"/>
           </a:xfrm>
-          <a:prstGeom prst="rect">
-            <a:avLst/>
-          </a:prstGeom>
           <a:noFill/>
           <a:ln w="0">
             <a:noFill/>
@@ -5312,7 +5415,7 @@
                 <a:uFillTx/>
                 <a:latin typeface="Arial"/>
               </a:rPr>
-              <a:t>Luồng đặt vé khép kín: Chọn phim → suất chiếu → chọn ghế → bắp nước → thanh toán → nhận vé điện tử.</a:t>
+              <a:t>Luồng đặt vé khép kín: Chọn phim → suất → ghế → bắp nước → vé QR.</a:t>
             </a:r>
             <a:endParaRPr lang="en-US" sz="1050" b="0" u="none" strike="noStrike">
               <a:solidFill>
@@ -5352,7 +5455,7 @@
                 <a:uFillTx/>
                 <a:latin typeface="Arial"/>
               </a:rPr>
-              <a:t>Sơ đồ 164 ghế trực quan, cơ chế giữ ghế chống đặt trùng thời gian thực.</a:t>
+              <a:t>Sơ đồ 164 ghế trực quan, giữ chỗ 5 phút chống đặt trùng thời gian thực.</a:t>
             </a:r>
             <a:endParaRPr lang="en-US" sz="1050" b="0" u="none" strike="noStrike">
               <a:solidFill>
@@ -5392,7 +5495,7 @@
                 <a:uFillTx/>
                 <a:latin typeface="Arial"/>
               </a:rPr>
-              <a:t>Xuất vé mã QR Code động phục vụ xác thực check-in tại quầy rạp.</a:t>
+              <a:t>Tài khoản hội viên &amp; bảo mật Cổng quản trị Admin bằng JWT Token.</a:t>
             </a:r>
             <a:endParaRPr lang="en-US" sz="1050" b="0" u="none" strike="noStrike">
               <a:solidFill>
@@ -5403,51 +5506,11 @@
               <a:latin typeface="Arial"/>
             </a:endParaRPr>
           </a:p>
-          <a:p>
-            <a:pPr defTabSz="914400">
-              <a:lnSpc>
-                <a:spcPct val="100000"/>
-              </a:lnSpc>
-              <a:tabLst>
-                <a:tab pos="0" algn="l"/>
-              </a:tabLst>
-            </a:pPr>
-            <a:r>
-              <a:rPr lang="en-US" sz="1300" b="1" u="none" strike="noStrike">
-                <a:solidFill>
-                  <a:srgbClr val="E51D2A"/>
-                </a:solidFill>
-                <a:effectLst/>
-                <a:uFillTx/>
-                <a:latin typeface="Arial"/>
-              </a:rPr>
-              <a:t>• </a:t>
-            </a:r>
-            <a:r>
-              <a:rPr lang="en-US" sz="1050" b="0" u="none" strike="noStrike">
-                <a:solidFill>
-                  <a:srgbClr val="171923"/>
-                </a:solidFill>
-                <a:effectLst/>
-                <a:uFillTx/>
-                <a:latin typeface="Arial"/>
-              </a:rPr>
-              <a:t>Quản lý tài khoản, tích lũy điểm thưởng và bảo vệ cổng quản trị Admin.</a:t>
-            </a:r>
-            <a:endParaRPr lang="en-US" sz="1050" b="0" u="none" strike="noStrike">
-              <a:solidFill>
-                <a:srgbClr val="000000"/>
-              </a:solidFill>
-              <a:effectLst/>
-              <a:uFillTx/>
-              <a:latin typeface="Arial"/>
-            </a:endParaRPr>
-          </a:p>
-        </p:txBody>
-      </p:sp>
-      <p:sp>
-        <p:nvSpPr>
-          <p:cNvPr id="67" name="Card Completed"/>
+        </p:txBody>
+      </p:sp>
+      <p:sp>
+        <p:nvSpPr>
+          <p:cNvPr id="69" name="Card Completed"/>
           <p:cNvSpPr/>
           <p:nvPr/>
         </p:nvSpPr>
@@ -5495,7 +5558,7 @@
       </p:sp>
       <p:sp>
         <p:nvSpPr>
-          <p:cNvPr id="68" name="Title Completed"/>
+          <p:cNvPr id="70" name="Title Completed"/>
           <p:cNvSpPr/>
           <p:nvPr/>
         </p:nvSpPr>
@@ -5555,7 +5618,7 @@
       </p:sp>
       <p:sp>
         <p:nvSpPr>
-          <p:cNvPr id="69" name="Body Completed"/>
+          <p:cNvPr id="71" name="Body Completed"/>
           <p:cNvSpPr/>
           <p:nvPr/>
         </p:nvSpPr>
@@ -5564,9 +5627,6 @@
             <a:off x="813960" y="4518000"/>
             <a:ext cx="4910040" cy="1152000"/>
           </a:xfrm>
-          <a:prstGeom prst="rect">
-            <a:avLst/>
-          </a:prstGeom>
           <a:noFill/>
           <a:ln w="0">
             <a:noFill/>
@@ -5580,7 +5640,7 @@
         </p:style>
         <p:txBody>
           <a:bodyPr lIns="0" tIns="0" rIns="0" bIns="0" anchor="ctr">
-            <a:normAutofit lnSpcReduction="9999"/>
+            <a:normAutofit/>
           </a:bodyPr>
           <a:p>
             <a:pPr defTabSz="914400">
@@ -5611,7 +5671,7 @@
                 <a:uFillTx/>
                 <a:latin typeface="Arial"/>
               </a:rPr>
-              <a:t>Hoàn thiện 14/14 trang MPA: Home, Movies, Detail, Schedule, Cinemas, Pricing, News, Booking, Checkout, Member, Profile, Admin, 404, Error.</a:t>
+              <a:t>14/14 trang MPA hoàn thiện, responsive mượt mà Desktop &amp; Mobile.</a:t>
             </a:r>
             <a:endParaRPr lang="en-US" sz="1050" b="0" u="none" strike="noStrike">
               <a:solidFill>
@@ -5651,7 +5711,7 @@
                 <a:uFillTx/>
                 <a:latin typeface="Arial"/>
               </a:rPr>
-              <a:t>Cơ chế giữ ghế 5 phút tự động hủy; hệ thống voucher kiểm tra minOrder/maxCap.</a:t>
+              <a:t>Giữ ghế 5 phút, áp mã voucher, thẻ thành viên 3D, soát vé QR tức thì.</a:t>
             </a:r>
             <a:endParaRPr lang="en-US" sz="1050" b="0" u="none" strike="noStrike">
               <a:solidFill>
@@ -5691,7 +5751,7 @@
                 <a:uFillTx/>
                 <a:latin typeface="Arial"/>
               </a:rPr>
-              <a:t>Trang Thành Viên thẻ 3D interactive, đổi quà; Cổng Admin Dashboard &amp; Soát vé QR.</a:t>
+              <a:t>Bộ test tự động 56/56 Use Cases &amp; Ngoại lệ PASS 100%; build nhanh ~740ms.</a:t>
             </a:r>
             <a:endParaRPr lang="en-US" sz="1050" b="0" u="none" strike="noStrike">
               <a:solidFill>
@@ -5702,51 +5762,11 @@
               <a:latin typeface="Arial"/>
             </a:endParaRPr>
           </a:p>
-          <a:p>
-            <a:pPr defTabSz="914400">
-              <a:lnSpc>
-                <a:spcPct val="100000"/>
-              </a:lnSpc>
-              <a:tabLst>
-                <a:tab pos="0" algn="l"/>
-              </a:tabLst>
-            </a:pPr>
-            <a:r>
-              <a:rPr lang="en-US" sz="1300" b="1" u="none" strike="noStrike">
-                <a:solidFill>
-                  <a:srgbClr val="E51D2A"/>
-                </a:solidFill>
-                <a:effectLst/>
-                <a:uFillTx/>
-                <a:latin typeface="Arial"/>
-              </a:rPr>
-              <a:t>• </a:t>
-            </a:r>
-            <a:r>
-              <a:rPr lang="en-US" sz="1050" b="0" u="none" strike="noStrike">
-                <a:solidFill>
-                  <a:srgbClr val="171923"/>
-                </a:solidFill>
-                <a:effectLst/>
-                <a:uFillTx/>
-                <a:latin typeface="Arial"/>
-              </a:rPr>
-              <a:t>Bộ kiểm thử 56/56 automated use cases PASS 100%; build MPA nhanh ~744ms.</a:t>
-            </a:r>
-            <a:endParaRPr lang="en-US" sz="1050" b="0" u="none" strike="noStrike">
-              <a:solidFill>
-                <a:srgbClr val="000000"/>
-              </a:solidFill>
-              <a:effectLst/>
-              <a:uFillTx/>
-              <a:latin typeface="Arial"/>
-            </a:endParaRPr>
-          </a:p>
-        </p:txBody>
-      </p:sp>
-      <p:sp>
-        <p:nvSpPr>
-          <p:cNvPr id="70" name="Card Pending"/>
+        </p:txBody>
+      </p:sp>
+      <p:sp>
+        <p:nvSpPr>
+          <p:cNvPr id="72" name="Card Pending"/>
           <p:cNvSpPr/>
           <p:nvPr/>
         </p:nvSpPr>
@@ -5794,7 +5814,7 @@
       </p:sp>
       <p:sp>
         <p:nvSpPr>
-          <p:cNvPr id="71" name="Title Pending"/>
+          <p:cNvPr id="73" name="Title Pending"/>
           <p:cNvSpPr/>
           <p:nvPr/>
         </p:nvSpPr>
@@ -5854,7 +5874,7 @@
       </p:sp>
       <p:sp>
         <p:nvSpPr>
-          <p:cNvPr id="72" name="Body Pending"/>
+          <p:cNvPr id="74" name="Body Pending"/>
           <p:cNvSpPr/>
           <p:nvPr/>
         </p:nvSpPr>
@@ -5863,9 +5883,6 @@
             <a:off x="6455520" y="2862000"/>
             <a:ext cx="4910040" cy="1116000"/>
           </a:xfrm>
-          <a:prstGeom prst="rect">
-            <a:avLst/>
-          </a:prstGeom>
           <a:noFill/>
           <a:ln w="0">
             <a:noFill/>
@@ -5910,7 +5927,7 @@
                 <a:uFillTx/>
                 <a:latin typeface="Arial"/>
               </a:rPr>
-              <a:t>Cổng thanh toán trực tiếp ngân hàng thật: Hiện tại là mô phỏng do cần tư cách pháp nhân ký hợp đồng thương mại với VNPAY/MoMo thực tế.</a:t>
+              <a:t>Cổng thanh toán ngân hàng thật (cần tư cách pháp nhân ký hợp đồng VNPAY).</a:t>
             </a:r>
             <a:endParaRPr lang="en-US" sz="1050" b="0" u="none" strike="noStrike">
               <a:solidFill>
@@ -5950,7 +5967,7 @@
                 <a:uFillTx/>
                 <a:latin typeface="Arial"/>
               </a:rPr>
-              <a:t>Gửi vé tự động qua SMS Brandname / Zalo ZNS: Cần đăng ký tên định danh viễn thông và chi phí duy trì dịch vụ SMS gateway.</a:t>
+              <a:t>Gửi vé tự động SMS Brandname / Zalo ZNS (yêu cầu chi phí viễn thông).</a:t>
             </a:r>
             <a:endParaRPr lang="en-US" sz="1050" b="0" u="none" strike="noStrike">
               <a:solidFill>
@@ -5990,7 +6007,7 @@
                 <a:uFillTx/>
                 <a:latin typeface="Arial"/>
               </a:rPr>
-              <a:t>Đồng bộ phòng chiếu đa server: Sử dụng REST API tập trung, chưa phân tán microservices.</a:t>
+              <a:t>Đồng bộ phòng chiếu đa server (hiện sử dụng REST API tập trung).</a:t>
             </a:r>
             <a:endParaRPr lang="en-US" sz="1050" b="0" u="none" strike="noStrike">
               <a:solidFill>
@@ -6005,7 +6022,7 @@
       </p:sp>
       <p:sp>
         <p:nvSpPr>
-          <p:cNvPr id="73" name="Card Scoped Out"/>
+          <p:cNvPr id="75" name="Card Scoped Out"/>
           <p:cNvSpPr/>
           <p:nvPr/>
         </p:nvSpPr>
@@ -6053,7 +6070,7 @@
       </p:sp>
       <p:sp>
         <p:nvSpPr>
-          <p:cNvPr id="74" name="Title Scoped Out"/>
+          <p:cNvPr id="76" name="Title Scoped Out"/>
           <p:cNvSpPr/>
           <p:nvPr/>
         </p:nvSpPr>
@@ -6113,7 +6130,7 @@
       </p:sp>
       <p:sp>
         <p:nvSpPr>
-          <p:cNvPr id="75" name="Body Scoped Out"/>
+          <p:cNvPr id="77" name="Body Scoped Out"/>
           <p:cNvSpPr/>
           <p:nvPr/>
         </p:nvSpPr>
@@ -6122,9 +6139,6 @@
             <a:off x="6455520" y="4518000"/>
             <a:ext cx="4910040" cy="1152000"/>
           </a:xfrm>
-          <a:prstGeom prst="rect">
-            <a:avLst/>
-          </a:prstGeom>
           <a:noFill/>
           <a:ln w="0">
             <a:noFill/>
@@ -6169,7 +6183,7 @@
                 <a:uFillTx/>
                 <a:latin typeface="Arial"/>
               </a:rPr>
-              <a:t>Đặt vé theo nhóm &amp; chia tiền (Split-bill): Cắt giảm để ưu tiên tối đa cho luồng cá nhân đặt vé nhanh, mượt mà và chống nghẽn thao tác.</a:t>
+              <a:t>Đặt vé theo nhóm chia tiền (Split-bill): Cắt để ưu tiên luồng đặt vé nhanh.</a:t>
             </a:r>
             <a:endParaRPr lang="en-US" sz="1050" b="0" u="none" strike="noStrike">
               <a:solidFill>
@@ -6209,7 +6223,7 @@
                 <a:uFillTx/>
                 <a:latin typeface="Arial"/>
               </a:rPr>
-              <a:t>Đặt trước dịch vụ xe đưa đón đến rạp: Cắt khỏi scope vì không thuộc nghiệp vụ cốt lõi của website rạp phim.</a:t>
+              <a:t>Đặt trước xe đưa đón rạp: Cắt vì không thuộc nghiệp vụ cốt lõi rạp phim.</a:t>
             </a:r>
             <a:endParaRPr lang="en-US" sz="1050" b="0" u="none" strike="noStrike">
               <a:solidFill>
@@ -6249,7 +6263,7 @@
                 <a:uFillTx/>
                 <a:latin typeface="Arial"/>
               </a:rPr>
-              <a:t>Mạng xã hội bình luận đa cấp: Thay thế bằng trailer YouTube và đánh giá trực quan để hệ thống vận hành nhẹ nhàng, tránh spam.</a:t>
+              <a:t>Mạng xã hội bình luận đa cấp: Thay bằng trailer YouTube &amp; đánh giá trực tiếp.</a:t>
             </a:r>
             <a:endParaRPr lang="en-US" sz="1050" b="0" u="none" strike="noStrike">
               <a:solidFill>
@@ -6264,7 +6278,7 @@
       </p:sp>
       <p:sp>
         <p:nvSpPr>
-          <p:cNvPr id="76" name="Footer MVP"/>
+          <p:cNvPr id="78" name="Footer MVP"/>
           <p:cNvSpPr/>
           <p:nvPr/>
         </p:nvSpPr>
@@ -6361,7 +6375,7 @@
       </p:grpSpPr>
       <p:sp>
         <p:nvSpPr>
-          <p:cNvPr id="77" name="Shape 0"/>
+          <p:cNvPr id="79" name="Shape 0"/>
           <p:cNvSpPr/>
           <p:nvPr/>
         </p:nvSpPr>
@@ -6409,7 +6423,7 @@
       </p:sp>
       <p:sp>
         <p:nvSpPr>
-          <p:cNvPr id="78" name="Text 1"/>
+          <p:cNvPr id="80" name="Text 1"/>
           <p:cNvSpPr/>
           <p:nvPr/>
         </p:nvSpPr>
@@ -6469,7 +6483,7 @@
       </p:sp>
       <p:sp>
         <p:nvSpPr>
-          <p:cNvPr id="79" name="Text 2"/>
+          <p:cNvPr id="81" name="Text 2"/>
           <p:cNvSpPr/>
           <p:nvPr/>
         </p:nvSpPr>
@@ -6529,7 +6543,7 @@
       </p:sp>
       <p:sp>
         <p:nvSpPr>
-          <p:cNvPr id="80" name="Text 3"/>
+          <p:cNvPr id="82" name="Text 3"/>
           <p:cNvSpPr/>
           <p:nvPr/>
         </p:nvSpPr>
@@ -6589,7 +6603,7 @@
       </p:sp>
       <p:sp>
         <p:nvSpPr>
-          <p:cNvPr id="81" name="Text 4"/>
+          <p:cNvPr id="83" name="Text 4"/>
           <p:cNvSpPr/>
           <p:nvPr/>
         </p:nvSpPr>
@@ -6649,7 +6663,7 @@
       </p:sp>
       <p:sp>
         <p:nvSpPr>
-          <p:cNvPr id="82" name="Text 5"/>
+          <p:cNvPr id="84" name="Text 5"/>
           <p:cNvSpPr/>
           <p:nvPr/>
         </p:nvSpPr>
@@ -6709,7 +6723,7 @@
       </p:sp>
       <p:sp>
         <p:nvSpPr>
-          <p:cNvPr id="83" name="Shape 6"/>
+          <p:cNvPr id="85" name="Shape 6"/>
           <p:cNvSpPr/>
           <p:nvPr/>
         </p:nvSpPr>
@@ -6757,7 +6771,7 @@
       </p:sp>
       <p:sp>
         <p:nvSpPr>
-          <p:cNvPr id="84" name="Text 7"/>
+          <p:cNvPr id="86" name="Text 7"/>
           <p:cNvSpPr/>
           <p:nvPr/>
         </p:nvSpPr>
@@ -6817,7 +6831,7 @@
       </p:sp>
       <p:sp>
         <p:nvSpPr>
-          <p:cNvPr id="85" name="Text 8"/>
+          <p:cNvPr id="87" name="Text 8"/>
           <p:cNvSpPr/>
           <p:nvPr/>
         </p:nvSpPr>
@@ -6842,7 +6856,7 @@
         </p:style>
         <p:txBody>
           <a:bodyPr lIns="0" tIns="0" rIns="0" bIns="0" anchor="ctr">
-            <a:normAutofit fontScale="77500" lnSpcReduction="19999"/>
+            <a:normAutofit fontScale="92500" lnSpcReduction="9999"/>
           </a:bodyPr>
           <a:p>
             <a:pPr defTabSz="914400">
@@ -6862,7 +6876,7 @@
                 <a:uFillTx/>
                 <a:latin typeface="Arial"/>
               </a:rPr>
-              <a:t>Giao diện 14 trang (MPA), SCSS module hóa, responsive chuẩn Mobile/PC</a:t>
+              <a:t>14 trang MPA, SCSS module hóa, responsive Mobile &amp; PC.</a:t>
             </a:r>
             <a:endParaRPr lang="en-US" sz="900" b="0" u="none" strike="noStrike">
               <a:solidFill>
@@ -6877,7 +6891,7 @@
       </p:sp>
       <p:sp>
         <p:nvSpPr>
-          <p:cNvPr id="86" name="Shape 9"/>
+          <p:cNvPr id="88" name="Shape 9"/>
           <p:cNvSpPr/>
           <p:nvPr/>
         </p:nvSpPr>
@@ -6925,7 +6939,7 @@
       </p:sp>
       <p:sp>
         <p:nvSpPr>
-          <p:cNvPr id="87" name="Text 10"/>
+          <p:cNvPr id="89" name="Text 10"/>
           <p:cNvSpPr/>
           <p:nvPr/>
         </p:nvSpPr>
@@ -6985,7 +6999,7 @@
       </p:sp>
       <p:sp>
         <p:nvSpPr>
-          <p:cNvPr id="88" name="Text 11"/>
+          <p:cNvPr id="90" name="Text 11"/>
           <p:cNvSpPr/>
           <p:nvPr/>
         </p:nvSpPr>
@@ -7010,7 +7024,7 @@
         </p:style>
         <p:txBody>
           <a:bodyPr lIns="0" tIns="0" rIns="0" bIns="0" anchor="ctr">
-            <a:normAutofit fontScale="70000" lnSpcReduction="19999"/>
+            <a:normAutofit fontScale="92500" lnSpcReduction="9999"/>
           </a:bodyPr>
           <a:p>
             <a:pPr defTabSz="914400">
@@ -7030,7 +7044,7 @@
                 <a:uFillTx/>
                 <a:latin typeface="Arial"/>
               </a:rPr>
-              <a:t>Logic thuần không phụ thuộc framework, xử lý luồng đặt vé cực mượt, runtime Bun siêu tốc</a:t>
+              <a:t>Logic thuần mượt mà, không phụ thuộc framework, runtime Bun.</a:t>
             </a:r>
             <a:endParaRPr lang="en-US" sz="900" b="0" u="none" strike="noStrike">
               <a:solidFill>
@@ -7045,7 +7059,7 @@
       </p:sp>
       <p:sp>
         <p:nvSpPr>
-          <p:cNvPr id="89" name="Shape 12"/>
+          <p:cNvPr id="91" name="Shape 12"/>
           <p:cNvSpPr/>
           <p:nvPr/>
         </p:nvSpPr>
@@ -7093,7 +7107,7 @@
       </p:sp>
       <p:sp>
         <p:nvSpPr>
-          <p:cNvPr id="90" name="Text 13"/>
+          <p:cNvPr id="92" name="Text 13"/>
           <p:cNvSpPr/>
           <p:nvPr/>
         </p:nvSpPr>
@@ -7153,7 +7167,7 @@
       </p:sp>
       <p:sp>
         <p:nvSpPr>
-          <p:cNvPr id="91" name="Text 14"/>
+          <p:cNvPr id="93" name="Text 14"/>
           <p:cNvSpPr/>
           <p:nvPr/>
         </p:nvSpPr>
@@ -7198,7 +7212,7 @@
                 <a:uFillTx/>
                 <a:latin typeface="Arial"/>
               </a:rPr>
-              <a:t>REST API: movies, showtimes, cinemas, concessions, vouchers, bookings</a:t>
+              <a:t>REST API CRUD: movies, showtimes, cinemas, concessions, bookings.</a:t>
             </a:r>
             <a:endParaRPr lang="en-US" sz="900" b="0" u="none" strike="noStrike">
               <a:solidFill>
@@ -7213,7 +7227,7 @@
       </p:sp>
       <p:sp>
         <p:nvSpPr>
-          <p:cNvPr id="92" name="Shape 15"/>
+          <p:cNvPr id="94" name="Shape 15"/>
           <p:cNvSpPr/>
           <p:nvPr/>
         </p:nvSpPr>
@@ -7261,7 +7275,7 @@
       </p:sp>
       <p:sp>
         <p:nvSpPr>
-          <p:cNvPr id="93" name="Text 16"/>
+          <p:cNvPr id="95" name="Text 16"/>
           <p:cNvSpPr/>
           <p:nvPr/>
         </p:nvSpPr>
@@ -7321,7 +7335,7 @@
       </p:sp>
       <p:sp>
         <p:nvSpPr>
-          <p:cNvPr id="94" name="Text 17"/>
+          <p:cNvPr id="96" name="Text 17"/>
           <p:cNvSpPr/>
           <p:nvPr/>
         </p:nvSpPr>
@@ -7346,7 +7360,7 @@
         </p:style>
         <p:txBody>
           <a:bodyPr lIns="0" tIns="0" rIns="0" bIns="0" anchor="ctr">
-            <a:normAutofit fontScale="77500" lnSpcReduction="19999"/>
+            <a:normAutofit fontScale="92500" lnSpcReduction="9999"/>
           </a:bodyPr>
           <a:p>
             <a:pPr defTabSz="914400">
@@ -7366,7 +7380,7 @@
                 <a:uFillTx/>
                 <a:latin typeface="Arial"/>
               </a:rPr>
-              <a:t>Auth JWT token, mã hóa bcrypt, đăng nhập Email/SĐT, phân quyền User/Admin</a:t>
+              <a:t>JWT Token, mã hóa bcrypt, đăng nhập Email/SĐT, phân quyền.</a:t>
             </a:r>
             <a:endParaRPr lang="en-US" sz="900" b="0" u="none" strike="noStrike">
               <a:solidFill>
@@ -7381,7 +7395,7 @@
       </p:sp>
       <p:sp>
         <p:nvSpPr>
-          <p:cNvPr id="95" name="Text 20"/>
+          <p:cNvPr id="97" name="Text 20"/>
           <p:cNvSpPr/>
           <p:nvPr/>
         </p:nvSpPr>
@@ -7441,14 +7455,14 @@
       </p:sp>
       <p:sp>
         <p:nvSpPr>
-          <p:cNvPr id="96" name="Text 18"/>
+          <p:cNvPr id="98" name="Text 18"/>
           <p:cNvSpPr/>
           <p:nvPr/>
         </p:nvSpPr>
         <p:spPr>
           <a:xfrm>
             <a:off x="5074920" y="2807280"/>
-            <a:ext cx="6263280" cy="648000"/>
+            <a:ext cx="6263280" cy="540000"/>
           </a:xfrm>
           <a:noFill/>
           <a:ln w="0">
@@ -7463,7 +7477,7 @@
         </p:style>
         <p:txBody>
           <a:bodyPr lIns="0" tIns="0" rIns="0" bIns="0" anchor="ctr">
-            <a:normAutofit fontScale="85000" lnSpcReduction="19999"/>
+            <a:normAutofit fontScale="85000" lnSpcReduction="9999"/>
           </a:bodyPr>
           <a:p>
             <a:pPr defTabSz="914400">
@@ -7483,7 +7497,7 @@
                 <a:uFillTx/>
                 <a:latin typeface="Arial"/>
               </a:rPr>
-              <a:t>• Khách hàng: Home · movies · movie-detail · schedule · cinemas · pricing · news · booking · checkout · member · profile.</a:t>
+              <a:t>• Khách hàng: Home · movies · detail · schedule · cinemas · pricing · news · booking · checkout · member · profile.</a:t>
             </a:r>
             <a:endParaRPr lang="en-US" sz="1500" b="0" u="none" strike="noStrike">
               <a:solidFill>
@@ -7512,7 +7526,7 @@
                 <a:uFillTx/>
                 <a:latin typeface="Arial"/>
               </a:rPr>
-              <a:t>• Quản trị &amp; Tiện ích: admin (Cổng quản lý &amp; Soát vé) · 404 (Not Found) · error (Error Handler).</a:t>
+              <a:t>• Quản trị &amp; Tiện ích: admin (Dashboard &amp; Soát vé QR) · 404 · error.</a:t>
             </a:r>
             <a:endParaRPr lang="en-US" sz="1500" b="0" u="none" strike="noStrike">
               <a:solidFill>
@@ -7527,7 +7541,7 @@
       </p:sp>
       <p:sp>
         <p:nvSpPr>
-          <p:cNvPr id="97" name="Shape 22"/>
+          <p:cNvPr id="99" name="Shape 22"/>
           <p:cNvSpPr/>
           <p:nvPr/>
         </p:nvSpPr>
@@ -7570,7 +7584,7 @@
       </p:sp>
       <p:sp>
         <p:nvSpPr>
-          <p:cNvPr id="98" name="Text 23"/>
+          <p:cNvPr id="100" name="Text 23"/>
           <p:cNvSpPr/>
           <p:nvPr/>
         </p:nvSpPr>
@@ -7630,14 +7644,14 @@
       </p:sp>
       <p:sp>
         <p:nvSpPr>
-          <p:cNvPr id="99" name="Text 20"/>
+          <p:cNvPr id="101" name="Text 20"/>
           <p:cNvSpPr/>
           <p:nvPr/>
         </p:nvSpPr>
         <p:spPr>
           <a:xfrm>
             <a:off x="5074920" y="3840480"/>
-            <a:ext cx="6263280" cy="648000"/>
+            <a:ext cx="6263280" cy="540000"/>
           </a:xfrm>
           <a:noFill/>
           <a:ln w="0">
@@ -7652,7 +7666,7 @@
         </p:style>
         <p:txBody>
           <a:bodyPr lIns="0" tIns="0" rIns="0" bIns="0" anchor="ctr">
-            <a:normAutofit fontScale="85000" lnSpcReduction="19999"/>
+            <a:normAutofit fontScale="77500" lnSpcReduction="19999"/>
           </a:bodyPr>
           <a:p>
             <a:pPr defTabSz="914400">
@@ -7701,7 +7715,7 @@
                 <a:uFillTx/>
                 <a:latin typeface="Arial"/>
               </a:rPr>
-              <a:t>• Endpoints: GET/POST/PATCH/DELETE kết hợp lớp api.js và storage.js đồng bộ client &amp; serverless.</a:t>
+              <a:t>• Đồng bộ: api.js + storage.js đa tầng (REST API json-server + LocalStorage fallback).</a:t>
             </a:r>
             <a:endParaRPr lang="en-US" sz="1500" b="0" u="none" strike="noStrike">
               <a:solidFill>
@@ -7716,7 +7730,7 @@
       </p:sp>
       <p:sp>
         <p:nvSpPr>
-          <p:cNvPr id="100" name="Shape 25"/>
+          <p:cNvPr id="102" name="Shape 25"/>
           <p:cNvSpPr/>
           <p:nvPr/>
         </p:nvSpPr>
@@ -7759,7 +7773,7 @@
       </p:sp>
       <p:sp>
         <p:nvSpPr>
-          <p:cNvPr id="101" name="Text 26"/>
+          <p:cNvPr id="103" name="Text 26"/>
           <p:cNvSpPr/>
           <p:nvPr/>
         </p:nvSpPr>
@@ -7819,14 +7833,14 @@
       </p:sp>
       <p:sp>
         <p:nvSpPr>
-          <p:cNvPr id="102" name="Text 22"/>
+          <p:cNvPr id="104" name="Text 22"/>
           <p:cNvSpPr/>
           <p:nvPr/>
         </p:nvSpPr>
         <p:spPr>
           <a:xfrm>
             <a:off x="5074920" y="4873680"/>
-            <a:ext cx="6263280" cy="648000"/>
+            <a:ext cx="3528000" cy="1008000"/>
           </a:xfrm>
           <a:noFill/>
           <a:ln w="0">
@@ -7841,7 +7855,7 @@
         </p:style>
         <p:txBody>
           <a:bodyPr lIns="0" tIns="0" rIns="0" bIns="0" anchor="ctr">
-            <a:normAutofit fontScale="85000" lnSpcReduction="19999"/>
+            <a:normAutofit/>
           </a:bodyPr>
           <a:p>
             <a:pPr defTabSz="914400">
@@ -7861,7 +7875,7 @@
                 <a:uFillTx/>
                 <a:latin typeface="Arial"/>
               </a:rPr>
-              <a:t>• Phân quyền tài khoản (User / Admin) bảo vệ bởi Auth Gate và JWT Token an toàn.</a:t>
+              <a:t>• Phân quyền tài khoản User / Admin với JWT token.</a:t>
             </a:r>
             <a:endParaRPr lang="en-US" sz="1500" b="0" u="none" strike="noStrike">
               <a:solidFill>
@@ -7890,7 +7904,7 @@
                 <a:uFillTx/>
                 <a:latin typeface="Arial"/>
               </a:rPr>
-              <a:t>• Cổng Admin: Dashboard giám sát doanh thu &amp; đơn vé, công cụ Soát vé QR trực tiếp bằng camera/mã vé.</a:t>
+              <a:t>• Dashboard KPI doanh thu &amp; công cụ Soát vé QR tức thì.</a:t>
             </a:r>
             <a:endParaRPr lang="en-US" sz="1500" b="0" u="none" strike="noStrike">
               <a:solidFill>
@@ -7905,7 +7919,7 @@
       </p:sp>
       <p:sp>
         <p:nvSpPr>
-          <p:cNvPr id="103" name="Shape 28"/>
+          <p:cNvPr id="105" name="Shape 28"/>
           <p:cNvSpPr/>
           <p:nvPr/>
         </p:nvSpPr>
@@ -7946,6 +7960,83 @@
           </a:p>
         </p:txBody>
       </p:sp>
+      <p:sp>
+        <p:nvSpPr>
+          <p:cNvPr id="106" name="CardPreviewAdmin"/>
+          <p:cNvSpPr/>
+          <p:nvPr/>
+        </p:nvSpPr>
+        <p:spPr>
+          <a:xfrm>
+            <a:off x="8712000" y="4500000"/>
+            <a:ext cx="2664000" cy="1584000"/>
+          </a:xfrm>
+          <a:prstGeom prst="roundRect">
+            <a:avLst>
+              <a:gd name="adj" fmla="val 5634"/>
+            </a:avLst>
+          </a:prstGeom>
+          <a:solidFill>
+            <a:srgbClr val="FFFFFF"/>
+          </a:solidFill>
+          <a:ln w="12600">
+            <a:solidFill>
+              <a:srgbClr val="E8E6E2"/>
+            </a:solidFill>
+            <a:round/>
+          </a:ln>
+        </p:spPr>
+        <p:style>
+          <a:lnRef idx="0"/>
+          <a:fillRef idx="0"/>
+          <a:effectRef idx="0"/>
+          <a:fontRef idx="minor"/>
+        </p:style>
+        <p:txBody>
+          <a:bodyPr lIns="90000" tIns="45000" rIns="90000" bIns="45000" anchor="t">
+            <a:noAutofit/>
+          </a:bodyPr>
+          <a:p>
+            <a:endParaRPr lang="en-US" sz="1800" b="0" u="none" strike="noStrike">
+              <a:solidFill>
+                <a:srgbClr val="000000"/>
+              </a:solidFill>
+              <a:effectLst/>
+              <a:uFillTx/>
+              <a:latin typeface="Arial"/>
+            </a:endParaRPr>
+          </a:p>
+        </p:txBody>
+      </p:sp>
+      <p:pic>
+        <p:nvPicPr>
+          <p:cNvPr id="107" name="PreviewAdmin"/>
+          <p:cNvPicPr/>
+          <p:nvPr/>
+        </p:nvPicPr>
+        <p:blipFill>
+          <a:blip r:embed="rId1"/>
+          <a:stretch/>
+        </p:blipFill>
+        <p:spPr>
+          <a:xfrm>
+            <a:off x="8766000" y="4554000"/>
+            <a:ext cx="2556000" cy="1476000"/>
+          </a:xfrm>
+          <a:prstGeom prst="rect">
+            <a:avLst/>
+          </a:prstGeom>
+          <a:solidFill>
+            <a:srgbClr val="FFFFFF"/>
+          </a:solidFill>
+          <a:ln w="12600">
+            <a:solidFill>
+              <a:srgbClr val="E8E6E2"/>
+            </a:solidFill>
+            <a:round/>
+          </a:ln>
+        </p:spPr>
+      </p:pic>
     </p:spTree>
   </p:cSld>
   <mc:AlternateContent>
@@ -7985,7 +8076,7 @@
       </p:grpSpPr>
       <p:sp>
         <p:nvSpPr>
-          <p:cNvPr id="104" name="Shape 0"/>
+          <p:cNvPr id="108" name="Shape 0"/>
           <p:cNvSpPr/>
           <p:nvPr/>
         </p:nvSpPr>
@@ -8033,7 +8124,7 @@
       </p:sp>
       <p:sp>
         <p:nvSpPr>
-          <p:cNvPr id="105" name="Text 1"/>
+          <p:cNvPr id="109" name="Text 1"/>
           <p:cNvSpPr/>
           <p:nvPr/>
         </p:nvSpPr>
@@ -8093,7 +8184,7 @@
       </p:sp>
       <p:sp>
         <p:nvSpPr>
-          <p:cNvPr id="106" name="Text 2"/>
+          <p:cNvPr id="110" name="Text 2"/>
           <p:cNvSpPr/>
           <p:nvPr/>
         </p:nvSpPr>
@@ -8153,7 +8244,7 @@
       </p:sp>
       <p:sp>
         <p:nvSpPr>
-          <p:cNvPr id="107" name="Text 3"/>
+          <p:cNvPr id="111" name="Text 3"/>
           <p:cNvSpPr/>
           <p:nvPr/>
         </p:nvSpPr>
@@ -8213,7 +8304,7 @@
       </p:sp>
       <p:sp>
         <p:nvSpPr>
-          <p:cNvPr id="108" name="Text 4"/>
+          <p:cNvPr id="112" name="Text 4"/>
           <p:cNvSpPr/>
           <p:nvPr/>
         </p:nvSpPr>
@@ -8273,7 +8364,7 @@
       </p:sp>
       <p:sp>
         <p:nvSpPr>
-          <p:cNvPr id="109" name="Text 5"/>
+          <p:cNvPr id="113" name="Text 5"/>
           <p:cNvSpPr/>
           <p:nvPr/>
         </p:nvSpPr>
@@ -8333,7 +8424,7 @@
       </p:sp>
       <p:sp>
         <p:nvSpPr>
-          <p:cNvPr id="110" name="Shape 6"/>
+          <p:cNvPr id="114" name="Shape 6"/>
           <p:cNvSpPr/>
           <p:nvPr/>
         </p:nvSpPr>
@@ -8381,7 +8472,7 @@
       </p:sp>
       <p:sp>
         <p:nvSpPr>
-          <p:cNvPr id="111" name="Text 7"/>
+          <p:cNvPr id="115" name="Text 7"/>
           <p:cNvSpPr/>
           <p:nvPr/>
         </p:nvSpPr>
@@ -8441,7 +8532,7 @@
       </p:sp>
       <p:sp>
         <p:nvSpPr>
-          <p:cNvPr id="112" name="Text 8"/>
+          <p:cNvPr id="116" name="Text 8"/>
           <p:cNvSpPr/>
           <p:nvPr/>
         </p:nvSpPr>
@@ -8486,7 +8577,7 @@
                 <a:uFillTx/>
                 <a:latin typeface="Arial"/>
               </a:rPr>
-              <a:t>Khám phá &amp; Chọn suất: Duyệt phim Đang chiếu tại Trang chủ/Phim, xem trailer YouTube modal, chọn cụm rạp và suất chiếu.</a:t>
+              <a:t>Khám phá &amp; Chọn suất: Xem phim đang chiếu, mở trailer YouTube, chọn rạp và suất chiếu.</a:t>
             </a:r>
             <a:endParaRPr lang="en-US" sz="1300" b="0" u="none" strike="noStrike">
               <a:solidFill>
@@ -8501,7 +8592,7 @@
       </p:sp>
       <p:sp>
         <p:nvSpPr>
-          <p:cNvPr id="113" name="Shape 9"/>
+          <p:cNvPr id="117" name="Shape 9"/>
           <p:cNvSpPr/>
           <p:nvPr/>
         </p:nvSpPr>
@@ -8549,7 +8640,7 @@
       </p:sp>
       <p:sp>
         <p:nvSpPr>
-          <p:cNvPr id="114" name="Text 10"/>
+          <p:cNvPr id="118" name="Text 10"/>
           <p:cNvSpPr/>
           <p:nvPr/>
         </p:nvSpPr>
@@ -8609,7 +8700,7 @@
       </p:sp>
       <p:sp>
         <p:nvSpPr>
-          <p:cNvPr id="115" name="Text 11"/>
+          <p:cNvPr id="119" name="Text 11"/>
           <p:cNvSpPr/>
           <p:nvPr/>
         </p:nvSpPr>
@@ -8654,7 +8745,7 @@
                 <a:uFillTx/>
                 <a:latin typeface="Arial"/>
               </a:rPr>
-              <a:t>Chọn ghế &amp; Giữ chỗ 5 phút: Chọn ghế Standard/VIP/Sweetbox trên sơ đồ 164 chỗ; kích hoạt đồng hồ đếm ngược 5 phút chống đặt trùng.</a:t>
+              <a:t>Chọn ghế &amp; Giữ chỗ 5p: Chọn ghế trên sơ đồ 164 chỗ; kích hoạt đếm ngược 5 phút chống trùng.</a:t>
             </a:r>
             <a:endParaRPr lang="en-US" sz="1300" b="0" u="none" strike="noStrike">
               <a:solidFill>
@@ -8669,7 +8760,7 @@
       </p:sp>
       <p:sp>
         <p:nvSpPr>
-          <p:cNvPr id="116" name="Shape 12"/>
+          <p:cNvPr id="120" name="Shape 12"/>
           <p:cNvSpPr/>
           <p:nvPr/>
         </p:nvSpPr>
@@ -8717,7 +8808,7 @@
       </p:sp>
       <p:sp>
         <p:nvSpPr>
-          <p:cNvPr id="117" name="Text 13"/>
+          <p:cNvPr id="121" name="Text 13"/>
           <p:cNvSpPr/>
           <p:nvPr/>
         </p:nvSpPr>
@@ -8777,7 +8868,7 @@
       </p:sp>
       <p:sp>
         <p:nvSpPr>
-          <p:cNvPr id="118" name="Text 14"/>
+          <p:cNvPr id="122" name="Text 14"/>
           <p:cNvSpPr/>
           <p:nvPr/>
         </p:nvSpPr>
@@ -8822,7 +8913,7 @@
                 <a:uFillTx/>
                 <a:latin typeface="Arial"/>
               </a:rPr>
-              <a:t>Thêm combo bắp nước &amp; Áp Voucher: Chọn combo bắp nước, áp mã ưu đãi (BETA10/BETA50/SV20); tự động kiểm tra điều kiện &amp; chiết khấu.</a:t>
+              <a:t>Bắp nước &amp; Áp Voucher: Chọn combo bắp nước, áp mã (BETA10/BETA50/SV20) tự động chiết khấu.</a:t>
             </a:r>
             <a:endParaRPr lang="en-US" sz="1300" b="0" u="none" strike="noStrike">
               <a:solidFill>
@@ -8837,7 +8928,7 @@
       </p:sp>
       <p:sp>
         <p:nvSpPr>
-          <p:cNvPr id="119" name="Shape 15"/>
+          <p:cNvPr id="123" name="Shape 15"/>
           <p:cNvSpPr/>
           <p:nvPr/>
         </p:nvSpPr>
@@ -8885,7 +8976,7 @@
       </p:sp>
       <p:sp>
         <p:nvSpPr>
-          <p:cNvPr id="120" name="Text 16"/>
+          <p:cNvPr id="124" name="Text 16"/>
           <p:cNvSpPr/>
           <p:nvPr/>
         </p:nvSpPr>
@@ -8945,7 +9036,7 @@
       </p:sp>
       <p:sp>
         <p:nvSpPr>
-          <p:cNvPr id="121" name="Text 17"/>
+          <p:cNvPr id="125" name="Text 17"/>
           <p:cNvSpPr/>
           <p:nvPr/>
         </p:nvSpPr>
@@ -8990,7 +9081,7 @@
                 <a:uFillTx/>
                 <a:latin typeface="Arial"/>
               </a:rPr>
-              <a:t>Xác nhận &amp; Xuất vé QR: Điền thông tin, thanh toán mô phỏng thành công; nhận ngay Vé điện tử tích hợp mã QR Code check-in.</a:t>
+              <a:t>Thanh toán &amp; Xuất vé QR: Xác nhận thanh toán mô phỏng; sinh ngay Vé điện tử có mã QR check-in.</a:t>
             </a:r>
             <a:endParaRPr lang="en-US" sz="1300" b="0" u="none" strike="noStrike">
               <a:solidFill>
@@ -9005,7 +9096,7 @@
       </p:sp>
       <p:sp>
         <p:nvSpPr>
-          <p:cNvPr id="122" name="Text 18"/>
+          <p:cNvPr id="126" name="Text 18"/>
           <p:cNvSpPr/>
           <p:nvPr/>
         </p:nvSpPr>
@@ -9065,7 +9156,7 @@
       </p:sp>
       <p:sp>
         <p:nvSpPr>
-          <p:cNvPr id="123" name="Text 19"/>
+          <p:cNvPr id="127" name="Text 19"/>
           <p:cNvSpPr/>
           <p:nvPr/>
         </p:nvSpPr>
@@ -9125,14 +9216,14 @@
       </p:sp>
       <p:sp>
         <p:nvSpPr>
-          <p:cNvPr id="124" name="Card Demo Right"/>
-          <p:cNvSpPr/>
-          <p:nvPr/>
-        </p:nvSpPr>
-        <p:spPr>
-          <a:xfrm>
-            <a:off x="7560000" y="3852000"/>
-            <a:ext cx="3960000" cy="1980000"/>
+          <p:cNvPr id="128" name="Card Demo Right"/>
+          <p:cNvSpPr/>
+          <p:nvPr/>
+        </p:nvSpPr>
+        <p:spPr>
+          <a:xfrm>
+            <a:off x="7560000" y="3384000"/>
+            <a:ext cx="4104000" cy="2340000"/>
           </a:xfrm>
           <a:prstGeom prst="roundRect">
             <a:avLst>
@@ -9171,17 +9262,49 @@
           </a:p>
         </p:txBody>
       </p:sp>
-      <p:sp>
-        <p:nvSpPr>
-          <p:cNvPr id="125" name="Text 31"/>
-          <p:cNvSpPr/>
-          <p:nvPr/>
-        </p:nvSpPr>
-        <p:spPr>
-          <a:xfrm>
-            <a:off x="7704000" y="3924000"/>
-            <a:ext cx="3672000" cy="1800000"/>
-          </a:xfrm>
+      <p:pic>
+        <p:nvPicPr>
+          <p:cNvPr id="129" name="PreviewBooking"/>
+          <p:cNvPicPr/>
+          <p:nvPr/>
+        </p:nvPicPr>
+        <p:blipFill>
+          <a:blip r:embed="rId1"/>
+          <a:stretch/>
+        </p:blipFill>
+        <p:spPr>
+          <a:xfrm>
+            <a:off x="7632000" y="3438000"/>
+            <a:ext cx="3960000" cy="2232000"/>
+          </a:xfrm>
+          <a:prstGeom prst="rect">
+            <a:avLst/>
+          </a:prstGeom>
+          <a:solidFill>
+            <a:srgbClr val="FFFFFF"/>
+          </a:solidFill>
+          <a:ln w="12600">
+            <a:solidFill>
+              <a:srgbClr val="E8E6E2"/>
+            </a:solidFill>
+            <a:round/>
+          </a:ln>
+        </p:spPr>
+      </p:pic>
+      <p:sp>
+        <p:nvSpPr>
+          <p:cNvPr id="130" name="CaptionBooking"/>
+          <p:cNvSpPr/>
+          <p:nvPr/>
+        </p:nvSpPr>
+        <p:spPr>
+          <a:xfrm>
+            <a:off x="7560000" y="5760000"/>
+            <a:ext cx="4104000" cy="324000"/>
+          </a:xfrm>
+          <a:prstGeom prst="rect">
+            <a:avLst/>
+          </a:prstGeom>
           <a:noFill/>
           <a:ln w="0">
             <a:noFill/>
@@ -9195,7 +9318,7 @@
         </p:style>
         <p:txBody>
           <a:bodyPr lIns="0" tIns="0" rIns="0" bIns="0" anchor="ctr">
-            <a:normAutofit/>
+            <a:normAutofit lnSpcReduction="9999"/>
           </a:bodyPr>
           <a:p>
             <a:pPr defTabSz="914400">
@@ -9215,9 +9338,20 @@
                 <a:uFillTx/>
                 <a:latin typeface="Arial"/>
               </a:rPr>
-              <a:t>CHỨC NĂNG NỔI BẬT DEMO THÊM:</a:t>
-            </a:r>
-            <a:endParaRPr lang="en-US" sz="900" b="0" u="none" strike="noStrike">
+              <a:t>HAPPY PATH: </a:t>
+            </a:r>
+            <a:r>
+              <a:rPr lang="en-US" sz="1050" b="0" u="none" strike="noStrike">
+                <a:solidFill>
+                  <a:srgbClr val="171923"/>
+                </a:solidFill>
+                <a:effectLst/>
+                <a:uFillTx/>
+                <a:latin typeface="Arial"/>
+              </a:rPr>
+              <a:t>Sơ đồ 164 ghế thực tế &amp; Giữ chỗ 5 phút</a:t>
+            </a:r>
+            <a:endParaRPr lang="en-US" sz="1050" b="0" u="none" strike="noStrike">
               <a:solidFill>
                 <a:srgbClr val="000000"/>
               </a:solidFill>
@@ -9236,6 +9370,17 @@
               </a:tabLst>
             </a:pPr>
             <a:r>
+              <a:rPr lang="en-US" sz="1300" b="1" u="none" strike="noStrike">
+                <a:solidFill>
+                  <a:srgbClr val="E51D2A"/>
+                </a:solidFill>
+                <a:effectLst/>
+                <a:uFillTx/>
+                <a:latin typeface="Arial"/>
+              </a:rPr>
+              <a:t>• </a:t>
+            </a:r>
+            <a:r>
               <a:rPr lang="en-US" sz="900" b="0" u="none" strike="noStrike">
                 <a:solidFill>
                   <a:srgbClr val="747985"/>
@@ -9244,141 +9389,7 @@
                 <a:uFillTx/>
                 <a:latin typeface="Arial"/>
               </a:rPr>
-              <a:t>• Trang Thành Viên: Trải nghiệm thẻ 3D interactive, xem điểm thưởng tích lũy và đổi voucher trực tiếp.</a:t>
-            </a:r>
-            <a:endParaRPr lang="en-US" sz="900" b="0" u="none" strike="noStrike">
-              <a:solidFill>
-                <a:srgbClr val="000000"/>
-              </a:solidFill>
-              <a:effectLst/>
-              <a:uFillTx/>
-              <a:latin typeface="Arial"/>
-            </a:endParaRPr>
-          </a:p>
-          <a:p>
-            <a:pPr defTabSz="914400">
-              <a:lnSpc>
-                <a:spcPct val="100000"/>
-              </a:lnSpc>
-              <a:tabLst>
-                <a:tab pos="0" algn="l"/>
-              </a:tabLst>
-            </a:pPr>
-            <a:r>
-              <a:rPr lang="en-US" sz="900" b="0" u="none" strike="noStrike">
-                <a:solidFill>
-                  <a:srgbClr val="747985"/>
-                </a:solidFill>
-                <a:effectLst/>
-                <a:uFillTx/>
-                <a:latin typeface="Arial"/>
-              </a:rPr>
-              <a:t>• Cổng Admin: Đăng nhập quản trị, xem Dashboard KPI doanh thu và quét mã QR vé vừa tạo để xác nhận Check-in.</a:t>
-            </a:r>
-            <a:endParaRPr lang="en-US" sz="900" b="0" u="none" strike="noStrike">
-              <a:solidFill>
-                <a:srgbClr val="000000"/>
-              </a:solidFill>
-              <a:effectLst/>
-              <a:uFillTx/>
-              <a:latin typeface="Arial"/>
-            </a:endParaRPr>
-          </a:p>
-          <a:p>
-            <a:pPr defTabSz="914400">
-              <a:lnSpc>
-                <a:spcPct val="100000"/>
-              </a:lnSpc>
-              <a:tabLst>
-                <a:tab pos="0" algn="l"/>
-              </a:tabLst>
-            </a:pPr>
-            <a:endParaRPr lang="en-US" sz="1800" b="0" u="none" strike="noStrike">
-              <a:solidFill>
-                <a:srgbClr val="000000"/>
-              </a:solidFill>
-              <a:effectLst/>
-              <a:uFillTx/>
-              <a:latin typeface="Arial"/>
-            </a:endParaRPr>
-          </a:p>
-          <a:p>
-            <a:pPr defTabSz="914400">
-              <a:lnSpc>
-                <a:spcPct val="100000"/>
-              </a:lnSpc>
-              <a:tabLst>
-                <a:tab pos="0" algn="l"/>
-              </a:tabLst>
-            </a:pPr>
-            <a:r>
-              <a:rPr lang="en-US" sz="900" b="1" u="none" spc="99" strike="noStrike">
-                <a:solidFill>
-                  <a:srgbClr val="E51D2A"/>
-                </a:solidFill>
-                <a:effectLst/>
-                <a:uFillTx/>
-                <a:latin typeface="Arial"/>
-              </a:rPr>
-              <a:t>CHỨNG MINH MVP THỰC SỰ CHẠY:</a:t>
-            </a:r>
-            <a:endParaRPr lang="en-US" sz="900" b="0" u="none" strike="noStrike">
-              <a:solidFill>
-                <a:srgbClr val="000000"/>
-              </a:solidFill>
-              <a:effectLst/>
-              <a:uFillTx/>
-              <a:latin typeface="Arial"/>
-            </a:endParaRPr>
-          </a:p>
-          <a:p>
-            <a:pPr defTabSz="914400">
-              <a:lnSpc>
-                <a:spcPct val="100000"/>
-              </a:lnSpc>
-              <a:tabLst>
-                <a:tab pos="0" algn="l"/>
-              </a:tabLst>
-            </a:pPr>
-            <a:r>
-              <a:rPr lang="en-US" sz="900" b="0" u="none" strike="noStrike">
-                <a:solidFill>
-                  <a:srgbClr val="747985"/>
-                </a:solidFill>
-                <a:effectLst/>
-                <a:uFillTx/>
-                <a:latin typeface="Arial"/>
-              </a:rPr>
-              <a:t>• 100% 56/56 automated test cases PASS (Auth, Booking, Timer 5p, Vouchers, Points, Error 400/404).</a:t>
-            </a:r>
-            <a:endParaRPr lang="en-US" sz="900" b="0" u="none" strike="noStrike">
-              <a:solidFill>
-                <a:srgbClr val="000000"/>
-              </a:solidFill>
-              <a:effectLst/>
-              <a:uFillTx/>
-              <a:latin typeface="Arial"/>
-            </a:endParaRPr>
-          </a:p>
-          <a:p>
-            <a:pPr defTabSz="914400">
-              <a:lnSpc>
-                <a:spcPct val="100000"/>
-              </a:lnSpc>
-              <a:tabLst>
-                <a:tab pos="0" algn="l"/>
-              </a:tabLst>
-            </a:pPr>
-            <a:r>
-              <a:rPr lang="en-US" sz="900" b="0" u="none" strike="noStrike">
-                <a:solidFill>
-                  <a:srgbClr val="747985"/>
-                </a:solidFill>
-                <a:effectLst/>
-                <a:uFillTx/>
-                <a:latin typeface="Arial"/>
-              </a:rPr>
-              <a:t>• Build MPA nhanh ~744ms, server Bun &amp; Vite chạy ổn định mượt mà.</a:t>
+              <a:t>Demo thêm: Thẻ thành viên 3D · Admin soát vé QR (56/56 Tests PASS)</a:t>
             </a:r>
             <a:endParaRPr lang="en-US" sz="900" b="0" u="none" strike="noStrike">
               <a:solidFill>
@@ -9430,7 +9441,7 @@
       </p:grpSpPr>
       <p:sp>
         <p:nvSpPr>
-          <p:cNvPr id="126" name="Shape 0"/>
+          <p:cNvPr id="131" name="Shape 0"/>
           <p:cNvSpPr/>
           <p:nvPr/>
         </p:nvSpPr>
@@ -9478,7 +9489,7 @@
       </p:sp>
       <p:sp>
         <p:nvSpPr>
-          <p:cNvPr id="127" name="Text 1"/>
+          <p:cNvPr id="132" name="Text 1"/>
           <p:cNvSpPr/>
           <p:nvPr/>
         </p:nvSpPr>
@@ -9538,7 +9549,7 @@
       </p:sp>
       <p:sp>
         <p:nvSpPr>
-          <p:cNvPr id="128" name="Text 2"/>
+          <p:cNvPr id="133" name="Text 2"/>
           <p:cNvSpPr/>
           <p:nvPr/>
         </p:nvSpPr>
@@ -9598,7 +9609,7 @@
       </p:sp>
       <p:sp>
         <p:nvSpPr>
-          <p:cNvPr id="129" name="Text 3"/>
+          <p:cNvPr id="134" name="Text 3"/>
           <p:cNvSpPr/>
           <p:nvPr/>
         </p:nvSpPr>
@@ -9658,7 +9669,7 @@
       </p:sp>
       <p:sp>
         <p:nvSpPr>
-          <p:cNvPr id="130" name="Text 4"/>
+          <p:cNvPr id="135" name="Text 4"/>
           <p:cNvSpPr/>
           <p:nvPr/>
         </p:nvSpPr>
@@ -9718,7 +9729,7 @@
       </p:sp>
       <p:sp>
         <p:nvSpPr>
-          <p:cNvPr id="131" name="Text 5"/>
+          <p:cNvPr id="136" name="Text 5"/>
           <p:cNvSpPr/>
           <p:nvPr/>
         </p:nvSpPr>
@@ -9778,7 +9789,7 @@
       </p:sp>
       <p:sp>
         <p:nvSpPr>
-          <p:cNvPr id="132" name="Shape 6"/>
+          <p:cNvPr id="137" name="Shape 6"/>
           <p:cNvSpPr/>
           <p:nvPr/>
         </p:nvSpPr>
@@ -9826,7 +9837,7 @@
       </p:sp>
       <p:sp>
         <p:nvSpPr>
-          <p:cNvPr id="133" name="Text 7"/>
+          <p:cNvPr id="138" name="Text 7"/>
           <p:cNvSpPr/>
           <p:nvPr/>
         </p:nvSpPr>
@@ -9886,7 +9897,7 @@
       </p:sp>
       <p:sp>
         <p:nvSpPr>
-          <p:cNvPr id="134" name="Text 8"/>
+          <p:cNvPr id="139" name="Text 8"/>
           <p:cNvSpPr/>
           <p:nvPr/>
         </p:nvSpPr>
@@ -9946,7 +9957,7 @@
       </p:sp>
       <p:sp>
         <p:nvSpPr>
-          <p:cNvPr id="135" name="Text 9"/>
+          <p:cNvPr id="140" name="Text 9"/>
           <p:cNvSpPr/>
           <p:nvPr/>
         </p:nvSpPr>
@@ -9991,7 +10002,7 @@
                 <a:uFillTx/>
                 <a:latin typeface="Arial"/>
               </a:rPr>
-              <a:t>Nguyễn Văn Trọng — Leader &amp; Architect: Thiết kế cấu trúc 14 trang MPA, Router &amp; REST API json-server, Bun runtime, tối ưu build &amp; Vercel deployment.</a:t>
+              <a:t>Nguyễn Văn Trọng — Leader &amp; Architect: Kiến trúc 14 trang MPA, Router &amp; REST API, Bun runtime, Vercel Serverless.</a:t>
             </a:r>
             <a:endParaRPr lang="en-US" sz="1100" b="0" u="none" strike="noStrike">
               <a:solidFill>
@@ -10006,7 +10017,7 @@
       </p:sp>
       <p:sp>
         <p:nvSpPr>
-          <p:cNvPr id="136" name="Text 10"/>
+          <p:cNvPr id="141" name="Text 10"/>
           <p:cNvSpPr/>
           <p:nvPr/>
         </p:nvSpPr>
@@ -10066,7 +10077,7 @@
       </p:sp>
       <p:sp>
         <p:nvSpPr>
-          <p:cNvPr id="137" name="Text 11"/>
+          <p:cNvPr id="142" name="Text 11"/>
           <p:cNvSpPr/>
           <p:nvPr/>
         </p:nvSpPr>
@@ -10111,7 +10122,7 @@
                 <a:uFillTx/>
                 <a:latin typeface="Arial"/>
               </a:rPr>
-              <a:t>Vũ Tiến Lập — Frontend &amp; QA Lead: Phát triển module Checkout, combo bắp nước, bảng giá vé (pricing), tin tức (news), Cụm rạp (cinemas), bộ kiểm thử tự động 56 use cases.</a:t>
+              <a:t>Vũ Tiến Lập — Frontend &amp; QA Lead: Module Checkout, bắp nước, Bảng giá vé, Tin tức, Cụm rạp, Bộ test 56/56.</a:t>
             </a:r>
             <a:endParaRPr lang="en-US" sz="1100" b="0" u="none" strike="noStrike">
               <a:solidFill>
@@ -10126,7 +10137,7 @@
       </p:sp>
       <p:sp>
         <p:nvSpPr>
-          <p:cNvPr id="138" name="Text 12"/>
+          <p:cNvPr id="143" name="Text 12"/>
           <p:cNvSpPr/>
           <p:nvPr/>
         </p:nvSpPr>
@@ -10186,7 +10197,7 @@
       </p:sp>
       <p:sp>
         <p:nvSpPr>
-          <p:cNvPr id="139" name="Text 13"/>
+          <p:cNvPr id="144" name="Text 13"/>
           <p:cNvSpPr/>
           <p:nvPr/>
         </p:nvSpPr>
@@ -10231,7 +10242,7 @@
                 <a:uFillTx/>
                 <a:latin typeface="Arial"/>
               </a:rPr>
-              <a:t>Phạm Anh Duy — Feature Lead &amp; Integrator: Sơ đồ 164 ghế &amp; đếm ngược giữ ghế 5 phút, hệ thống Voucher giảm giá, Trang Thành Viên thẻ 3D, Cổng Admin &amp; Soát vé QR.</a:t>
+              <a:t>Phạm Anh Duy — Feature Lead &amp; Integrator: Sơ đồ 164 ghế &amp; đếm ngược 5p, Hệ thống Voucher, Thẻ thành viên 3D, Cổng Admin QR.</a:t>
             </a:r>
             <a:endParaRPr lang="en-US" sz="1100" b="0" u="none" strike="noStrike">
               <a:solidFill>
@@ -10246,7 +10257,7 @@
       </p:sp>
       <p:sp>
         <p:nvSpPr>
-          <p:cNvPr id="140" name="Text 14"/>
+          <p:cNvPr id="145" name="Text 14"/>
           <p:cNvSpPr/>
           <p:nvPr/>
         </p:nvSpPr>
@@ -10306,7 +10317,7 @@
       </p:sp>
       <p:sp>
         <p:nvSpPr>
-          <p:cNvPr id="141" name="Text 15"/>
+          <p:cNvPr id="146" name="Text 15"/>
           <p:cNvSpPr/>
           <p:nvPr/>
         </p:nvSpPr>
@@ -10375,7 +10386,7 @@
       </p:sp>
       <p:sp>
         <p:nvSpPr>
-          <p:cNvPr id="142" name="Shape 16"/>
+          <p:cNvPr id="147" name="Shape 16"/>
           <p:cNvSpPr/>
           <p:nvPr/>
         </p:nvSpPr>
@@ -10423,7 +10434,7 @@
       </p:sp>
       <p:sp>
         <p:nvSpPr>
-          <p:cNvPr id="143" name="Text 17"/>
+          <p:cNvPr id="148" name="Text 17"/>
           <p:cNvSpPr/>
           <p:nvPr/>
         </p:nvSpPr>
@@ -10483,7 +10494,7 @@
       </p:sp>
       <p:sp>
         <p:nvSpPr>
-          <p:cNvPr id="144" name="Text 18"/>
+          <p:cNvPr id="149" name="Text 18"/>
           <p:cNvSpPr/>
           <p:nvPr/>
         </p:nvSpPr>
@@ -10543,7 +10554,7 @@
       </p:sp>
       <p:sp>
         <p:nvSpPr>
-          <p:cNvPr id="145" name="Text 19"/>
+          <p:cNvPr id="150" name="Text 19"/>
           <p:cNvSpPr/>
           <p:nvPr/>
         </p:nvSpPr>
@@ -10588,7 +10599,7 @@
                 <a:uFillTx/>
                 <a:latin typeface="Arial"/>
               </a:rPr>
-              <a:t>Khó khăn lớn nhất: Đồng bộ trạng thái giữ ghế thời gian thực (5-min hold) và dữ liệu đơn vé giữa REST API json-server, client LocalStorage và môi trường Serverless (Vercel read-only filesystem).</a:t>
+              <a:t>Khó khăn: Đồng bộ trạng thái giữ ghế thời gian thực giữa json-server, cache client và Vercel Serverless (read-only filesystem).</a:t>
             </a:r>
             <a:endParaRPr lang="en-US" sz="1100" b="0" u="none" strike="noStrike">
               <a:solidFill>
@@ -10603,7 +10614,7 @@
       </p:sp>
       <p:sp>
         <p:nvSpPr>
-          <p:cNvPr id="146" name="Text 20"/>
+          <p:cNvPr id="151" name="Text 20"/>
           <p:cNvSpPr/>
           <p:nvPr/>
         </p:nvSpPr>
@@ -10663,7 +10674,7 @@
       </p:sp>
       <p:sp>
         <p:nvSpPr>
-          <p:cNvPr id="147" name="Text 21"/>
+          <p:cNvPr id="152" name="Text 21"/>
           <p:cNvSpPr/>
           <p:nvPr/>
         </p:nvSpPr>
@@ -10708,7 +10719,7 @@
                 <a:uFillTx/>
                 <a:latin typeface="Arial"/>
               </a:rPr>
-              <a:t>Cách giải quyết: Thiết kế kiến trúc Hybrid Storage (api.js + storage.js) tự động chuyển đổi linh hoạt kèm cơ chế sao chép cơ sở dữ liệu tạm vào thư mục /tmp trên Vercel.</a:t>
+              <a:t>Cách xử lý: Kiến trúc Hybrid Storage (api.js + storage.js) đa tầng kèm cơ chế sao chép database tạm vào /tmp trên Vercel.</a:t>
             </a:r>
             <a:endParaRPr lang="en-US" sz="1100" b="0" u="none" strike="noStrike">
               <a:solidFill>
@@ -10723,7 +10734,7 @@
       </p:sp>
       <p:sp>
         <p:nvSpPr>
-          <p:cNvPr id="148" name="Title Next Steps"/>
+          <p:cNvPr id="153" name="Title Next Steps"/>
           <p:cNvSpPr/>
           <p:nvPr/>
         </p:nvSpPr>
@@ -10783,7 +10794,7 @@
       </p:sp>
       <p:sp>
         <p:nvSpPr>
-          <p:cNvPr id="149" name="Body Next Steps"/>
+          <p:cNvPr id="154" name="Body Next Steps"/>
           <p:cNvSpPr/>
           <p:nvPr/>
         </p:nvSpPr>
@@ -10792,9 +10803,6 @@
             <a:off x="6574680" y="4770000"/>
             <a:ext cx="4791240" cy="900000"/>
           </a:xfrm>
-          <a:prstGeom prst="rect">
-            <a:avLst/>
-          </a:prstGeom>
           <a:noFill/>
           <a:ln w="0">
             <a:noFill/>
@@ -10808,7 +10816,7 @@
         </p:style>
         <p:txBody>
           <a:bodyPr lIns="0" tIns="0" rIns="0" bIns="0" anchor="ctr">
-            <a:normAutofit fontScale="92500" lnSpcReduction="9999"/>
+            <a:normAutofit/>
           </a:bodyPr>
           <a:p>
             <a:pPr defTabSz="914400">
@@ -10839,7 +10847,7 @@
                 <a:uFillTx/>
                 <a:latin typeface="Arial"/>
               </a:rPr>
-              <a:t>Tích hợp cổng thanh toán trực tiếp qua Webhook thực tế từ VNPAY / MoMo merchant.</a:t>
+              <a:t>Tích hợp cổng thanh toán trực tiếp qua Webhook VNPAY / MoMo thực tế.</a:t>
             </a:r>
             <a:endParaRPr lang="en-US" sz="1050" b="0" u="none" strike="noStrike">
               <a:solidFill>
@@ -10879,7 +10887,7 @@
                 <a:uFillTx/>
                 <a:latin typeface="Arial"/>
               </a:rPr>
-              <a:t>Phát triển ứng dụng di động đa nền tảng (PWA / Mobile App) và tự động gửi vé qua Zalo ZNS / SMS.</a:t>
+              <a:t>Phát triển ứng dụng di động (PWA) và tự động gửi vé qua Zalo ZNS / SMS.</a:t>
             </a:r>
             <a:endParaRPr lang="en-US" sz="1050" b="0" u="none" strike="noStrike">
               <a:solidFill>
@@ -10919,7 +10927,7 @@
                 <a:uFillTx/>
                 <a:latin typeface="Arial"/>
               </a:rPr>
-              <a:t>Nâng cấp hệ thống Admin: Quản lý động sơ đồ phòng chiếu và thiết lập chiến dịch ưu đãi theo khung giờ vàng.</a:t>
+              <a:t>Quản lý động sơ đồ phòng chiếu &amp; chiến dịch ưu đãi giờ vàng trên Admin.</a:t>
             </a:r>
             <a:endParaRPr lang="en-US" sz="1050" b="0" u="none" strike="noStrike">
               <a:solidFill>

</xml_diff>

<commit_message>
feat(i18n & latte): add bilingual support, fix auth forms and refine light mode
- Implement universal VI/EN translation system with language toggle across all pages
- Fix login and registration modal input styles, labels and button contrast in Light Mode (Latte)
- Refine light mode styling for movies filter, showtimes, pricing, member and movie detail pages
- Redesign presentation slides with Catppuccin Mocha theme, real UI screenshots and core feature highlights
</commit_message>
<xml_diff>
--- a/Beta-Cinemas-Presentation.pptx
+++ b/Beta-Cinemas-Presentation.pptx
@@ -1497,7 +1497,7 @@
     <p:bg>
       <p:bgPr>
         <a:solidFill>
-          <a:srgbClr val="FFFFFF"/>
+          <a:srgbClr val="1E1E2E"/>
         </a:solidFill>
       </p:bgPr>
     </p:bg>
@@ -1985,7 +1985,7 @@
     <p:bg>
       <p:bgPr>
         <a:solidFill>
-          <a:srgbClr val="F4F2EF"/>
+          <a:srgbClr val="1E1E2E"/>
         </a:solidFill>
       </p:bgPr>
     </p:bg>
@@ -2018,11 +2018,11 @@
             <a:avLst/>
           </a:prstGeom>
           <a:solidFill>
-            <a:srgbClr val="E51D2A"/>
+            <a:srgbClr val="89B4FA"/>
           </a:solidFill>
           <a:ln w="12600">
             <a:solidFill>
-              <a:srgbClr val="E51D2A">
+              <a:srgbClr val="89B4FA">
                 <a:alpha val="0"/>
               </a:srgbClr>
             </a:solidFill>
@@ -2092,7 +2092,7 @@
             <a:r>
               <a:rPr lang="en-US" sz="1000" b="1" u="none" spc="150" strike="noStrike">
                 <a:solidFill>
-                  <a:srgbClr val="E51D2A"/>
+                  <a:srgbClr val="89B4FA"/>
                 </a:solidFill>
                 <a:effectLst/>
                 <a:uFillTx/>
@@ -2102,7 +2102,7 @@
             </a:r>
             <a:endParaRPr lang="en-US" sz="1000" b="0" u="none" strike="noStrike">
               <a:solidFill>
-                <a:srgbClr val="000000"/>
+                <a:srgbClr val="CDD6F4"/>
               </a:solidFill>
               <a:effectLst/>
               <a:uFillTx/>
@@ -2152,7 +2152,7 @@
             <a:r>
               <a:rPr lang="en-US" sz="900" b="1" u="none" spc="99" strike="noStrike">
                 <a:solidFill>
-                  <a:srgbClr val="747985"/>
+                  <a:srgbClr val="A6ADC8"/>
                 </a:solidFill>
                 <a:effectLst/>
                 <a:uFillTx/>
@@ -2162,7 +2162,7 @@
             </a:r>
             <a:endParaRPr lang="en-US" sz="900" b="0" u="none" strike="noStrike">
               <a:solidFill>
-                <a:srgbClr val="000000"/>
+                <a:srgbClr val="CDD6F4"/>
               </a:solidFill>
               <a:effectLst/>
               <a:uFillTx/>
@@ -2212,7 +2212,7 @@
             <a:r>
               <a:rPr lang="en-US" sz="900" b="0" u="none" strike="noStrike">
                 <a:solidFill>
-                  <a:srgbClr val="999999"/>
+                  <a:srgbClr val="9399B2"/>
                 </a:solidFill>
                 <a:effectLst/>
                 <a:uFillTx/>
@@ -2222,7 +2222,7 @@
             </a:r>
             <a:endParaRPr lang="en-US" sz="900" b="0" u="none" strike="noStrike">
               <a:solidFill>
-                <a:srgbClr val="000000"/>
+                <a:srgbClr val="CDD6F4"/>
               </a:solidFill>
               <a:effectLst/>
               <a:uFillTx/>
@@ -2272,7 +2272,7 @@
             <a:r>
               <a:rPr lang="en-US" sz="1100" b="1" u="none" spc="159" strike="noStrike">
                 <a:solidFill>
-                  <a:srgbClr val="E51D2A"/>
+                  <a:srgbClr val="89B4FA"/>
                 </a:solidFill>
                 <a:effectLst/>
                 <a:uFillTx/>
@@ -2282,7 +2282,7 @@
             </a:r>
             <a:endParaRPr lang="en-US" sz="1100" b="0" u="none" strike="noStrike">
               <a:solidFill>
-                <a:srgbClr val="000000"/>
+                <a:srgbClr val="CDD6F4"/>
               </a:solidFill>
               <a:effectLst/>
               <a:uFillTx/>
@@ -2332,7 +2332,7 @@
             <a:r>
               <a:rPr lang="en-US" sz="4200" b="1" u="none" spc="-99" strike="noStrike">
                 <a:solidFill>
-                  <a:srgbClr val="171923"/>
+                  <a:srgbClr val="CDD6F4"/>
                 </a:solidFill>
                 <a:effectLst/>
                 <a:uFillTx/>
@@ -2342,7 +2342,7 @@
             </a:r>
             <a:endParaRPr lang="en-US" sz="4200" b="0" u="none" strike="noStrike">
               <a:solidFill>
-                <a:srgbClr val="000000"/>
+                <a:srgbClr val="CDD6F4"/>
               </a:solidFill>
               <a:effectLst/>
               <a:uFillTx/>
@@ -2361,7 +2361,7 @@
             <a:r>
               <a:rPr lang="en-US" sz="4200" b="1" u="none" spc="-99" strike="noStrike">
                 <a:solidFill>
-                  <a:srgbClr val="171923"/>
+                  <a:srgbClr val="CDD6F4"/>
                 </a:solidFill>
                 <a:effectLst/>
                 <a:uFillTx/>
@@ -2371,7 +2371,7 @@
             </a:r>
             <a:endParaRPr lang="en-US" sz="4200" b="0" u="none" strike="noStrike">
               <a:solidFill>
-                <a:srgbClr val="000000"/>
+                <a:srgbClr val="CDD6F4"/>
               </a:solidFill>
               <a:effectLst/>
               <a:uFillTx/>
@@ -2421,7 +2421,7 @@
             <a:r>
               <a:rPr lang="en-US" sz="1600" b="0" u="none" strike="noStrike">
                 <a:solidFill>
-                  <a:srgbClr val="555B67"/>
+                  <a:srgbClr val="BAC2DE"/>
                 </a:solidFill>
                 <a:effectLst/>
                 <a:uFillTx/>
@@ -2431,7 +2431,7 @@
             </a:r>
             <a:endParaRPr lang="en-US" sz="1600" b="0" u="none" strike="noStrike">
               <a:solidFill>
-                <a:srgbClr val="000000"/>
+                <a:srgbClr val="CDD6F4"/>
               </a:solidFill>
               <a:effectLst/>
               <a:uFillTx/>
@@ -2455,11 +2455,11 @@
             <a:avLst/>
           </a:prstGeom>
           <a:solidFill>
-            <a:srgbClr val="E51D2A"/>
+            <a:srgbClr val="89B4FA"/>
           </a:solidFill>
           <a:ln w="12600">
             <a:solidFill>
-              <a:srgbClr val="E51D2A">
+              <a:srgbClr val="89B4FA">
                 <a:alpha val="0"/>
               </a:srgbClr>
             </a:solidFill>
@@ -2529,17 +2529,17 @@
             <a:r>
               <a:rPr lang="en-US" sz="900" b="1" u="none" spc="99" strike="noStrike">
                 <a:solidFill>
-                  <a:srgbClr val="747985"/>
-                </a:solidFill>
-                <a:effectLst/>
-                <a:uFillTx/>
-                <a:latin typeface="Arial"/>
-              </a:rPr>
-              <a:t>VẤN ĐỀ GIẢI QUYẾT</a:t>
+                  <a:srgbClr val="A6ADC8"/>
+                </a:solidFill>
+                <a:effectLst/>
+                <a:uFillTx/>
+                <a:latin typeface="Arial"/>
+              </a:rPr>
+              <a:t>CÁC TÍNH NĂNG CHÍNH</a:t>
             </a:r>
             <a:endParaRPr lang="en-US" sz="900" b="0" u="none" strike="noStrike">
               <a:solidFill>
-                <a:srgbClr val="000000"/>
+                <a:srgbClr val="CDD6F4"/>
               </a:solidFill>
               <a:effectLst/>
               <a:uFillTx/>
@@ -2586,17 +2586,17 @@
             <a:r>
               <a:rPr lang="en-US" sz="1500" b="1" u="none" strike="noStrike">
                 <a:solidFill>
-                  <a:srgbClr val="171923"/>
-                </a:solidFill>
-                <a:effectLst/>
-                <a:uFillTx/>
-                <a:latin typeface="Arial"/>
-              </a:rPr>
-              <a:t>• Tra cứu lịch, rạp &amp; chọn ghế còn phân tán.</a:t>
+                  <a:srgbClr val="CDD6F4"/>
+                </a:solidFill>
+                <a:effectLst/>
+                <a:uFillTx/>
+                <a:latin typeface="Arial"/>
+              </a:rPr>
+              <a:t>• Đặt vé &amp; chọn sơ đồ 164 ghế trực quan, giữ chỗ 5 phút.</a:t>
             </a:r>
             <a:endParaRPr lang="en-US" sz="1500" b="0" u="none" strike="noStrike">
               <a:solidFill>
-                <a:srgbClr val="000000"/>
+                <a:srgbClr val="CDD6F4"/>
               </a:solidFill>
               <a:effectLst/>
               <a:uFillTx/>
@@ -2615,17 +2615,17 @@
             <a:r>
               <a:rPr lang="en-US" sz="1500" b="1" u="none" strike="noStrike">
                 <a:solidFill>
-                  <a:srgbClr val="171923"/>
-                </a:solidFill>
-                <a:effectLst/>
-                <a:uFillTx/>
-                <a:latin typeface="Arial"/>
-              </a:rPr>
-              <a:t>• Thanh toán rườm rà, thiếu minh bạch ưu đãi &amp; điểm thành viên.</a:t>
+                  <a:srgbClr val="CDD6F4"/>
+                </a:solidFill>
+                <a:effectLst/>
+                <a:uFillTx/>
+                <a:latin typeface="Arial"/>
+              </a:rPr>
+              <a:t>• Đa kênh thanh toán, voucher giảm giá &amp; vé điện tử SVG QR.</a:t>
             </a:r>
             <a:endParaRPr lang="en-US" sz="1500" b="0" u="none" strike="noStrike">
               <a:solidFill>
-                <a:srgbClr val="000000"/>
+                <a:srgbClr val="CDD6F4"/>
               </a:solidFill>
               <a:effectLst/>
               <a:uFillTx/>
@@ -2649,11 +2649,11 @@
             <a:avLst/>
           </a:prstGeom>
           <a:solidFill>
-            <a:srgbClr val="E51D2A"/>
+            <a:srgbClr val="89B4FA"/>
           </a:solidFill>
           <a:ln w="12600">
             <a:solidFill>
-              <a:srgbClr val="E51D2A">
+              <a:srgbClr val="89B4FA">
                 <a:alpha val="0"/>
               </a:srgbClr>
             </a:solidFill>
@@ -2723,7 +2723,7 @@
             <a:r>
               <a:rPr lang="en-US" sz="900" b="1" u="none" spc="99" strike="noStrike">
                 <a:solidFill>
-                  <a:srgbClr val="747985"/>
+                  <a:srgbClr val="A6ADC8"/>
                 </a:solidFill>
                 <a:effectLst/>
                 <a:uFillTx/>
@@ -2733,7 +2733,7 @@
             </a:r>
             <a:endParaRPr lang="en-US" sz="900" b="0" u="none" strike="noStrike">
               <a:solidFill>
-                <a:srgbClr val="000000"/>
+                <a:srgbClr val="CDD6F4"/>
               </a:solidFill>
               <a:effectLst/>
               <a:uFillTx/>
@@ -2780,7 +2780,7 @@
             <a:r>
               <a:rPr lang="en-US" sz="1500" b="1" u="none" strike="noStrike">
                 <a:solidFill>
-                  <a:srgbClr val="171923"/>
+                  <a:srgbClr val="CDD6F4"/>
                 </a:solidFill>
                 <a:effectLst/>
                 <a:uFillTx/>
@@ -2790,7 +2790,7 @@
             </a:r>
             <a:endParaRPr lang="en-US" sz="1500" b="0" u="none" strike="noStrike">
               <a:solidFill>
-                <a:srgbClr val="000000"/>
+                <a:srgbClr val="CDD6F4"/>
               </a:solidFill>
               <a:effectLst/>
               <a:uFillTx/>
@@ -2809,7 +2809,7 @@
             <a:r>
               <a:rPr lang="en-US" sz="1500" b="1" u="none" strike="noStrike">
                 <a:solidFill>
-                  <a:srgbClr val="171923"/>
+                  <a:srgbClr val="CDD6F4"/>
                 </a:solidFill>
                 <a:effectLst/>
                 <a:uFillTx/>
@@ -2819,7 +2819,7 @@
             </a:r>
             <a:endParaRPr lang="en-US" sz="1500" b="0" u="none" strike="noStrike">
               <a:solidFill>
-                <a:srgbClr val="000000"/>
+                <a:srgbClr val="CDD6F4"/>
               </a:solidFill>
               <a:effectLst/>
               <a:uFillTx/>
@@ -2843,11 +2843,11 @@
             <a:avLst/>
           </a:prstGeom>
           <a:solidFill>
-            <a:srgbClr val="E51D2A"/>
+            <a:srgbClr val="89B4FA"/>
           </a:solidFill>
           <a:ln w="12600">
             <a:solidFill>
-              <a:srgbClr val="E51D2A">
+              <a:srgbClr val="89B4FA">
                 <a:alpha val="0"/>
               </a:srgbClr>
             </a:solidFill>
@@ -2917,7 +2917,7 @@
             <a:r>
               <a:rPr lang="en-US" sz="900" b="1" u="none" spc="99" strike="noStrike">
                 <a:solidFill>
-                  <a:srgbClr val="747985"/>
+                  <a:srgbClr val="A6ADC8"/>
                 </a:solidFill>
                 <a:effectLst/>
                 <a:uFillTx/>
@@ -2927,7 +2927,7 @@
             </a:r>
             <a:endParaRPr lang="en-US" sz="900" b="0" u="none" strike="noStrike">
               <a:solidFill>
-                <a:srgbClr val="000000"/>
+                <a:srgbClr val="CDD6F4"/>
               </a:solidFill>
               <a:effectLst/>
               <a:uFillTx/>
@@ -2974,7 +2974,7 @@
             <a:r>
               <a:rPr lang="en-US" sz="1500" b="1" u="none" strike="noStrike">
                 <a:solidFill>
-                  <a:srgbClr val="171923"/>
+                  <a:srgbClr val="CDD6F4"/>
                 </a:solidFill>
                 <a:effectLst/>
                 <a:uFillTx/>
@@ -2984,7 +2984,7 @@
             </a:r>
             <a:endParaRPr lang="en-US" sz="1500" b="0" u="none" strike="noStrike">
               <a:solidFill>
-                <a:srgbClr val="000000"/>
+                <a:srgbClr val="CDD6F4"/>
               </a:solidFill>
               <a:effectLst/>
               <a:uFillTx/>
@@ -3003,17 +3003,17 @@
             <a:r>
               <a:rPr lang="en-US" sz="1500" b="1" u="none" strike="noStrike">
                 <a:solidFill>
-                  <a:srgbClr val="171923"/>
-                </a:solidFill>
-                <a:effectLst/>
-                <a:uFillTx/>
-                <a:latin typeface="Arial"/>
-              </a:rPr>
-              <a:t>• Vũ Tiến Lập: Frontend &amp; QA Lead (Checkout, Rạp, Test 56/56)</a:t>
+                  <a:srgbClr val="CDD6F4"/>
+                </a:solidFill>
+                <a:effectLst/>
+                <a:uFillTx/>
+                <a:latin typeface="Arial"/>
+              </a:rPr>
+              <a:t>• Vũ Tiến Lập (PH65133): Frontend &amp; QA Lead (Checkout, Rạp, Test 56/56)</a:t>
             </a:r>
             <a:endParaRPr lang="en-US" sz="1500" b="0" u="none" strike="noStrike">
               <a:solidFill>
-                <a:srgbClr val="000000"/>
+                <a:srgbClr val="CDD6F4"/>
               </a:solidFill>
               <a:effectLst/>
               <a:uFillTx/>
@@ -3032,17 +3032,17 @@
             <a:r>
               <a:rPr lang="en-US" sz="1500" b="1" u="none" strike="noStrike">
                 <a:solidFill>
-                  <a:srgbClr val="171923"/>
-                </a:solidFill>
-                <a:effectLst/>
-                <a:uFillTx/>
-                <a:latin typeface="Arial"/>
-              </a:rPr>
-              <a:t>• Phạm Anh Duy: Feature Lead (Ghế 164, Voucher, Member 3D, Admin)</a:t>
+                  <a:srgbClr val="CDD6F4"/>
+                </a:solidFill>
+                <a:effectLst/>
+                <a:uFillTx/>
+                <a:latin typeface="Arial"/>
+              </a:rPr>
+              <a:t>• Phạm Anh Duy (PH65717): Feature Lead (Ghế 164, Voucher, Member 3D, Admin)</a:t>
             </a:r>
             <a:endParaRPr lang="en-US" sz="1500" b="0" u="none" strike="noStrike">
               <a:solidFill>
-                <a:srgbClr val="000000"/>
+                <a:srgbClr val="CDD6F4"/>
               </a:solidFill>
               <a:effectLst/>
               <a:uFillTx/>
@@ -3068,11 +3068,11 @@
             </a:avLst>
           </a:prstGeom>
           <a:solidFill>
-            <a:srgbClr val="FFFFFF"/>
+            <a:srgbClr val="313244"/>
           </a:solidFill>
           <a:ln w="12600">
             <a:solidFill>
-              <a:srgbClr val="E8E6E2"/>
+              <a:srgbClr val="45475A"/>
             </a:solidFill>
             <a:round/>
           </a:ln>
@@ -3090,7 +3090,7 @@
           <a:p>
             <a:endParaRPr lang="en-US" sz="1800" b="0" u="none" strike="noStrike">
               <a:solidFill>
-                <a:srgbClr val="000000"/>
+                <a:srgbClr val="CDD6F4"/>
               </a:solidFill>
               <a:effectLst/>
               <a:uFillTx/>
@@ -3118,11 +3118,11 @@
             <a:avLst/>
           </a:prstGeom>
           <a:solidFill>
-            <a:srgbClr val="FFFFFF"/>
+            <a:srgbClr val="313244"/>
           </a:solidFill>
           <a:ln w="12600">
             <a:solidFill>
-              <a:srgbClr val="E8E6E2"/>
+              <a:srgbClr val="45475A"/>
             </a:solidFill>
             <a:round/>
           </a:ln>
@@ -3143,6 +3143,13 @@
 
 <file path=ppt/slides/slide2.xml><?xml version="1.0" encoding="utf-8"?>
 <p:sld xmlns:a="http://schemas.openxmlformats.org/drawingml/2006/main" xmlns:p="http://schemas.openxmlformats.org/presentationml/2006/main" xmlns:r="http://schemas.openxmlformats.org/officeDocument/2006/relationships" xmlns:p14="http://schemas.microsoft.com/office/powerpoint/2010/main" xmlns:p15="http://schemas.microsoft.com/office/powerpoint/2012/main" xmlns:mc="http://schemas.openxmlformats.org/markup-compatibility/2006">
+  <p:bg>
+    <p:bgPr>
+      <a:solidFill>
+        <a:srgbClr val="1E1E2E"/>
+      </a:solidFill>
+    </p:bgPr>
+  </p:bg>
   <p:cSld>
     <p:spTree>
       <p:nvGrpSpPr>
@@ -3173,11 +3180,11 @@
             <a:avLst/>
           </a:prstGeom>
           <a:solidFill>
-            <a:srgbClr val="E51D2A"/>
+            <a:srgbClr val="89B4FA"/>
           </a:solidFill>
           <a:ln w="12600">
             <a:solidFill>
-              <a:srgbClr val="E51D2A">
+              <a:srgbClr val="89B4FA">
                 <a:alpha val="0"/>
               </a:srgbClr>
             </a:solidFill>
@@ -3247,7 +3254,7 @@
             <a:r>
               <a:rPr lang="en-US" sz="1000" b="1" u="none" spc="150" strike="noStrike">
                 <a:solidFill>
-                  <a:srgbClr val="E51D2A"/>
+                  <a:srgbClr val="89B4FA"/>
                 </a:solidFill>
                 <a:effectLst/>
                 <a:uFillTx/>
@@ -3257,7 +3264,7 @@
             </a:r>
             <a:endParaRPr lang="en-US" sz="1000" b="0" u="none" strike="noStrike">
               <a:solidFill>
-                <a:srgbClr val="000000"/>
+                <a:srgbClr val="CDD6F4"/>
               </a:solidFill>
               <a:effectLst/>
               <a:uFillTx/>
@@ -3307,7 +3314,7 @@
             <a:r>
               <a:rPr lang="en-US" sz="900" b="1" u="none" spc="99" strike="noStrike">
                 <a:solidFill>
-                  <a:srgbClr val="747985"/>
+                  <a:srgbClr val="A6ADC8"/>
                 </a:solidFill>
                 <a:effectLst/>
                 <a:uFillTx/>
@@ -3317,7 +3324,7 @@
             </a:r>
             <a:endParaRPr lang="en-US" sz="900" b="0" u="none" strike="noStrike">
               <a:solidFill>
-                <a:srgbClr val="000000"/>
+                <a:srgbClr val="CDD6F4"/>
               </a:solidFill>
               <a:effectLst/>
               <a:uFillTx/>
@@ -3367,7 +3374,7 @@
             <a:r>
               <a:rPr lang="en-US" sz="900" b="0" u="none" strike="noStrike">
                 <a:solidFill>
-                  <a:srgbClr val="999999"/>
+                  <a:srgbClr val="9399B2"/>
                 </a:solidFill>
                 <a:effectLst/>
                 <a:uFillTx/>
@@ -3377,7 +3384,7 @@
             </a:r>
             <a:endParaRPr lang="en-US" sz="900" b="0" u="none" strike="noStrike">
               <a:solidFill>
-                <a:srgbClr val="000000"/>
+                <a:srgbClr val="CDD6F4"/>
               </a:solidFill>
               <a:effectLst/>
               <a:uFillTx/>
@@ -3427,7 +3434,7 @@
             <a:r>
               <a:rPr lang="en-US" sz="1000" b="1" u="none" spc="159" strike="noStrike">
                 <a:solidFill>
-                  <a:srgbClr val="E51D2A"/>
+                  <a:srgbClr val="89B4FA"/>
                 </a:solidFill>
                 <a:effectLst/>
                 <a:uFillTx/>
@@ -3437,7 +3444,7 @@
             </a:r>
             <a:endParaRPr lang="en-US" sz="1000" b="0" u="none" strike="noStrike">
               <a:solidFill>
-                <a:srgbClr val="000000"/>
+                <a:srgbClr val="CDD6F4"/>
               </a:solidFill>
               <a:effectLst/>
               <a:uFillTx/>
@@ -3487,7 +3494,7 @@
             <a:r>
               <a:rPr lang="en-US" sz="3100" b="1" u="none" spc="-51" strike="noStrike">
                 <a:solidFill>
-                  <a:srgbClr val="171923"/>
+                  <a:srgbClr val="CDD6F4"/>
                 </a:solidFill>
                 <a:effectLst/>
                 <a:uFillTx/>
@@ -3497,7 +3504,7 @@
             </a:r>
             <a:endParaRPr lang="en-US" sz="3100" b="0" u="none" strike="noStrike">
               <a:solidFill>
-                <a:srgbClr val="000000"/>
+                <a:srgbClr val="CDD6F4"/>
               </a:solidFill>
               <a:effectLst/>
               <a:uFillTx/>
@@ -3523,11 +3530,11 @@
             </a:avLst>
           </a:prstGeom>
           <a:solidFill>
-            <a:srgbClr val="FFFFFF"/>
+            <a:srgbClr val="313244"/>
           </a:solidFill>
           <a:ln w="12600">
             <a:solidFill>
-              <a:srgbClr val="E8E6E2"/>
+              <a:srgbClr val="45475A"/>
             </a:solidFill>
             <a:round/>
           </a:ln>
@@ -3545,7 +3552,7 @@
           <a:p>
             <a:endParaRPr lang="en-US" sz="1800" b="0" u="none" strike="noStrike">
               <a:solidFill>
-                <a:srgbClr val="000000"/>
+                <a:srgbClr val="CDD6F4"/>
               </a:solidFill>
               <a:effectLst/>
               <a:uFillTx/>
@@ -3595,7 +3602,7 @@
             <a:r>
               <a:rPr lang="en-US" sz="900" b="1" u="none" spc="99" strike="noStrike">
                 <a:solidFill>
-                  <a:srgbClr val="E51D2A"/>
+                  <a:srgbClr val="89B4FA"/>
                 </a:solidFill>
                 <a:effectLst/>
                 <a:uFillTx/>
@@ -3605,7 +3612,7 @@
             </a:r>
             <a:endParaRPr lang="en-US" sz="900" b="0" u="none" strike="noStrike">
               <a:solidFill>
-                <a:srgbClr val="000000"/>
+                <a:srgbClr val="CDD6F4"/>
               </a:solidFill>
               <a:effectLst/>
               <a:uFillTx/>
@@ -3655,7 +3662,7 @@
             <a:r>
               <a:rPr lang="en-US" sz="1300" b="1" u="none" strike="noStrike">
                 <a:solidFill>
-                  <a:srgbClr val="171923"/>
+                  <a:srgbClr val="CDD6F4"/>
                 </a:solidFill>
                 <a:effectLst/>
                 <a:uFillTx/>
@@ -3665,7 +3672,7 @@
             </a:r>
             <a:endParaRPr lang="en-US" sz="1300" b="0" u="none" strike="noStrike">
               <a:solidFill>
-                <a:srgbClr val="000000"/>
+                <a:srgbClr val="CDD6F4"/>
               </a:solidFill>
               <a:effectLst/>
               <a:uFillTx/>
@@ -3715,7 +3722,7 @@
             <a:r>
               <a:rPr lang="en-US" sz="1050" b="0" u="none" strike="noStrike">
                 <a:solidFill>
-                  <a:srgbClr val="171923"/>
+                  <a:srgbClr val="CDD6F4"/>
                 </a:solidFill>
                 <a:effectLst/>
                 <a:uFillTx/>
@@ -3725,7 +3732,7 @@
             </a:r>
             <a:endParaRPr lang="en-US" sz="1050" b="0" u="none" strike="noStrike">
               <a:solidFill>
-                <a:srgbClr val="000000"/>
+                <a:srgbClr val="CDD6F4"/>
               </a:solidFill>
               <a:effectLst/>
               <a:uFillTx/>
@@ -3751,11 +3758,11 @@
             </a:avLst>
           </a:prstGeom>
           <a:solidFill>
-            <a:srgbClr val="FFFFFF"/>
+            <a:srgbClr val="313244"/>
           </a:solidFill>
           <a:ln w="12600">
             <a:solidFill>
-              <a:srgbClr val="E8E6E2"/>
+              <a:srgbClr val="45475A"/>
             </a:solidFill>
             <a:round/>
           </a:ln>
@@ -3773,7 +3780,7 @@
           <a:p>
             <a:endParaRPr lang="en-US" sz="1800" b="0" u="none" strike="noStrike">
               <a:solidFill>
-                <a:srgbClr val="000000"/>
+                <a:srgbClr val="CDD6F4"/>
               </a:solidFill>
               <a:effectLst/>
               <a:uFillTx/>
@@ -3823,7 +3830,7 @@
             <a:r>
               <a:rPr lang="en-US" sz="900" b="1" u="none" spc="99" strike="noStrike">
                 <a:solidFill>
-                  <a:srgbClr val="E51D2A"/>
+                  <a:srgbClr val="89B4FA"/>
                 </a:solidFill>
                 <a:effectLst/>
                 <a:uFillTx/>
@@ -3833,7 +3840,7 @@
             </a:r>
             <a:endParaRPr lang="en-US" sz="900" b="0" u="none" strike="noStrike">
               <a:solidFill>
-                <a:srgbClr val="000000"/>
+                <a:srgbClr val="CDD6F4"/>
               </a:solidFill>
               <a:effectLst/>
               <a:uFillTx/>
@@ -3883,7 +3890,7 @@
             <a:r>
               <a:rPr lang="en-US" sz="1300" b="1" u="none" strike="noStrike">
                 <a:solidFill>
-                  <a:srgbClr val="171923"/>
+                  <a:srgbClr val="CDD6F4"/>
                 </a:solidFill>
                 <a:effectLst/>
                 <a:uFillTx/>
@@ -3893,7 +3900,7 @@
             </a:r>
             <a:endParaRPr lang="en-US" sz="1300" b="0" u="none" strike="noStrike">
               <a:solidFill>
-                <a:srgbClr val="000000"/>
+                <a:srgbClr val="CDD6F4"/>
               </a:solidFill>
               <a:effectLst/>
               <a:uFillTx/>
@@ -3943,7 +3950,7 @@
             <a:r>
               <a:rPr lang="en-US" sz="1050" b="0" u="none" strike="noStrike">
                 <a:solidFill>
-                  <a:srgbClr val="171923"/>
+                  <a:srgbClr val="CDD6F4"/>
                 </a:solidFill>
                 <a:effectLst/>
                 <a:uFillTx/>
@@ -3953,7 +3960,7 @@
             </a:r>
             <a:endParaRPr lang="en-US" sz="1050" b="0" u="none" strike="noStrike">
               <a:solidFill>
-                <a:srgbClr val="000000"/>
+                <a:srgbClr val="CDD6F4"/>
               </a:solidFill>
               <a:effectLst/>
               <a:uFillTx/>
@@ -3979,11 +3986,11 @@
             </a:avLst>
           </a:prstGeom>
           <a:solidFill>
-            <a:srgbClr val="FFFFFF"/>
+            <a:srgbClr val="313244"/>
           </a:solidFill>
           <a:ln w="12600">
             <a:solidFill>
-              <a:srgbClr val="E8E6E2"/>
+              <a:srgbClr val="45475A"/>
             </a:solidFill>
             <a:round/>
           </a:ln>
@@ -4001,7 +4008,7 @@
           <a:p>
             <a:endParaRPr lang="en-US" sz="1800" b="0" u="none" strike="noStrike">
               <a:solidFill>
-                <a:srgbClr val="000000"/>
+                <a:srgbClr val="CDD6F4"/>
               </a:solidFill>
               <a:effectLst/>
               <a:uFillTx/>
@@ -4051,7 +4058,7 @@
             <a:r>
               <a:rPr lang="en-US" sz="900" b="1" u="none" spc="99" strike="noStrike">
                 <a:solidFill>
-                  <a:srgbClr val="E51D2A"/>
+                  <a:srgbClr val="89B4FA"/>
                 </a:solidFill>
                 <a:effectLst/>
                 <a:uFillTx/>
@@ -4061,7 +4068,7 @@
             </a:r>
             <a:endParaRPr lang="en-US" sz="900" b="0" u="none" strike="noStrike">
               <a:solidFill>
-                <a:srgbClr val="000000"/>
+                <a:srgbClr val="CDD6F4"/>
               </a:solidFill>
               <a:effectLst/>
               <a:uFillTx/>
@@ -4111,7 +4118,7 @@
             <a:r>
               <a:rPr lang="en-US" sz="1300" b="1" u="none" strike="noStrike">
                 <a:solidFill>
-                  <a:srgbClr val="171923"/>
+                  <a:srgbClr val="CDD6F4"/>
                 </a:solidFill>
                 <a:effectLst/>
                 <a:uFillTx/>
@@ -4121,7 +4128,7 @@
             </a:r>
             <a:endParaRPr lang="en-US" sz="1300" b="0" u="none" strike="noStrike">
               <a:solidFill>
-                <a:srgbClr val="000000"/>
+                <a:srgbClr val="CDD6F4"/>
               </a:solidFill>
               <a:effectLst/>
               <a:uFillTx/>
@@ -4171,7 +4178,7 @@
             <a:r>
               <a:rPr lang="en-US" sz="1050" b="0" u="none" strike="noStrike">
                 <a:solidFill>
-                  <a:srgbClr val="171923"/>
+                  <a:srgbClr val="CDD6F4"/>
                 </a:solidFill>
                 <a:effectLst/>
                 <a:uFillTx/>
@@ -4181,7 +4188,7 @@
             </a:r>
             <a:endParaRPr lang="en-US" sz="1050" b="0" u="none" strike="noStrike">
               <a:solidFill>
-                <a:srgbClr val="000000"/>
+                <a:srgbClr val="CDD6F4"/>
               </a:solidFill>
               <a:effectLst/>
               <a:uFillTx/>
@@ -4207,11 +4214,11 @@
             </a:avLst>
           </a:prstGeom>
           <a:solidFill>
-            <a:srgbClr val="FFFFFF"/>
+            <a:srgbClr val="313244"/>
           </a:solidFill>
           <a:ln w="12600">
             <a:solidFill>
-              <a:srgbClr val="E8E6E2"/>
+              <a:srgbClr val="45475A"/>
             </a:solidFill>
             <a:round/>
           </a:ln>
@@ -4229,7 +4236,7 @@
           <a:p>
             <a:endParaRPr lang="en-US" sz="1800" b="0" u="none" strike="noStrike">
               <a:solidFill>
-                <a:srgbClr val="000000"/>
+                <a:srgbClr val="CDD6F4"/>
               </a:solidFill>
               <a:effectLst/>
               <a:uFillTx/>
@@ -4279,7 +4286,7 @@
             <a:r>
               <a:rPr lang="en-US" sz="900" b="1" u="none" spc="99" strike="noStrike">
                 <a:solidFill>
-                  <a:srgbClr val="E51D2A"/>
+                  <a:srgbClr val="89B4FA"/>
                 </a:solidFill>
                 <a:effectLst/>
                 <a:uFillTx/>
@@ -4289,7 +4296,7 @@
             </a:r>
             <a:endParaRPr lang="en-US" sz="900" b="0" u="none" strike="noStrike">
               <a:solidFill>
-                <a:srgbClr val="000000"/>
+                <a:srgbClr val="CDD6F4"/>
               </a:solidFill>
               <a:effectLst/>
               <a:uFillTx/>
@@ -4339,7 +4346,7 @@
             <a:r>
               <a:rPr lang="en-US" sz="1300" b="1" u="none" strike="noStrike">
                 <a:solidFill>
-                  <a:srgbClr val="171923"/>
+                  <a:srgbClr val="CDD6F4"/>
                 </a:solidFill>
                 <a:effectLst/>
                 <a:uFillTx/>
@@ -4349,7 +4356,7 @@
             </a:r>
             <a:endParaRPr lang="en-US" sz="1300" b="0" u="none" strike="noStrike">
               <a:solidFill>
-                <a:srgbClr val="000000"/>
+                <a:srgbClr val="CDD6F4"/>
               </a:solidFill>
               <a:effectLst/>
               <a:uFillTx/>
@@ -4399,7 +4406,7 @@
             <a:r>
               <a:rPr lang="en-US" sz="1050" b="0" u="none" strike="noStrike">
                 <a:solidFill>
-                  <a:srgbClr val="171923"/>
+                  <a:srgbClr val="CDD6F4"/>
                 </a:solidFill>
                 <a:effectLst/>
                 <a:uFillTx/>
@@ -4409,7 +4416,7 @@
             </a:r>
             <a:endParaRPr lang="en-US" sz="1050" b="0" u="none" strike="noStrike">
               <a:solidFill>
-                <a:srgbClr val="000000"/>
+                <a:srgbClr val="CDD6F4"/>
               </a:solidFill>
               <a:effectLst/>
               <a:uFillTx/>
@@ -4435,11 +4442,11 @@
             </a:avLst>
           </a:prstGeom>
           <a:solidFill>
-            <a:srgbClr val="FFFFFF"/>
+            <a:srgbClr val="313244"/>
           </a:solidFill>
           <a:ln w="12600">
             <a:solidFill>
-              <a:srgbClr val="E8E6E2"/>
+              <a:srgbClr val="45475A"/>
             </a:solidFill>
             <a:round/>
           </a:ln>
@@ -4457,7 +4464,7 @@
           <a:p>
             <a:endParaRPr lang="en-US" sz="1800" b="0" u="none" strike="noStrike">
               <a:solidFill>
-                <a:srgbClr val="000000"/>
+                <a:srgbClr val="CDD6F4"/>
               </a:solidFill>
               <a:effectLst/>
               <a:uFillTx/>
@@ -4507,7 +4514,7 @@
             <a:r>
               <a:rPr lang="en-US" sz="900" b="1" u="none" spc="99" strike="noStrike">
                 <a:solidFill>
-                  <a:srgbClr val="E51D2A"/>
+                  <a:srgbClr val="89B4FA"/>
                 </a:solidFill>
                 <a:effectLst/>
                 <a:uFillTx/>
@@ -4517,7 +4524,7 @@
             </a:r>
             <a:endParaRPr lang="en-US" sz="900" b="0" u="none" strike="noStrike">
               <a:solidFill>
-                <a:srgbClr val="000000"/>
+                <a:srgbClr val="CDD6F4"/>
               </a:solidFill>
               <a:effectLst/>
               <a:uFillTx/>
@@ -4567,17 +4574,17 @@
             <a:r>
               <a:rPr lang="en-US" sz="1300" b="1" u="none" strike="noStrike">
                 <a:solidFill>
-                  <a:srgbClr val="171923"/>
-                </a:solidFill>
-                <a:effectLst/>
-                <a:uFillTx/>
-                <a:latin typeface="Arial"/>
-              </a:rPr>
-              <a:t>Thanh toán mô phỏng &amp; Xuất vé QR</a:t>
+                  <a:srgbClr val="CDD6F4"/>
+                </a:solidFill>
+                <a:effectLst/>
+                <a:uFillTx/>
+                <a:latin typeface="Arial"/>
+              </a:rPr>
+              <a:t>Thanh toán đa kênh &amp; Xuất vé QR</a:t>
             </a:r>
             <a:endParaRPr lang="en-US" sz="1300" b="0" u="none" strike="noStrike">
               <a:solidFill>
-                <a:srgbClr val="000000"/>
+                <a:srgbClr val="CDD6F4"/>
               </a:solidFill>
               <a:effectLst/>
               <a:uFillTx/>
@@ -4627,17 +4634,17 @@
             <a:r>
               <a:rPr lang="en-US" sz="1050" b="0" u="none" strike="noStrike">
                 <a:solidFill>
-                  <a:srgbClr val="171923"/>
-                </a:solidFill>
-                <a:effectLst/>
-                <a:uFillTx/>
-                <a:latin typeface="Arial"/>
-              </a:rPr>
-              <a:t>Thanh toán mô phỏng VNPAY/MoMo/Thẻ ngân hàng; tự động sinh vé điện tử có mã QR Code check-in tại quầy.</a:t>
+                  <a:srgbClr val="CDD6F4"/>
+                </a:solidFill>
+                <a:effectLst/>
+                <a:uFillTx/>
+                <a:latin typeface="Arial"/>
+              </a:rPr>
+              <a:t>Thanh toán đa kênh (MoMo, ZaloPay, Thẻ quốc tế, VietQR); tự động sinh Vé điện tử SVG kèm mã QR Kiosk check-in.</a:t>
             </a:r>
             <a:endParaRPr lang="en-US" sz="1050" b="0" u="none" strike="noStrike">
               <a:solidFill>
-                <a:srgbClr val="000000"/>
+                <a:srgbClr val="CDD6F4"/>
               </a:solidFill>
               <a:effectLst/>
               <a:uFillTx/>
@@ -4663,11 +4670,11 @@
             </a:avLst>
           </a:prstGeom>
           <a:solidFill>
-            <a:srgbClr val="FFFFFF"/>
+            <a:srgbClr val="313244"/>
           </a:solidFill>
           <a:ln w="12600">
             <a:solidFill>
-              <a:srgbClr val="E8E6E2"/>
+              <a:srgbClr val="45475A"/>
             </a:solidFill>
             <a:round/>
           </a:ln>
@@ -4685,7 +4692,7 @@
           <a:p>
             <a:endParaRPr lang="en-US" sz="1800" b="0" u="none" strike="noStrike">
               <a:solidFill>
-                <a:srgbClr val="000000"/>
+                <a:srgbClr val="CDD6F4"/>
               </a:solidFill>
               <a:effectLst/>
               <a:uFillTx/>
@@ -4735,7 +4742,7 @@
             <a:r>
               <a:rPr lang="en-US" sz="900" b="1" u="none" spc="99" strike="noStrike">
                 <a:solidFill>
-                  <a:srgbClr val="E51D2A"/>
+                  <a:srgbClr val="89B4FA"/>
                 </a:solidFill>
                 <a:effectLst/>
                 <a:uFillTx/>
@@ -4745,7 +4752,7 @@
             </a:r>
             <a:endParaRPr lang="en-US" sz="900" b="0" u="none" strike="noStrike">
               <a:solidFill>
-                <a:srgbClr val="000000"/>
+                <a:srgbClr val="CDD6F4"/>
               </a:solidFill>
               <a:effectLst/>
               <a:uFillTx/>
@@ -4795,7 +4802,7 @@
             <a:r>
               <a:rPr lang="en-US" sz="1300" b="1" u="none" strike="noStrike">
                 <a:solidFill>
-                  <a:srgbClr val="171923"/>
+                  <a:srgbClr val="CDD6F4"/>
                 </a:solidFill>
                 <a:effectLst/>
                 <a:uFillTx/>
@@ -4805,7 +4812,7 @@
             </a:r>
             <a:endParaRPr lang="en-US" sz="1300" b="0" u="none" strike="noStrike">
               <a:solidFill>
-                <a:srgbClr val="000000"/>
+                <a:srgbClr val="CDD6F4"/>
               </a:solidFill>
               <a:effectLst/>
               <a:uFillTx/>
@@ -4855,17 +4862,17 @@
             <a:r>
               <a:rPr lang="en-US" sz="1050" b="0" u="none" strike="noStrike">
                 <a:solidFill>
-                  <a:srgbClr val="171923"/>
-                </a:solidFill>
-                <a:effectLst/>
-                <a:uFillTx/>
-                <a:latin typeface="Arial"/>
-              </a:rPr>
-              <a:t>Thẻ hội viên 3D interactive, đổi voucher bằng điểm; Cổng Admin bảo mật Auth Gate, Dashboard KPI &amp; Soát vé QR.</a:t>
+                  <a:srgbClr val="CDD6F4"/>
+                </a:solidFill>
+                <a:effectLst/>
+                <a:uFillTx/>
+                <a:latin typeface="Arial"/>
+              </a:rPr>
+              <a:t>Thẻ hội viên 3D lật mặt &amp; máy tính tích điểm; Cổng Admin bảo mật Auth Gate, Dashboard KPI &amp; 8 Tabs quản lý nghiệp vụ.</a:t>
             </a:r>
             <a:endParaRPr lang="en-US" sz="1050" b="0" u="none" strike="noStrike">
               <a:solidFill>
-                <a:srgbClr val="000000"/>
+                <a:srgbClr val="CDD6F4"/>
               </a:solidFill>
               <a:effectLst/>
               <a:uFillTx/>
@@ -4889,6 +4896,13 @@
 
 <file path=ppt/slides/slide3.xml><?xml version="1.0" encoding="utf-8"?>
 <p:sld xmlns:a="http://schemas.openxmlformats.org/drawingml/2006/main" xmlns:p="http://schemas.openxmlformats.org/presentationml/2006/main" xmlns:r="http://schemas.openxmlformats.org/officeDocument/2006/relationships" xmlns:p14="http://schemas.microsoft.com/office/powerpoint/2010/main" xmlns:p15="http://schemas.microsoft.com/office/powerpoint/2012/main" xmlns:mc="http://schemas.openxmlformats.org/markup-compatibility/2006">
+  <p:bg>
+    <p:bgPr>
+      <a:solidFill>
+        <a:srgbClr val="1E1E2E"/>
+      </a:solidFill>
+    </p:bgPr>
+  </p:bg>
   <p:cSld>
     <p:spTree>
       <p:nvGrpSpPr>
@@ -4919,11 +4933,11 @@
             <a:avLst/>
           </a:prstGeom>
           <a:solidFill>
-            <a:srgbClr val="E51D2A"/>
+            <a:srgbClr val="89B4FA"/>
           </a:solidFill>
           <a:ln w="12600">
             <a:solidFill>
-              <a:srgbClr val="E51D2A">
+              <a:srgbClr val="89B4FA">
                 <a:alpha val="0"/>
               </a:srgbClr>
             </a:solidFill>
@@ -4993,7 +5007,7 @@
             <a:r>
               <a:rPr lang="en-US" sz="1000" b="1" u="none" spc="150" strike="noStrike">
                 <a:solidFill>
-                  <a:srgbClr val="E51D2A"/>
+                  <a:srgbClr val="89B4FA"/>
                 </a:solidFill>
                 <a:effectLst/>
                 <a:uFillTx/>
@@ -5003,7 +5017,7 @@
             </a:r>
             <a:endParaRPr lang="en-US" sz="1000" b="0" u="none" strike="noStrike">
               <a:solidFill>
-                <a:srgbClr val="000000"/>
+                <a:srgbClr val="CDD6F4"/>
               </a:solidFill>
               <a:effectLst/>
               <a:uFillTx/>
@@ -5053,7 +5067,7 @@
             <a:r>
               <a:rPr lang="en-US" sz="900" b="1" u="none" spc="99" strike="noStrike">
                 <a:solidFill>
-                  <a:srgbClr val="747985"/>
+                  <a:srgbClr val="A6ADC8"/>
                 </a:solidFill>
                 <a:effectLst/>
                 <a:uFillTx/>
@@ -5063,7 +5077,7 @@
             </a:r>
             <a:endParaRPr lang="en-US" sz="900" b="0" u="none" strike="noStrike">
               <a:solidFill>
-                <a:srgbClr val="000000"/>
+                <a:srgbClr val="CDD6F4"/>
               </a:solidFill>
               <a:effectLst/>
               <a:uFillTx/>
@@ -5113,7 +5127,7 @@
             <a:r>
               <a:rPr lang="en-US" sz="900" b="0" u="none" strike="noStrike">
                 <a:solidFill>
-                  <a:srgbClr val="999999"/>
+                  <a:srgbClr val="9399B2"/>
                 </a:solidFill>
                 <a:effectLst/>
                 <a:uFillTx/>
@@ -5123,7 +5137,7 @@
             </a:r>
             <a:endParaRPr lang="en-US" sz="900" b="0" u="none" strike="noStrike">
               <a:solidFill>
-                <a:srgbClr val="000000"/>
+                <a:srgbClr val="CDD6F4"/>
               </a:solidFill>
               <a:effectLst/>
               <a:uFillTx/>
@@ -5173,7 +5187,7 @@
             <a:r>
               <a:rPr lang="en-US" sz="1000" b="1" u="none" spc="159" strike="noStrike">
                 <a:solidFill>
-                  <a:srgbClr val="E51D2A"/>
+                  <a:srgbClr val="89B4FA"/>
                 </a:solidFill>
                 <a:effectLst/>
                 <a:uFillTx/>
@@ -5183,7 +5197,7 @@
             </a:r>
             <a:endParaRPr lang="en-US" sz="1000" b="0" u="none" strike="noStrike">
               <a:solidFill>
-                <a:srgbClr val="000000"/>
+                <a:srgbClr val="CDD6F4"/>
               </a:solidFill>
               <a:effectLst/>
               <a:uFillTx/>
@@ -5233,7 +5247,7 @@
             <a:r>
               <a:rPr lang="en-US" sz="3100" b="1" u="none" spc="-51" strike="noStrike">
                 <a:solidFill>
-                  <a:srgbClr val="171923"/>
+                  <a:srgbClr val="CDD6F4"/>
                 </a:solidFill>
                 <a:effectLst/>
                 <a:uFillTx/>
@@ -5243,7 +5257,7 @@
             </a:r>
             <a:endParaRPr lang="en-US" sz="3100" b="0" u="none" strike="noStrike">
               <a:solidFill>
-                <a:srgbClr val="000000"/>
+                <a:srgbClr val="CDD6F4"/>
               </a:solidFill>
               <a:effectLst/>
               <a:uFillTx/>
@@ -5269,11 +5283,11 @@
             </a:avLst>
           </a:prstGeom>
           <a:solidFill>
-            <a:srgbClr val="FFFFFF"/>
+            <a:srgbClr val="313244"/>
           </a:solidFill>
           <a:ln w="12600">
             <a:solidFill>
-              <a:srgbClr val="E8E6E2"/>
+              <a:srgbClr val="45475A"/>
             </a:solidFill>
             <a:round/>
           </a:ln>
@@ -5291,7 +5305,7 @@
           <a:p>
             <a:endParaRPr lang="en-US" sz="1800" b="0" u="none" strike="noStrike">
               <a:solidFill>
-                <a:srgbClr val="000000"/>
+                <a:srgbClr val="CDD6F4"/>
               </a:solidFill>
               <a:effectLst/>
               <a:uFillTx/>
@@ -5341,7 +5355,7 @@
             <a:r>
               <a:rPr lang="en-US" sz="1400" b="1" u="none" spc="40" strike="noStrike">
                 <a:solidFill>
-                  <a:srgbClr val="171923"/>
+                  <a:srgbClr val="CDD6F4"/>
                 </a:solidFill>
                 <a:effectLst/>
                 <a:uFillTx/>
@@ -5351,7 +5365,7 @@
             </a:r>
             <a:endParaRPr lang="en-US" sz="1400" b="0" u="none" strike="noStrike">
               <a:solidFill>
-                <a:srgbClr val="000000"/>
+                <a:srgbClr val="CDD6F4"/>
               </a:solidFill>
               <a:effectLst/>
               <a:uFillTx/>
@@ -5398,7 +5412,7 @@
             <a:r>
               <a:rPr lang="en-US" sz="1300" b="1" u="none" strike="noStrike">
                 <a:solidFill>
-                  <a:srgbClr val="E51D2A"/>
+                  <a:srgbClr val="89B4FA"/>
                 </a:solidFill>
                 <a:effectLst/>
                 <a:uFillTx/>
@@ -5409,7 +5423,7 @@
             <a:r>
               <a:rPr lang="en-US" sz="1050" b="0" u="none" strike="noStrike">
                 <a:solidFill>
-                  <a:srgbClr val="171923"/>
+                  <a:srgbClr val="CDD6F4"/>
                 </a:solidFill>
                 <a:effectLst/>
                 <a:uFillTx/>
@@ -5419,7 +5433,7 @@
             </a:r>
             <a:endParaRPr lang="en-US" sz="1050" b="0" u="none" strike="noStrike">
               <a:solidFill>
-                <a:srgbClr val="000000"/>
+                <a:srgbClr val="CDD6F4"/>
               </a:solidFill>
               <a:effectLst/>
               <a:uFillTx/>
@@ -5438,7 +5452,7 @@
             <a:r>
               <a:rPr lang="en-US" sz="1300" b="1" u="none" strike="noStrike">
                 <a:solidFill>
-                  <a:srgbClr val="E51D2A"/>
+                  <a:srgbClr val="89B4FA"/>
                 </a:solidFill>
                 <a:effectLst/>
                 <a:uFillTx/>
@@ -5449,7 +5463,7 @@
             <a:r>
               <a:rPr lang="en-US" sz="1050" b="0" u="none" strike="noStrike">
                 <a:solidFill>
-                  <a:srgbClr val="171923"/>
+                  <a:srgbClr val="CDD6F4"/>
                 </a:solidFill>
                 <a:effectLst/>
                 <a:uFillTx/>
@@ -5459,7 +5473,7 @@
             </a:r>
             <a:endParaRPr lang="en-US" sz="1050" b="0" u="none" strike="noStrike">
               <a:solidFill>
-                <a:srgbClr val="000000"/>
+                <a:srgbClr val="CDD6F4"/>
               </a:solidFill>
               <a:effectLst/>
               <a:uFillTx/>
@@ -5478,7 +5492,7 @@
             <a:r>
               <a:rPr lang="en-US" sz="1300" b="1" u="none" strike="noStrike">
                 <a:solidFill>
-                  <a:srgbClr val="E51D2A"/>
+                  <a:srgbClr val="89B4FA"/>
                 </a:solidFill>
                 <a:effectLst/>
                 <a:uFillTx/>
@@ -5489,7 +5503,7 @@
             <a:r>
               <a:rPr lang="en-US" sz="1050" b="0" u="none" strike="noStrike">
                 <a:solidFill>
-                  <a:srgbClr val="171923"/>
+                  <a:srgbClr val="CDD6F4"/>
                 </a:solidFill>
                 <a:effectLst/>
                 <a:uFillTx/>
@@ -5499,7 +5513,7 @@
             </a:r>
             <a:endParaRPr lang="en-US" sz="1050" b="0" u="none" strike="noStrike">
               <a:solidFill>
-                <a:srgbClr val="000000"/>
+                <a:srgbClr val="CDD6F4"/>
               </a:solidFill>
               <a:effectLst/>
               <a:uFillTx/>
@@ -5525,11 +5539,11 @@
             </a:avLst>
           </a:prstGeom>
           <a:solidFill>
-            <a:srgbClr val="FFFFFF"/>
+            <a:srgbClr val="313244"/>
           </a:solidFill>
           <a:ln w="12600">
             <a:solidFill>
-              <a:srgbClr val="E8E6E2"/>
+              <a:srgbClr val="45475A"/>
             </a:solidFill>
             <a:round/>
           </a:ln>
@@ -5547,7 +5561,7 @@
           <a:p>
             <a:endParaRPr lang="en-US" sz="1800" b="0" u="none" strike="noStrike">
               <a:solidFill>
-                <a:srgbClr val="000000"/>
+                <a:srgbClr val="CDD6F4"/>
               </a:solidFill>
               <a:effectLst/>
               <a:uFillTx/>
@@ -5597,7 +5611,7 @@
             <a:r>
               <a:rPr lang="en-US" sz="1400" b="1" u="none" spc="40" strike="noStrike">
                 <a:solidFill>
-                  <a:srgbClr val="171923"/>
+                  <a:srgbClr val="CDD6F4"/>
                 </a:solidFill>
                 <a:effectLst/>
                 <a:uFillTx/>
@@ -5607,7 +5621,7 @@
             </a:r>
             <a:endParaRPr lang="en-US" sz="1400" b="0" u="none" strike="noStrike">
               <a:solidFill>
-                <a:srgbClr val="000000"/>
+                <a:srgbClr val="CDD6F4"/>
               </a:solidFill>
               <a:effectLst/>
               <a:uFillTx/>
@@ -5654,7 +5668,7 @@
             <a:r>
               <a:rPr lang="en-US" sz="1300" b="1" u="none" strike="noStrike">
                 <a:solidFill>
-                  <a:srgbClr val="E51D2A"/>
+                  <a:srgbClr val="89B4FA"/>
                 </a:solidFill>
                 <a:effectLst/>
                 <a:uFillTx/>
@@ -5665,7 +5679,7 @@
             <a:r>
               <a:rPr lang="en-US" sz="1050" b="0" u="none" strike="noStrike">
                 <a:solidFill>
-                  <a:srgbClr val="171923"/>
+                  <a:srgbClr val="CDD6F4"/>
                 </a:solidFill>
                 <a:effectLst/>
                 <a:uFillTx/>
@@ -5675,7 +5689,7 @@
             </a:r>
             <a:endParaRPr lang="en-US" sz="1050" b="0" u="none" strike="noStrike">
               <a:solidFill>
-                <a:srgbClr val="000000"/>
+                <a:srgbClr val="CDD6F4"/>
               </a:solidFill>
               <a:effectLst/>
               <a:uFillTx/>
@@ -5694,7 +5708,7 @@
             <a:r>
               <a:rPr lang="en-US" sz="1300" b="1" u="none" strike="noStrike">
                 <a:solidFill>
-                  <a:srgbClr val="E51D2A"/>
+                  <a:srgbClr val="89B4FA"/>
                 </a:solidFill>
                 <a:effectLst/>
                 <a:uFillTx/>
@@ -5705,7 +5719,7 @@
             <a:r>
               <a:rPr lang="en-US" sz="1050" b="0" u="none" strike="noStrike">
                 <a:solidFill>
-                  <a:srgbClr val="171923"/>
+                  <a:srgbClr val="CDD6F4"/>
                 </a:solidFill>
                 <a:effectLst/>
                 <a:uFillTx/>
@@ -5715,7 +5729,7 @@
             </a:r>
             <a:endParaRPr lang="en-US" sz="1050" b="0" u="none" strike="noStrike">
               <a:solidFill>
-                <a:srgbClr val="000000"/>
+                <a:srgbClr val="CDD6F4"/>
               </a:solidFill>
               <a:effectLst/>
               <a:uFillTx/>
@@ -5734,7 +5748,7 @@
             <a:r>
               <a:rPr lang="en-US" sz="1300" b="1" u="none" strike="noStrike">
                 <a:solidFill>
-                  <a:srgbClr val="E51D2A"/>
+                  <a:srgbClr val="89B4FA"/>
                 </a:solidFill>
                 <a:effectLst/>
                 <a:uFillTx/>
@@ -5745,17 +5759,17 @@
             <a:r>
               <a:rPr lang="en-US" sz="1050" b="0" u="none" strike="noStrike">
                 <a:solidFill>
-                  <a:srgbClr val="171923"/>
-                </a:solidFill>
-                <a:effectLst/>
-                <a:uFillTx/>
-                <a:latin typeface="Arial"/>
-              </a:rPr>
-              <a:t>Bộ test tự động 56/56 Use Cases &amp; Ngoại lệ PASS 100%; build nhanh ~740ms.</a:t>
+                  <a:srgbClr val="CDD6F4"/>
+                </a:solidFill>
+                <a:effectLst/>
+                <a:uFillTx/>
+                <a:latin typeface="Arial"/>
+              </a:rPr>
+              <a:t>Bộ test tự động 56/56 Use Cases &amp; Ngoại lệ PASS 100%; Vite build tối ưu ~1s.</a:t>
             </a:r>
             <a:endParaRPr lang="en-US" sz="1050" b="0" u="none" strike="noStrike">
               <a:solidFill>
-                <a:srgbClr val="000000"/>
+                <a:srgbClr val="CDD6F4"/>
               </a:solidFill>
               <a:effectLst/>
               <a:uFillTx/>
@@ -5781,11 +5795,11 @@
             </a:avLst>
           </a:prstGeom>
           <a:solidFill>
-            <a:srgbClr val="FFFFFF"/>
+            <a:srgbClr val="313244"/>
           </a:solidFill>
           <a:ln w="12600">
             <a:solidFill>
-              <a:srgbClr val="E8E6E2"/>
+              <a:srgbClr val="45475A"/>
             </a:solidFill>
             <a:round/>
           </a:ln>
@@ -5803,7 +5817,7 @@
           <a:p>
             <a:endParaRPr lang="en-US" sz="1800" b="0" u="none" strike="noStrike">
               <a:solidFill>
-                <a:srgbClr val="000000"/>
+                <a:srgbClr val="CDD6F4"/>
               </a:solidFill>
               <a:effectLst/>
               <a:uFillTx/>
@@ -5853,7 +5867,7 @@
             <a:r>
               <a:rPr lang="en-US" sz="1400" b="1" u="none" spc="40" strike="noStrike">
                 <a:solidFill>
-                  <a:srgbClr val="171923"/>
+                  <a:srgbClr val="CDD6F4"/>
                 </a:solidFill>
                 <a:effectLst/>
                 <a:uFillTx/>
@@ -5863,7 +5877,7 @@
             </a:r>
             <a:endParaRPr lang="en-US" sz="1400" b="0" u="none" strike="noStrike">
               <a:solidFill>
-                <a:srgbClr val="000000"/>
+                <a:srgbClr val="CDD6F4"/>
               </a:solidFill>
               <a:effectLst/>
               <a:uFillTx/>
@@ -5910,7 +5924,7 @@
             <a:r>
               <a:rPr lang="en-US" sz="1300" b="1" u="none" strike="noStrike">
                 <a:solidFill>
-                  <a:srgbClr val="E51D2A"/>
+                  <a:srgbClr val="89B4FA"/>
                 </a:solidFill>
                 <a:effectLst/>
                 <a:uFillTx/>
@@ -5921,7 +5935,7 @@
             <a:r>
               <a:rPr lang="en-US" sz="1050" b="0" u="none" strike="noStrike">
                 <a:solidFill>
-                  <a:srgbClr val="171923"/>
+                  <a:srgbClr val="CDD6F4"/>
                 </a:solidFill>
                 <a:effectLst/>
                 <a:uFillTx/>
@@ -5931,7 +5945,7 @@
             </a:r>
             <a:endParaRPr lang="en-US" sz="1050" b="0" u="none" strike="noStrike">
               <a:solidFill>
-                <a:srgbClr val="000000"/>
+                <a:srgbClr val="CDD6F4"/>
               </a:solidFill>
               <a:effectLst/>
               <a:uFillTx/>
@@ -5950,7 +5964,7 @@
             <a:r>
               <a:rPr lang="en-US" sz="1300" b="1" u="none" strike="noStrike">
                 <a:solidFill>
-                  <a:srgbClr val="E51D2A"/>
+                  <a:srgbClr val="89B4FA"/>
                 </a:solidFill>
                 <a:effectLst/>
                 <a:uFillTx/>
@@ -5961,7 +5975,7 @@
             <a:r>
               <a:rPr lang="en-US" sz="1050" b="0" u="none" strike="noStrike">
                 <a:solidFill>
-                  <a:srgbClr val="171923"/>
+                  <a:srgbClr val="CDD6F4"/>
                 </a:solidFill>
                 <a:effectLst/>
                 <a:uFillTx/>
@@ -5971,7 +5985,7 @@
             </a:r>
             <a:endParaRPr lang="en-US" sz="1050" b="0" u="none" strike="noStrike">
               <a:solidFill>
-                <a:srgbClr val="000000"/>
+                <a:srgbClr val="CDD6F4"/>
               </a:solidFill>
               <a:effectLst/>
               <a:uFillTx/>
@@ -5990,7 +6004,7 @@
             <a:r>
               <a:rPr lang="en-US" sz="1300" b="1" u="none" strike="noStrike">
                 <a:solidFill>
-                  <a:srgbClr val="E51D2A"/>
+                  <a:srgbClr val="89B4FA"/>
                 </a:solidFill>
                 <a:effectLst/>
                 <a:uFillTx/>
@@ -6001,7 +6015,7 @@
             <a:r>
               <a:rPr lang="en-US" sz="1050" b="0" u="none" strike="noStrike">
                 <a:solidFill>
-                  <a:srgbClr val="171923"/>
+                  <a:srgbClr val="CDD6F4"/>
                 </a:solidFill>
                 <a:effectLst/>
                 <a:uFillTx/>
@@ -6011,7 +6025,7 @@
             </a:r>
             <a:endParaRPr lang="en-US" sz="1050" b="0" u="none" strike="noStrike">
               <a:solidFill>
-                <a:srgbClr val="000000"/>
+                <a:srgbClr val="CDD6F4"/>
               </a:solidFill>
               <a:effectLst/>
               <a:uFillTx/>
@@ -6037,11 +6051,11 @@
             </a:avLst>
           </a:prstGeom>
           <a:solidFill>
-            <a:srgbClr val="FFFFFF"/>
+            <a:srgbClr val="313244"/>
           </a:solidFill>
           <a:ln w="12600">
             <a:solidFill>
-              <a:srgbClr val="E8E6E2"/>
+              <a:srgbClr val="45475A"/>
             </a:solidFill>
             <a:round/>
           </a:ln>
@@ -6059,7 +6073,7 @@
           <a:p>
             <a:endParaRPr lang="en-US" sz="1800" b="0" u="none" strike="noStrike">
               <a:solidFill>
-                <a:srgbClr val="000000"/>
+                <a:srgbClr val="CDD6F4"/>
               </a:solidFill>
               <a:effectLst/>
               <a:uFillTx/>
@@ -6109,7 +6123,7 @@
             <a:r>
               <a:rPr lang="en-US" sz="1400" b="1" u="none" spc="40" strike="noStrike">
                 <a:solidFill>
-                  <a:srgbClr val="171923"/>
+                  <a:srgbClr val="CDD6F4"/>
                 </a:solidFill>
                 <a:effectLst/>
                 <a:uFillTx/>
@@ -6119,7 +6133,7 @@
             </a:r>
             <a:endParaRPr lang="en-US" sz="1400" b="0" u="none" strike="noStrike">
               <a:solidFill>
-                <a:srgbClr val="000000"/>
+                <a:srgbClr val="CDD6F4"/>
               </a:solidFill>
               <a:effectLst/>
               <a:uFillTx/>
@@ -6166,7 +6180,7 @@
             <a:r>
               <a:rPr lang="en-US" sz="1300" b="1" u="none" strike="noStrike">
                 <a:solidFill>
-                  <a:srgbClr val="E51D2A"/>
+                  <a:srgbClr val="89B4FA"/>
                 </a:solidFill>
                 <a:effectLst/>
                 <a:uFillTx/>
@@ -6177,7 +6191,7 @@
             <a:r>
               <a:rPr lang="en-US" sz="1050" b="0" u="none" strike="noStrike">
                 <a:solidFill>
-                  <a:srgbClr val="171923"/>
+                  <a:srgbClr val="CDD6F4"/>
                 </a:solidFill>
                 <a:effectLst/>
                 <a:uFillTx/>
@@ -6187,7 +6201,7 @@
             </a:r>
             <a:endParaRPr lang="en-US" sz="1050" b="0" u="none" strike="noStrike">
               <a:solidFill>
-                <a:srgbClr val="000000"/>
+                <a:srgbClr val="CDD6F4"/>
               </a:solidFill>
               <a:effectLst/>
               <a:uFillTx/>
@@ -6206,7 +6220,7 @@
             <a:r>
               <a:rPr lang="en-US" sz="1300" b="1" u="none" strike="noStrike">
                 <a:solidFill>
-                  <a:srgbClr val="E51D2A"/>
+                  <a:srgbClr val="89B4FA"/>
                 </a:solidFill>
                 <a:effectLst/>
                 <a:uFillTx/>
@@ -6217,7 +6231,7 @@
             <a:r>
               <a:rPr lang="en-US" sz="1050" b="0" u="none" strike="noStrike">
                 <a:solidFill>
-                  <a:srgbClr val="171923"/>
+                  <a:srgbClr val="CDD6F4"/>
                 </a:solidFill>
                 <a:effectLst/>
                 <a:uFillTx/>
@@ -6227,7 +6241,7 @@
             </a:r>
             <a:endParaRPr lang="en-US" sz="1050" b="0" u="none" strike="noStrike">
               <a:solidFill>
-                <a:srgbClr val="000000"/>
+                <a:srgbClr val="CDD6F4"/>
               </a:solidFill>
               <a:effectLst/>
               <a:uFillTx/>
@@ -6246,7 +6260,7 @@
             <a:r>
               <a:rPr lang="en-US" sz="1300" b="1" u="none" strike="noStrike">
                 <a:solidFill>
-                  <a:srgbClr val="E51D2A"/>
+                  <a:srgbClr val="89B4FA"/>
                 </a:solidFill>
                 <a:effectLst/>
                 <a:uFillTx/>
@@ -6257,7 +6271,7 @@
             <a:r>
               <a:rPr lang="en-US" sz="1050" b="0" u="none" strike="noStrike">
                 <a:solidFill>
-                  <a:srgbClr val="171923"/>
+                  <a:srgbClr val="CDD6F4"/>
                 </a:solidFill>
                 <a:effectLst/>
                 <a:uFillTx/>
@@ -6267,7 +6281,7 @@
             </a:r>
             <a:endParaRPr lang="en-US" sz="1050" b="0" u="none" strike="noStrike">
               <a:solidFill>
-                <a:srgbClr val="000000"/>
+                <a:srgbClr val="CDD6F4"/>
               </a:solidFill>
               <a:effectLst/>
               <a:uFillTx/>
@@ -6317,7 +6331,7 @@
             <a:r>
               <a:rPr lang="en-US" sz="900" b="0" u="none" strike="noStrike">
                 <a:solidFill>
-                  <a:srgbClr val="747985"/>
+                  <a:srgbClr val="A6ADC8"/>
                 </a:solidFill>
                 <a:effectLst/>
                 <a:uFillTx/>
@@ -6327,7 +6341,7 @@
             </a:r>
             <a:endParaRPr lang="en-US" sz="900" b="0" u="none" strike="noStrike">
               <a:solidFill>
-                <a:srgbClr val="000000"/>
+                <a:srgbClr val="CDD6F4"/>
               </a:solidFill>
               <a:effectLst/>
               <a:uFillTx/>
@@ -6355,7 +6369,7 @@
     <p:bg>
       <p:bgPr>
         <a:solidFill>
-          <a:srgbClr val="F4F2EF"/>
+          <a:srgbClr val="1E1E2E"/>
         </a:solidFill>
       </p:bgPr>
     </p:bg>
@@ -6388,11 +6402,11 @@
             <a:avLst/>
           </a:prstGeom>
           <a:solidFill>
-            <a:srgbClr val="E51D2A"/>
+            <a:srgbClr val="89B4FA"/>
           </a:solidFill>
           <a:ln w="12600">
             <a:solidFill>
-              <a:srgbClr val="E51D2A">
+              <a:srgbClr val="89B4FA">
                 <a:alpha val="0"/>
               </a:srgbClr>
             </a:solidFill>
@@ -6462,7 +6476,7 @@
             <a:r>
               <a:rPr lang="en-US" sz="1000" b="1" u="none" spc="150" strike="noStrike">
                 <a:solidFill>
-                  <a:srgbClr val="E51D2A"/>
+                  <a:srgbClr val="89B4FA"/>
                 </a:solidFill>
                 <a:effectLst/>
                 <a:uFillTx/>
@@ -6472,7 +6486,7 @@
             </a:r>
             <a:endParaRPr lang="en-US" sz="1000" b="0" u="none" strike="noStrike">
               <a:solidFill>
-                <a:srgbClr val="000000"/>
+                <a:srgbClr val="CDD6F4"/>
               </a:solidFill>
               <a:effectLst/>
               <a:uFillTx/>
@@ -6522,7 +6536,7 @@
             <a:r>
               <a:rPr lang="en-US" sz="900" b="1" u="none" spc="99" strike="noStrike">
                 <a:solidFill>
-                  <a:srgbClr val="747985"/>
+                  <a:srgbClr val="A6ADC8"/>
                 </a:solidFill>
                 <a:effectLst/>
                 <a:uFillTx/>
@@ -6532,7 +6546,7 @@
             </a:r>
             <a:endParaRPr lang="en-US" sz="900" b="0" u="none" strike="noStrike">
               <a:solidFill>
-                <a:srgbClr val="000000"/>
+                <a:srgbClr val="CDD6F4"/>
               </a:solidFill>
               <a:effectLst/>
               <a:uFillTx/>
@@ -6582,7 +6596,7 @@
             <a:r>
               <a:rPr lang="en-US" sz="900" b="0" u="none" strike="noStrike">
                 <a:solidFill>
-                  <a:srgbClr val="999999"/>
+                  <a:srgbClr val="9399B2"/>
                 </a:solidFill>
                 <a:effectLst/>
                 <a:uFillTx/>
@@ -6592,7 +6606,7 @@
             </a:r>
             <a:endParaRPr lang="en-US" sz="900" b="0" u="none" strike="noStrike">
               <a:solidFill>
-                <a:srgbClr val="000000"/>
+                <a:srgbClr val="CDD6F4"/>
               </a:solidFill>
               <a:effectLst/>
               <a:uFillTx/>
@@ -6642,7 +6656,7 @@
             <a:r>
               <a:rPr lang="en-US" sz="1000" b="1" u="none" spc="159" strike="noStrike">
                 <a:solidFill>
-                  <a:srgbClr val="E51D2A"/>
+                  <a:srgbClr val="89B4FA"/>
                 </a:solidFill>
                 <a:effectLst/>
                 <a:uFillTx/>
@@ -6652,7 +6666,7 @@
             </a:r>
             <a:endParaRPr lang="en-US" sz="1000" b="0" u="none" strike="noStrike">
               <a:solidFill>
-                <a:srgbClr val="000000"/>
+                <a:srgbClr val="CDD6F4"/>
               </a:solidFill>
               <a:effectLst/>
               <a:uFillTx/>
@@ -6702,7 +6716,7 @@
             <a:r>
               <a:rPr lang="en-US" sz="3100" b="1" u="none" spc="-51" strike="noStrike">
                 <a:solidFill>
-                  <a:srgbClr val="171923"/>
+                  <a:srgbClr val="CDD6F4"/>
                 </a:solidFill>
                 <a:effectLst/>
                 <a:uFillTx/>
@@ -6712,7 +6726,7 @@
             </a:r>
             <a:endParaRPr lang="en-US" sz="3100" b="0" u="none" strike="noStrike">
               <a:solidFill>
-                <a:srgbClr val="000000"/>
+                <a:srgbClr val="CDD6F4"/>
               </a:solidFill>
               <a:effectLst/>
               <a:uFillTx/>
@@ -6738,11 +6752,11 @@
             </a:avLst>
           </a:prstGeom>
           <a:solidFill>
-            <a:srgbClr val="FFFFFF"/>
+            <a:srgbClr val="313244"/>
           </a:solidFill>
           <a:ln w="12600">
             <a:solidFill>
-              <a:srgbClr val="E8E6E2"/>
+              <a:srgbClr val="45475A"/>
             </a:solidFill>
             <a:round/>
           </a:ln>
@@ -6760,7 +6774,7 @@
           <a:p>
             <a:endParaRPr lang="en-US" sz="1800" b="0" u="none" strike="noStrike">
               <a:solidFill>
-                <a:srgbClr val="000000"/>
+                <a:srgbClr val="CDD6F4"/>
               </a:solidFill>
               <a:effectLst/>
               <a:uFillTx/>
@@ -6810,7 +6824,7 @@
             <a:r>
               <a:rPr lang="en-US" sz="1300" b="1" u="none" strike="noStrike">
                 <a:solidFill>
-                  <a:srgbClr val="E51D2A"/>
+                  <a:srgbClr val="89B4FA"/>
                 </a:solidFill>
                 <a:effectLst/>
                 <a:uFillTx/>
@@ -6820,7 +6834,7 @@
             </a:r>
             <a:endParaRPr lang="en-US" sz="1300" b="0" u="none" strike="noStrike">
               <a:solidFill>
-                <a:srgbClr val="000000"/>
+                <a:srgbClr val="CDD6F4"/>
               </a:solidFill>
               <a:effectLst/>
               <a:uFillTx/>
@@ -6870,7 +6884,7 @@
             <a:r>
               <a:rPr lang="en-US" sz="900" b="0" u="none" strike="noStrike">
                 <a:solidFill>
-                  <a:srgbClr val="747985"/>
+                  <a:srgbClr val="A6ADC8"/>
                 </a:solidFill>
                 <a:effectLst/>
                 <a:uFillTx/>
@@ -6880,7 +6894,7 @@
             </a:r>
             <a:endParaRPr lang="en-US" sz="900" b="0" u="none" strike="noStrike">
               <a:solidFill>
-                <a:srgbClr val="000000"/>
+                <a:srgbClr val="CDD6F4"/>
               </a:solidFill>
               <a:effectLst/>
               <a:uFillTx/>
@@ -6906,11 +6920,11 @@
             </a:avLst>
           </a:prstGeom>
           <a:solidFill>
-            <a:srgbClr val="FFFFFF"/>
+            <a:srgbClr val="313244"/>
           </a:solidFill>
           <a:ln w="12600">
             <a:solidFill>
-              <a:srgbClr val="E8E6E2"/>
+              <a:srgbClr val="45475A"/>
             </a:solidFill>
             <a:round/>
           </a:ln>
@@ -6928,7 +6942,7 @@
           <a:p>
             <a:endParaRPr lang="en-US" sz="1800" b="0" u="none" strike="noStrike">
               <a:solidFill>
-                <a:srgbClr val="000000"/>
+                <a:srgbClr val="CDD6F4"/>
               </a:solidFill>
               <a:effectLst/>
               <a:uFillTx/>
@@ -6978,7 +6992,7 @@
             <a:r>
               <a:rPr lang="en-US" sz="1300" b="1" u="none" strike="noStrike">
                 <a:solidFill>
-                  <a:srgbClr val="E51D2A"/>
+                  <a:srgbClr val="89B4FA"/>
                 </a:solidFill>
                 <a:effectLst/>
                 <a:uFillTx/>
@@ -6988,7 +7002,7 @@
             </a:r>
             <a:endParaRPr lang="en-US" sz="1300" b="0" u="none" strike="noStrike">
               <a:solidFill>
-                <a:srgbClr val="000000"/>
+                <a:srgbClr val="CDD6F4"/>
               </a:solidFill>
               <a:effectLst/>
               <a:uFillTx/>
@@ -7038,7 +7052,7 @@
             <a:r>
               <a:rPr lang="en-US" sz="900" b="0" u="none" strike="noStrike">
                 <a:solidFill>
-                  <a:srgbClr val="747985"/>
+                  <a:srgbClr val="A6ADC8"/>
                 </a:solidFill>
                 <a:effectLst/>
                 <a:uFillTx/>
@@ -7048,7 +7062,7 @@
             </a:r>
             <a:endParaRPr lang="en-US" sz="900" b="0" u="none" strike="noStrike">
               <a:solidFill>
-                <a:srgbClr val="000000"/>
+                <a:srgbClr val="CDD6F4"/>
               </a:solidFill>
               <a:effectLst/>
               <a:uFillTx/>
@@ -7074,11 +7088,11 @@
             </a:avLst>
           </a:prstGeom>
           <a:solidFill>
-            <a:srgbClr val="FFFFFF"/>
+            <a:srgbClr val="313244"/>
           </a:solidFill>
           <a:ln w="12600">
             <a:solidFill>
-              <a:srgbClr val="E8E6E2"/>
+              <a:srgbClr val="45475A"/>
             </a:solidFill>
             <a:round/>
           </a:ln>
@@ -7096,7 +7110,7 @@
           <a:p>
             <a:endParaRPr lang="en-US" sz="1800" b="0" u="none" strike="noStrike">
               <a:solidFill>
-                <a:srgbClr val="000000"/>
+                <a:srgbClr val="CDD6F4"/>
               </a:solidFill>
               <a:effectLst/>
               <a:uFillTx/>
@@ -7146,7 +7160,7 @@
             <a:r>
               <a:rPr lang="en-US" sz="1300" b="1" u="none" strike="noStrike">
                 <a:solidFill>
-                  <a:srgbClr val="E51D2A"/>
+                  <a:srgbClr val="89B4FA"/>
                 </a:solidFill>
                 <a:effectLst/>
                 <a:uFillTx/>
@@ -7156,7 +7170,7 @@
             </a:r>
             <a:endParaRPr lang="en-US" sz="1300" b="0" u="none" strike="noStrike">
               <a:solidFill>
-                <a:srgbClr val="000000"/>
+                <a:srgbClr val="CDD6F4"/>
               </a:solidFill>
               <a:effectLst/>
               <a:uFillTx/>
@@ -7206,7 +7220,7 @@
             <a:r>
               <a:rPr lang="en-US" sz="900" b="0" u="none" strike="noStrike">
                 <a:solidFill>
-                  <a:srgbClr val="747985"/>
+                  <a:srgbClr val="A6ADC8"/>
                 </a:solidFill>
                 <a:effectLst/>
                 <a:uFillTx/>
@@ -7216,7 +7230,7 @@
             </a:r>
             <a:endParaRPr lang="en-US" sz="900" b="0" u="none" strike="noStrike">
               <a:solidFill>
-                <a:srgbClr val="000000"/>
+                <a:srgbClr val="CDD6F4"/>
               </a:solidFill>
               <a:effectLst/>
               <a:uFillTx/>
@@ -7242,11 +7256,11 @@
             </a:avLst>
           </a:prstGeom>
           <a:solidFill>
-            <a:srgbClr val="FFFFFF"/>
+            <a:srgbClr val="313244"/>
           </a:solidFill>
           <a:ln w="12600">
             <a:solidFill>
-              <a:srgbClr val="E8E6E2"/>
+              <a:srgbClr val="45475A"/>
             </a:solidFill>
             <a:round/>
           </a:ln>
@@ -7264,7 +7278,7 @@
           <a:p>
             <a:endParaRPr lang="en-US" sz="1800" b="0" u="none" strike="noStrike">
               <a:solidFill>
-                <a:srgbClr val="000000"/>
+                <a:srgbClr val="CDD6F4"/>
               </a:solidFill>
               <a:effectLst/>
               <a:uFillTx/>
@@ -7314,7 +7328,7 @@
             <a:r>
               <a:rPr lang="en-US" sz="1300" b="1" u="none" strike="noStrike">
                 <a:solidFill>
-                  <a:srgbClr val="E51D2A"/>
+                  <a:srgbClr val="89B4FA"/>
                 </a:solidFill>
                 <a:effectLst/>
                 <a:uFillTx/>
@@ -7324,7 +7338,7 @@
             </a:r>
             <a:endParaRPr lang="en-US" sz="1300" b="0" u="none" strike="noStrike">
               <a:solidFill>
-                <a:srgbClr val="000000"/>
+                <a:srgbClr val="CDD6F4"/>
               </a:solidFill>
               <a:effectLst/>
               <a:uFillTx/>
@@ -7374,7 +7388,7 @@
             <a:r>
               <a:rPr lang="en-US" sz="900" b="0" u="none" strike="noStrike">
                 <a:solidFill>
-                  <a:srgbClr val="747985"/>
+                  <a:srgbClr val="A6ADC8"/>
                 </a:solidFill>
                 <a:effectLst/>
                 <a:uFillTx/>
@@ -7384,7 +7398,7 @@
             </a:r>
             <a:endParaRPr lang="en-US" sz="900" b="0" u="none" strike="noStrike">
               <a:solidFill>
-                <a:srgbClr val="000000"/>
+                <a:srgbClr val="CDD6F4"/>
               </a:solidFill>
               <a:effectLst/>
               <a:uFillTx/>
@@ -7434,7 +7448,7 @@
             <a:r>
               <a:rPr lang="en-US" sz="900" b="1" u="none" spc="99" strike="noStrike">
                 <a:solidFill>
-                  <a:srgbClr val="E51D2A"/>
+                  <a:srgbClr val="89B4FA"/>
                 </a:solidFill>
                 <a:effectLst/>
                 <a:uFillTx/>
@@ -7444,7 +7458,7 @@
             </a:r>
             <a:endParaRPr lang="en-US" sz="900" b="0" u="none" strike="noStrike">
               <a:solidFill>
-                <a:srgbClr val="000000"/>
+                <a:srgbClr val="CDD6F4"/>
               </a:solidFill>
               <a:effectLst/>
               <a:uFillTx/>
@@ -7491,17 +7505,17 @@
             <a:r>
               <a:rPr lang="en-US" sz="1500" b="1" u="none" strike="noStrike">
                 <a:solidFill>
-                  <a:srgbClr val="171923"/>
-                </a:solidFill>
-                <a:effectLst/>
-                <a:uFillTx/>
-                <a:latin typeface="Arial"/>
-              </a:rPr>
-              <a:t>• Khách hàng: Home · movies · detail · schedule · cinemas · pricing · news · booking · checkout · member · profile.</a:t>
+                  <a:srgbClr val="CDD6F4"/>
+                </a:solidFill>
+                <a:effectLst/>
+                <a:uFillTx/>
+                <a:latin typeface="Arial"/>
+              </a:rPr>
+              <a:t>• Khách hàng (11 trang): Home · movies · detail · schedule · cinemas · pricing · news · booking · checkout · member · profile.</a:t>
             </a:r>
             <a:endParaRPr lang="en-US" sz="1500" b="0" u="none" strike="noStrike">
               <a:solidFill>
-                <a:srgbClr val="000000"/>
+                <a:srgbClr val="CDD6F4"/>
               </a:solidFill>
               <a:effectLst/>
               <a:uFillTx/>
@@ -7520,17 +7534,17 @@
             <a:r>
               <a:rPr lang="en-US" sz="1500" b="1" u="none" strike="noStrike">
                 <a:solidFill>
-                  <a:srgbClr val="171923"/>
-                </a:solidFill>
-                <a:effectLst/>
-                <a:uFillTx/>
-                <a:latin typeface="Arial"/>
-              </a:rPr>
-              <a:t>• Quản trị &amp; Tiện ích: admin (Dashboard &amp; Soát vé QR) · 404 · error.</a:t>
+                  <a:srgbClr val="CDD6F4"/>
+                </a:solidFill>
+                <a:effectLst/>
+                <a:uFillTx/>
+                <a:latin typeface="Arial"/>
+              </a:rPr>
+              <a:t>• Quản trị &amp; Tiện ích (3 trang): admin (Dashboard KPI, 8 Tabs quản lý &amp; Soát vé QR) · 404 · error.</a:t>
             </a:r>
             <a:endParaRPr lang="en-US" sz="1500" b="0" u="none" strike="noStrike">
               <a:solidFill>
-                <a:srgbClr val="000000"/>
+                <a:srgbClr val="CDD6F4"/>
               </a:solidFill>
               <a:effectLst/>
               <a:uFillTx/>
@@ -7555,7 +7569,7 @@
           </a:prstGeom>
           <a:ln w="12600">
             <a:solidFill>
-              <a:srgbClr val="E8E6E2"/>
+              <a:srgbClr val="45475A"/>
             </a:solidFill>
             <a:round/>
           </a:ln>
@@ -7573,7 +7587,7 @@
           <a:p>
             <a:endParaRPr lang="en-US" sz="1800" b="0" u="none" strike="noStrike">
               <a:solidFill>
-                <a:srgbClr val="000000"/>
+                <a:srgbClr val="CDD6F4"/>
               </a:solidFill>
               <a:effectLst/>
               <a:uFillTx/>
@@ -7623,7 +7637,7 @@
             <a:r>
               <a:rPr lang="en-US" sz="900" b="1" u="none" spc="99" strike="noStrike">
                 <a:solidFill>
-                  <a:srgbClr val="E51D2A"/>
+                  <a:srgbClr val="89B4FA"/>
                 </a:solidFill>
                 <a:effectLst/>
                 <a:uFillTx/>
@@ -7633,7 +7647,7 @@
             </a:r>
             <a:endParaRPr lang="en-US" sz="900" b="0" u="none" strike="noStrike">
               <a:solidFill>
-                <a:srgbClr val="000000"/>
+                <a:srgbClr val="CDD6F4"/>
               </a:solidFill>
               <a:effectLst/>
               <a:uFillTx/>
@@ -7680,17 +7694,17 @@
             <a:r>
               <a:rPr lang="en-US" sz="1500" b="1" u="none" strike="noStrike">
                 <a:solidFill>
-                  <a:srgbClr val="171923"/>
-                </a:solidFill>
-                <a:effectLst/>
-                <a:uFillTx/>
-                <a:latin typeface="Arial"/>
-              </a:rPr>
-              <a:t>• Thực thể: movies (11 phim) · cinemas (10 rạp) · showtimes · concessions · vouchers · bookings · users.</a:t>
+                  <a:srgbClr val="CDD6F4"/>
+                </a:solidFill>
+                <a:effectLst/>
+                <a:uFillTx/>
+                <a:latin typeface="Arial"/>
+              </a:rPr>
+              <a:t>• Thực thể: movies (11 phim) · cinemas (10 rạp) · showtimes (11 ngày) · concessions (11 món) · vouchers · bookings · users.</a:t>
             </a:r>
             <a:endParaRPr lang="en-US" sz="1500" b="0" u="none" strike="noStrike">
               <a:solidFill>
-                <a:srgbClr val="000000"/>
+                <a:srgbClr val="CDD6F4"/>
               </a:solidFill>
               <a:effectLst/>
               <a:uFillTx/>
@@ -7709,7 +7723,7 @@
             <a:r>
               <a:rPr lang="en-US" sz="1500" b="1" u="none" strike="noStrike">
                 <a:solidFill>
-                  <a:srgbClr val="171923"/>
+                  <a:srgbClr val="CDD6F4"/>
                 </a:solidFill>
                 <a:effectLst/>
                 <a:uFillTx/>
@@ -7719,7 +7733,7 @@
             </a:r>
             <a:endParaRPr lang="en-US" sz="1500" b="0" u="none" strike="noStrike">
               <a:solidFill>
-                <a:srgbClr val="000000"/>
+                <a:srgbClr val="CDD6F4"/>
               </a:solidFill>
               <a:effectLst/>
               <a:uFillTx/>
@@ -7744,7 +7758,7 @@
           </a:prstGeom>
           <a:ln w="12600">
             <a:solidFill>
-              <a:srgbClr val="E8E6E2"/>
+              <a:srgbClr val="45475A"/>
             </a:solidFill>
             <a:round/>
           </a:ln>
@@ -7762,7 +7776,7 @@
           <a:p>
             <a:endParaRPr lang="en-US" sz="1800" b="0" u="none" strike="noStrike">
               <a:solidFill>
-                <a:srgbClr val="000000"/>
+                <a:srgbClr val="CDD6F4"/>
               </a:solidFill>
               <a:effectLst/>
               <a:uFillTx/>
@@ -7812,7 +7826,7 @@
             <a:r>
               <a:rPr lang="en-US" sz="900" b="1" u="none" spc="99" strike="noStrike">
                 <a:solidFill>
-                  <a:srgbClr val="E51D2A"/>
+                  <a:srgbClr val="89B4FA"/>
                 </a:solidFill>
                 <a:effectLst/>
                 <a:uFillTx/>
@@ -7822,7 +7836,7 @@
             </a:r>
             <a:endParaRPr lang="en-US" sz="900" b="0" u="none" strike="noStrike">
               <a:solidFill>
-                <a:srgbClr val="000000"/>
+                <a:srgbClr val="CDD6F4"/>
               </a:solidFill>
               <a:effectLst/>
               <a:uFillTx/>
@@ -7869,17 +7883,17 @@
             <a:r>
               <a:rPr lang="en-US" sz="1500" b="1" u="none" strike="noStrike">
                 <a:solidFill>
-                  <a:srgbClr val="171923"/>
-                </a:solidFill>
-                <a:effectLst/>
-                <a:uFillTx/>
-                <a:latin typeface="Arial"/>
-              </a:rPr>
-              <a:t>• Phân quyền tài khoản User / Admin với JWT token.</a:t>
+                  <a:srgbClr val="CDD6F4"/>
+                </a:solidFill>
+                <a:effectLst/>
+                <a:uFillTx/>
+                <a:latin typeface="Arial"/>
+              </a:rPr>
+              <a:t>• Phân quyền tài khoản User / Quản trị viên bằng JWT Token bảo mật.</a:t>
             </a:r>
             <a:endParaRPr lang="en-US" sz="1500" b="0" u="none" strike="noStrike">
               <a:solidFill>
-                <a:srgbClr val="000000"/>
+                <a:srgbClr val="CDD6F4"/>
               </a:solidFill>
               <a:effectLst/>
               <a:uFillTx/>
@@ -7898,7 +7912,7 @@
             <a:r>
               <a:rPr lang="en-US" sz="1500" b="1" u="none" strike="noStrike">
                 <a:solidFill>
-                  <a:srgbClr val="171923"/>
+                  <a:srgbClr val="CDD6F4"/>
                 </a:solidFill>
                 <a:effectLst/>
                 <a:uFillTx/>
@@ -7908,7 +7922,7 @@
             </a:r>
             <a:endParaRPr lang="en-US" sz="1500" b="0" u="none" strike="noStrike">
               <a:solidFill>
-                <a:srgbClr val="000000"/>
+                <a:srgbClr val="CDD6F4"/>
               </a:solidFill>
               <a:effectLst/>
               <a:uFillTx/>
@@ -7933,7 +7947,7 @@
           </a:prstGeom>
           <a:ln w="12600">
             <a:solidFill>
-              <a:srgbClr val="E8E6E2"/>
+              <a:srgbClr val="45475A"/>
             </a:solidFill>
             <a:round/>
           </a:ln>
@@ -7951,7 +7965,7 @@
           <a:p>
             <a:endParaRPr lang="en-US" sz="1800" b="0" u="none" strike="noStrike">
               <a:solidFill>
-                <a:srgbClr val="000000"/>
+                <a:srgbClr val="CDD6F4"/>
               </a:solidFill>
               <a:effectLst/>
               <a:uFillTx/>
@@ -7977,11 +7991,11 @@
             </a:avLst>
           </a:prstGeom>
           <a:solidFill>
-            <a:srgbClr val="FFFFFF"/>
+            <a:srgbClr val="313244"/>
           </a:solidFill>
           <a:ln w="12600">
             <a:solidFill>
-              <a:srgbClr val="E8E6E2"/>
+              <a:srgbClr val="45475A"/>
             </a:solidFill>
             <a:round/>
           </a:ln>
@@ -7999,7 +8013,7 @@
           <a:p>
             <a:endParaRPr lang="en-US" sz="1800" b="0" u="none" strike="noStrike">
               <a:solidFill>
-                <a:srgbClr val="000000"/>
+                <a:srgbClr val="CDD6F4"/>
               </a:solidFill>
               <a:effectLst/>
               <a:uFillTx/>
@@ -8027,11 +8041,11 @@
             <a:avLst/>
           </a:prstGeom>
           <a:solidFill>
-            <a:srgbClr val="FFFFFF"/>
+            <a:srgbClr val="313244"/>
           </a:solidFill>
           <a:ln w="12600">
             <a:solidFill>
-              <a:srgbClr val="E8E6E2"/>
+              <a:srgbClr val="45475A"/>
             </a:solidFill>
             <a:round/>
           </a:ln>
@@ -8056,7 +8070,7 @@
     <p:bg>
       <p:bgPr>
         <a:solidFill>
-          <a:srgbClr val="F4F2EF"/>
+          <a:srgbClr val="1E1E2E"/>
         </a:solidFill>
       </p:bgPr>
     </p:bg>
@@ -8089,11 +8103,11 @@
             <a:avLst/>
           </a:prstGeom>
           <a:solidFill>
-            <a:srgbClr val="E51D2A"/>
+            <a:srgbClr val="89B4FA"/>
           </a:solidFill>
           <a:ln w="12600">
             <a:solidFill>
-              <a:srgbClr val="E51D2A">
+              <a:srgbClr val="89B4FA">
                 <a:alpha val="0"/>
               </a:srgbClr>
             </a:solidFill>
@@ -8163,7 +8177,7 @@
             <a:r>
               <a:rPr lang="en-US" sz="1000" b="1" u="none" spc="150" strike="noStrike">
                 <a:solidFill>
-                  <a:srgbClr val="E51D2A"/>
+                  <a:srgbClr val="89B4FA"/>
                 </a:solidFill>
                 <a:effectLst/>
                 <a:uFillTx/>
@@ -8173,7 +8187,7 @@
             </a:r>
             <a:endParaRPr lang="en-US" sz="1000" b="0" u="none" strike="noStrike">
               <a:solidFill>
-                <a:srgbClr val="000000"/>
+                <a:srgbClr val="CDD6F4"/>
               </a:solidFill>
               <a:effectLst/>
               <a:uFillTx/>
@@ -8223,7 +8237,7 @@
             <a:r>
               <a:rPr lang="en-US" sz="900" b="1" u="none" spc="99" strike="noStrike">
                 <a:solidFill>
-                  <a:srgbClr val="747985"/>
+                  <a:srgbClr val="A6ADC8"/>
                 </a:solidFill>
                 <a:effectLst/>
                 <a:uFillTx/>
@@ -8233,7 +8247,7 @@
             </a:r>
             <a:endParaRPr lang="en-US" sz="900" b="0" u="none" strike="noStrike">
               <a:solidFill>
-                <a:srgbClr val="000000"/>
+                <a:srgbClr val="CDD6F4"/>
               </a:solidFill>
               <a:effectLst/>
               <a:uFillTx/>
@@ -8283,7 +8297,7 @@
             <a:r>
               <a:rPr lang="en-US" sz="900" b="0" u="none" strike="noStrike">
                 <a:solidFill>
-                  <a:srgbClr val="999999"/>
+                  <a:srgbClr val="9399B2"/>
                 </a:solidFill>
                 <a:effectLst/>
                 <a:uFillTx/>
@@ -8293,7 +8307,7 @@
             </a:r>
             <a:endParaRPr lang="en-US" sz="900" b="0" u="none" strike="noStrike">
               <a:solidFill>
-                <a:srgbClr val="000000"/>
+                <a:srgbClr val="CDD6F4"/>
               </a:solidFill>
               <a:effectLst/>
               <a:uFillTx/>
@@ -8343,7 +8357,7 @@
             <a:r>
               <a:rPr lang="en-US" sz="1000" b="1" u="none" spc="159" strike="noStrike">
                 <a:solidFill>
-                  <a:srgbClr val="E51D2A"/>
+                  <a:srgbClr val="89B4FA"/>
                 </a:solidFill>
                 <a:effectLst/>
                 <a:uFillTx/>
@@ -8353,7 +8367,7 @@
             </a:r>
             <a:endParaRPr lang="en-US" sz="1000" b="0" u="none" strike="noStrike">
               <a:solidFill>
-                <a:srgbClr val="000000"/>
+                <a:srgbClr val="CDD6F4"/>
               </a:solidFill>
               <a:effectLst/>
               <a:uFillTx/>
@@ -8403,7 +8417,7 @@
             <a:r>
               <a:rPr lang="en-US" sz="3100" b="1" u="none" spc="-51" strike="noStrike">
                 <a:solidFill>
-                  <a:srgbClr val="171923"/>
+                  <a:srgbClr val="CDD6F4"/>
                 </a:solidFill>
                 <a:effectLst/>
                 <a:uFillTx/>
@@ -8413,7 +8427,7 @@
             </a:r>
             <a:endParaRPr lang="en-US" sz="3100" b="0" u="none" strike="noStrike">
               <a:solidFill>
-                <a:srgbClr val="000000"/>
+                <a:srgbClr val="CDD6F4"/>
               </a:solidFill>
               <a:effectLst/>
               <a:uFillTx/>
@@ -8439,11 +8453,11 @@
             </a:avLst>
           </a:prstGeom>
           <a:solidFill>
-            <a:srgbClr val="FFFFFF"/>
+            <a:srgbClr val="313244"/>
           </a:solidFill>
           <a:ln w="12600">
             <a:solidFill>
-              <a:srgbClr val="E8E6E2"/>
+              <a:srgbClr val="45475A"/>
             </a:solidFill>
             <a:round/>
           </a:ln>
@@ -8461,7 +8475,7 @@
           <a:p>
             <a:endParaRPr lang="en-US" sz="1800" b="0" u="none" strike="noStrike">
               <a:solidFill>
-                <a:srgbClr val="000000"/>
+                <a:srgbClr val="CDD6F4"/>
               </a:solidFill>
               <a:effectLst/>
               <a:uFillTx/>
@@ -8511,7 +8525,7 @@
             <a:r>
               <a:rPr lang="en-US" sz="1400" b="1" u="none" strike="noStrike">
                 <a:solidFill>
-                  <a:srgbClr val="E51D2A"/>
+                  <a:srgbClr val="89B4FA"/>
                 </a:solidFill>
                 <a:effectLst/>
                 <a:uFillTx/>
@@ -8521,7 +8535,7 @@
             </a:r>
             <a:endParaRPr lang="en-US" sz="1400" b="0" u="none" strike="noStrike">
               <a:solidFill>
-                <a:srgbClr val="000000"/>
+                <a:srgbClr val="CDD6F4"/>
               </a:solidFill>
               <a:effectLst/>
               <a:uFillTx/>
@@ -8571,7 +8585,7 @@
             <a:r>
               <a:rPr lang="en-US" sz="1300" b="1" u="none" strike="noStrike">
                 <a:solidFill>
-                  <a:srgbClr val="171923"/>
+                  <a:srgbClr val="CDD6F4"/>
                 </a:solidFill>
                 <a:effectLst/>
                 <a:uFillTx/>
@@ -8581,7 +8595,7 @@
             </a:r>
             <a:endParaRPr lang="en-US" sz="1300" b="0" u="none" strike="noStrike">
               <a:solidFill>
-                <a:srgbClr val="000000"/>
+                <a:srgbClr val="CDD6F4"/>
               </a:solidFill>
               <a:effectLst/>
               <a:uFillTx/>
@@ -8607,11 +8621,11 @@
             </a:avLst>
           </a:prstGeom>
           <a:solidFill>
-            <a:srgbClr val="FFFFFF"/>
+            <a:srgbClr val="313244"/>
           </a:solidFill>
           <a:ln w="12600">
             <a:solidFill>
-              <a:srgbClr val="E8E6E2"/>
+              <a:srgbClr val="45475A"/>
             </a:solidFill>
             <a:round/>
           </a:ln>
@@ -8629,7 +8643,7 @@
           <a:p>
             <a:endParaRPr lang="en-US" sz="1800" b="0" u="none" strike="noStrike">
               <a:solidFill>
-                <a:srgbClr val="000000"/>
+                <a:srgbClr val="CDD6F4"/>
               </a:solidFill>
               <a:effectLst/>
               <a:uFillTx/>
@@ -8679,7 +8693,7 @@
             <a:r>
               <a:rPr lang="en-US" sz="1400" b="1" u="none" strike="noStrike">
                 <a:solidFill>
-                  <a:srgbClr val="E51D2A"/>
+                  <a:srgbClr val="89B4FA"/>
                 </a:solidFill>
                 <a:effectLst/>
                 <a:uFillTx/>
@@ -8689,7 +8703,7 @@
             </a:r>
             <a:endParaRPr lang="en-US" sz="1400" b="0" u="none" strike="noStrike">
               <a:solidFill>
-                <a:srgbClr val="000000"/>
+                <a:srgbClr val="CDD6F4"/>
               </a:solidFill>
               <a:effectLst/>
               <a:uFillTx/>
@@ -8739,7 +8753,7 @@
             <a:r>
               <a:rPr lang="en-US" sz="1300" b="1" u="none" strike="noStrike">
                 <a:solidFill>
-                  <a:srgbClr val="171923"/>
+                  <a:srgbClr val="CDD6F4"/>
                 </a:solidFill>
                 <a:effectLst/>
                 <a:uFillTx/>
@@ -8749,7 +8763,7 @@
             </a:r>
             <a:endParaRPr lang="en-US" sz="1300" b="0" u="none" strike="noStrike">
               <a:solidFill>
-                <a:srgbClr val="000000"/>
+                <a:srgbClr val="CDD6F4"/>
               </a:solidFill>
               <a:effectLst/>
               <a:uFillTx/>
@@ -8775,11 +8789,11 @@
             </a:avLst>
           </a:prstGeom>
           <a:solidFill>
-            <a:srgbClr val="FFFFFF"/>
+            <a:srgbClr val="313244"/>
           </a:solidFill>
           <a:ln w="12600">
             <a:solidFill>
-              <a:srgbClr val="E8E6E2"/>
+              <a:srgbClr val="45475A"/>
             </a:solidFill>
             <a:round/>
           </a:ln>
@@ -8797,7 +8811,7 @@
           <a:p>
             <a:endParaRPr lang="en-US" sz="1800" b="0" u="none" strike="noStrike">
               <a:solidFill>
-                <a:srgbClr val="000000"/>
+                <a:srgbClr val="CDD6F4"/>
               </a:solidFill>
               <a:effectLst/>
               <a:uFillTx/>
@@ -8847,7 +8861,7 @@
             <a:r>
               <a:rPr lang="en-US" sz="1400" b="1" u="none" strike="noStrike">
                 <a:solidFill>
-                  <a:srgbClr val="E51D2A"/>
+                  <a:srgbClr val="89B4FA"/>
                 </a:solidFill>
                 <a:effectLst/>
                 <a:uFillTx/>
@@ -8857,7 +8871,7 @@
             </a:r>
             <a:endParaRPr lang="en-US" sz="1400" b="0" u="none" strike="noStrike">
               <a:solidFill>
-                <a:srgbClr val="000000"/>
+                <a:srgbClr val="CDD6F4"/>
               </a:solidFill>
               <a:effectLst/>
               <a:uFillTx/>
@@ -8907,7 +8921,7 @@
             <a:r>
               <a:rPr lang="en-US" sz="1300" b="1" u="none" strike="noStrike">
                 <a:solidFill>
-                  <a:srgbClr val="171923"/>
+                  <a:srgbClr val="CDD6F4"/>
                 </a:solidFill>
                 <a:effectLst/>
                 <a:uFillTx/>
@@ -8917,7 +8931,7 @@
             </a:r>
             <a:endParaRPr lang="en-US" sz="1300" b="0" u="none" strike="noStrike">
               <a:solidFill>
-                <a:srgbClr val="000000"/>
+                <a:srgbClr val="CDD6F4"/>
               </a:solidFill>
               <a:effectLst/>
               <a:uFillTx/>
@@ -8943,11 +8957,11 @@
             </a:avLst>
           </a:prstGeom>
           <a:solidFill>
-            <a:srgbClr val="FFFFFF"/>
+            <a:srgbClr val="313244"/>
           </a:solidFill>
           <a:ln w="12600">
             <a:solidFill>
-              <a:srgbClr val="E8E6E2"/>
+              <a:srgbClr val="45475A"/>
             </a:solidFill>
             <a:round/>
           </a:ln>
@@ -8965,7 +8979,7 @@
           <a:p>
             <a:endParaRPr lang="en-US" sz="1800" b="0" u="none" strike="noStrike">
               <a:solidFill>
-                <a:srgbClr val="000000"/>
+                <a:srgbClr val="CDD6F4"/>
               </a:solidFill>
               <a:effectLst/>
               <a:uFillTx/>
@@ -9015,7 +9029,7 @@
             <a:r>
               <a:rPr lang="en-US" sz="1400" b="1" u="none" strike="noStrike">
                 <a:solidFill>
-                  <a:srgbClr val="E51D2A"/>
+                  <a:srgbClr val="89B4FA"/>
                 </a:solidFill>
                 <a:effectLst/>
                 <a:uFillTx/>
@@ -9025,7 +9039,7 @@
             </a:r>
             <a:endParaRPr lang="en-US" sz="1400" b="0" u="none" strike="noStrike">
               <a:solidFill>
-                <a:srgbClr val="000000"/>
+                <a:srgbClr val="CDD6F4"/>
               </a:solidFill>
               <a:effectLst/>
               <a:uFillTx/>
@@ -9075,17 +9089,17 @@
             <a:r>
               <a:rPr lang="en-US" sz="1300" b="1" u="none" strike="noStrike">
                 <a:solidFill>
-                  <a:srgbClr val="171923"/>
-                </a:solidFill>
-                <a:effectLst/>
-                <a:uFillTx/>
-                <a:latin typeface="Arial"/>
-              </a:rPr>
-              <a:t>Thanh toán &amp; Xuất vé QR: Xác nhận thanh toán mô phỏng; sinh ngay Vé điện tử có mã QR check-in.</a:t>
+                  <a:srgbClr val="CDD6F4"/>
+                </a:solidFill>
+                <a:effectLst/>
+                <a:uFillTx/>
+                <a:latin typeface="Arial"/>
+              </a:rPr>
+              <a:t>Thanh toán &amp; Xuất vé QR: Xác nhận thanh toán đa kênh (MoMo/ZaloPay/Thẻ/VietQR); sinh ngay Vé điện tử có mã QR check-in.</a:t>
             </a:r>
             <a:endParaRPr lang="en-US" sz="1300" b="0" u="none" strike="noStrike">
               <a:solidFill>
-                <a:srgbClr val="000000"/>
+                <a:srgbClr val="CDD6F4"/>
               </a:solidFill>
               <a:effectLst/>
               <a:uFillTx/>
@@ -9135,7 +9149,7 @@
             <a:r>
               <a:rPr lang="en-US" sz="5900" b="1" u="none" spc="-201" strike="noStrike">
                 <a:solidFill>
-                  <a:srgbClr val="E51D2A"/>
+                  <a:srgbClr val="89B4FA"/>
                 </a:solidFill>
                 <a:effectLst/>
                 <a:uFillTx/>
@@ -9145,7 +9159,7 @@
             </a:r>
             <a:endParaRPr lang="en-US" sz="5900" b="0" u="none" strike="noStrike">
               <a:solidFill>
-                <a:srgbClr val="000000"/>
+                <a:srgbClr val="CDD6F4"/>
               </a:solidFill>
               <a:effectLst/>
               <a:uFillTx/>
@@ -9195,7 +9209,7 @@
             <a:r>
               <a:rPr lang="en-US" sz="1100" b="1" u="none" spc="99" strike="noStrike">
                 <a:solidFill>
-                  <a:srgbClr val="171923"/>
+                  <a:srgbClr val="CDD6F4"/>
                 </a:solidFill>
                 <a:effectLst/>
                 <a:uFillTx/>
@@ -9205,7 +9219,7 @@
             </a:r>
             <a:endParaRPr lang="en-US" sz="1100" b="0" u="none" strike="noStrike">
               <a:solidFill>
-                <a:srgbClr val="000000"/>
+                <a:srgbClr val="CDD6F4"/>
               </a:solidFill>
               <a:effectLst/>
               <a:uFillTx/>
@@ -9231,11 +9245,11 @@
             </a:avLst>
           </a:prstGeom>
           <a:solidFill>
-            <a:srgbClr val="FFFFFF"/>
+            <a:srgbClr val="313244"/>
           </a:solidFill>
           <a:ln w="12600">
             <a:solidFill>
-              <a:srgbClr val="E8E6E2"/>
+              <a:srgbClr val="45475A"/>
             </a:solidFill>
             <a:round/>
           </a:ln>
@@ -9253,7 +9267,7 @@
           <a:p>
             <a:endParaRPr lang="en-US" sz="1800" b="0" u="none" strike="noStrike">
               <a:solidFill>
-                <a:srgbClr val="000000"/>
+                <a:srgbClr val="CDD6F4"/>
               </a:solidFill>
               <a:effectLst/>
               <a:uFillTx/>
@@ -9281,11 +9295,11 @@
             <a:avLst/>
           </a:prstGeom>
           <a:solidFill>
-            <a:srgbClr val="FFFFFF"/>
+            <a:srgbClr val="313244"/>
           </a:solidFill>
           <a:ln w="12600">
             <a:solidFill>
-              <a:srgbClr val="E8E6E2"/>
+              <a:srgbClr val="45475A"/>
             </a:solidFill>
             <a:round/>
           </a:ln>
@@ -9332,7 +9346,7 @@
             <a:r>
               <a:rPr lang="en-US" sz="900" b="1" u="none" spc="99" strike="noStrike">
                 <a:solidFill>
-                  <a:srgbClr val="E51D2A"/>
+                  <a:srgbClr val="89B4FA"/>
                 </a:solidFill>
                 <a:effectLst/>
                 <a:uFillTx/>
@@ -9343,7 +9357,7 @@
             <a:r>
               <a:rPr lang="en-US" sz="1050" b="0" u="none" strike="noStrike">
                 <a:solidFill>
-                  <a:srgbClr val="171923"/>
+                  <a:srgbClr val="CDD6F4"/>
                 </a:solidFill>
                 <a:effectLst/>
                 <a:uFillTx/>
@@ -9353,7 +9367,7 @@
             </a:r>
             <a:endParaRPr lang="en-US" sz="1050" b="0" u="none" strike="noStrike">
               <a:solidFill>
-                <a:srgbClr val="000000"/>
+                <a:srgbClr val="CDD6F4"/>
               </a:solidFill>
               <a:effectLst/>
               <a:uFillTx/>
@@ -9372,7 +9386,7 @@
             <a:r>
               <a:rPr lang="en-US" sz="1300" b="1" u="none" strike="noStrike">
                 <a:solidFill>
-                  <a:srgbClr val="E51D2A"/>
+                  <a:srgbClr val="89B4FA"/>
                 </a:solidFill>
                 <a:effectLst/>
                 <a:uFillTx/>
@@ -9383,17 +9397,17 @@
             <a:r>
               <a:rPr lang="en-US" sz="900" b="0" u="none" strike="noStrike">
                 <a:solidFill>
-                  <a:srgbClr val="747985"/>
-                </a:solidFill>
-                <a:effectLst/>
-                <a:uFillTx/>
-                <a:latin typeface="Arial"/>
-              </a:rPr>
-              <a:t>Demo thêm: Thẻ thành viên 3D · Admin soát vé QR (56/56 Tests PASS)</a:t>
+                  <a:srgbClr val="A6ADC8"/>
+                </a:solidFill>
+                <a:effectLst/>
+                <a:uFillTx/>
+                <a:latin typeface="Arial"/>
+              </a:rPr>
+              <a:t>Demo thêm: Thẻ thành viên 3D · Trang Profile tra cứu vé · Admin soát vé QR &amp; 8 Tabs quản lý (56/56 Tests PASS)</a:t>
             </a:r>
             <a:endParaRPr lang="en-US" sz="900" b="0" u="none" strike="noStrike">
               <a:solidFill>
-                <a:srgbClr val="000000"/>
+                <a:srgbClr val="CDD6F4"/>
               </a:solidFill>
               <a:effectLst/>
               <a:uFillTx/>
@@ -9421,7 +9435,7 @@
     <p:bg>
       <p:bgPr>
         <a:solidFill>
-          <a:srgbClr val="F4F2EF"/>
+          <a:srgbClr val="1E1E2E"/>
         </a:solidFill>
       </p:bgPr>
     </p:bg>
@@ -9454,11 +9468,11 @@
             <a:avLst/>
           </a:prstGeom>
           <a:solidFill>
-            <a:srgbClr val="E51D2A"/>
+            <a:srgbClr val="89B4FA"/>
           </a:solidFill>
           <a:ln w="12600">
             <a:solidFill>
-              <a:srgbClr val="E51D2A">
+              <a:srgbClr val="89B4FA">
                 <a:alpha val="0"/>
               </a:srgbClr>
             </a:solidFill>
@@ -9528,7 +9542,7 @@
             <a:r>
               <a:rPr lang="en-US" sz="1000" b="1" u="none" spc="150" strike="noStrike">
                 <a:solidFill>
-                  <a:srgbClr val="E51D2A"/>
+                  <a:srgbClr val="89B4FA"/>
                 </a:solidFill>
                 <a:effectLst/>
                 <a:uFillTx/>
@@ -9538,7 +9552,7 @@
             </a:r>
             <a:endParaRPr lang="en-US" sz="1000" b="0" u="none" strike="noStrike">
               <a:solidFill>
-                <a:srgbClr val="000000"/>
+                <a:srgbClr val="CDD6F4"/>
               </a:solidFill>
               <a:effectLst/>
               <a:uFillTx/>
@@ -9588,7 +9602,7 @@
             <a:r>
               <a:rPr lang="en-US" sz="900" b="1" u="none" spc="99" strike="noStrike">
                 <a:solidFill>
-                  <a:srgbClr val="747985"/>
+                  <a:srgbClr val="A6ADC8"/>
                 </a:solidFill>
                 <a:effectLst/>
                 <a:uFillTx/>
@@ -9598,7 +9612,7 @@
             </a:r>
             <a:endParaRPr lang="en-US" sz="900" b="0" u="none" strike="noStrike">
               <a:solidFill>
-                <a:srgbClr val="000000"/>
+                <a:srgbClr val="CDD6F4"/>
               </a:solidFill>
               <a:effectLst/>
               <a:uFillTx/>
@@ -9648,7 +9662,7 @@
             <a:r>
               <a:rPr lang="en-US" sz="900" b="0" u="none" strike="noStrike">
                 <a:solidFill>
-                  <a:srgbClr val="999999"/>
+                  <a:srgbClr val="9399B2"/>
                 </a:solidFill>
                 <a:effectLst/>
                 <a:uFillTx/>
@@ -9658,7 +9672,7 @@
             </a:r>
             <a:endParaRPr lang="en-US" sz="900" b="0" u="none" strike="noStrike">
               <a:solidFill>
-                <a:srgbClr val="000000"/>
+                <a:srgbClr val="CDD6F4"/>
               </a:solidFill>
               <a:effectLst/>
               <a:uFillTx/>
@@ -9708,7 +9722,7 @@
             <a:r>
               <a:rPr lang="en-US" sz="1000" b="1" u="none" spc="159" strike="noStrike">
                 <a:solidFill>
-                  <a:srgbClr val="E51D2A"/>
+                  <a:srgbClr val="89B4FA"/>
                 </a:solidFill>
                 <a:effectLst/>
                 <a:uFillTx/>
@@ -9718,7 +9732,7 @@
             </a:r>
             <a:endParaRPr lang="en-US" sz="1000" b="0" u="none" strike="noStrike">
               <a:solidFill>
-                <a:srgbClr val="000000"/>
+                <a:srgbClr val="CDD6F4"/>
               </a:solidFill>
               <a:effectLst/>
               <a:uFillTx/>
@@ -9768,7 +9782,7 @@
             <a:r>
               <a:rPr lang="en-US" sz="3100" b="1" u="none" spc="-51" strike="noStrike">
                 <a:solidFill>
-                  <a:srgbClr val="171923"/>
+                  <a:srgbClr val="CDD6F4"/>
                 </a:solidFill>
                 <a:effectLst/>
                 <a:uFillTx/>
@@ -9778,7 +9792,7 @@
             </a:r>
             <a:endParaRPr lang="en-US" sz="3100" b="0" u="none" strike="noStrike">
               <a:solidFill>
-                <a:srgbClr val="000000"/>
+                <a:srgbClr val="CDD6F4"/>
               </a:solidFill>
               <a:effectLst/>
               <a:uFillTx/>
@@ -9804,11 +9818,11 @@
             </a:avLst>
           </a:prstGeom>
           <a:solidFill>
-            <a:srgbClr val="FFFFFF"/>
+            <a:srgbClr val="313244"/>
           </a:solidFill>
           <a:ln w="12600">
             <a:solidFill>
-              <a:srgbClr val="E8E6E2"/>
+              <a:srgbClr val="45475A"/>
             </a:solidFill>
             <a:round/>
           </a:ln>
@@ -9826,7 +9840,7 @@
           <a:p>
             <a:endParaRPr lang="en-US" sz="1800" b="0" u="none" strike="noStrike">
               <a:solidFill>
-                <a:srgbClr val="000000"/>
+                <a:srgbClr val="CDD6F4"/>
               </a:solidFill>
               <a:effectLst/>
               <a:uFillTx/>
@@ -9876,7 +9890,7 @@
             <a:r>
               <a:rPr lang="en-US" sz="1400" b="1" u="none" spc="40" strike="noStrike">
                 <a:solidFill>
-                  <a:srgbClr val="171923"/>
+                  <a:srgbClr val="CDD6F4"/>
                 </a:solidFill>
                 <a:effectLst/>
                 <a:uFillTx/>
@@ -9886,7 +9900,7 @@
             </a:r>
             <a:endParaRPr lang="en-US" sz="1400" b="0" u="none" strike="noStrike">
               <a:solidFill>
-                <a:srgbClr val="000000"/>
+                <a:srgbClr val="CDD6F4"/>
               </a:solidFill>
               <a:effectLst/>
               <a:uFillTx/>
@@ -9936,7 +9950,7 @@
             <a:r>
               <a:rPr lang="en-US" sz="1300" b="1" u="none" strike="noStrike">
                 <a:solidFill>
-                  <a:srgbClr val="E51D2A"/>
+                  <a:srgbClr val="89B4FA"/>
                 </a:solidFill>
                 <a:effectLst/>
                 <a:uFillTx/>
@@ -9946,7 +9960,7 @@
             </a:r>
             <a:endParaRPr lang="en-US" sz="1300" b="0" u="none" strike="noStrike">
               <a:solidFill>
-                <a:srgbClr val="000000"/>
+                <a:srgbClr val="CDD6F4"/>
               </a:solidFill>
               <a:effectLst/>
               <a:uFillTx/>
@@ -9996,7 +10010,7 @@
             <a:r>
               <a:rPr lang="en-US" sz="1100" b="0" u="none" strike="noStrike">
                 <a:solidFill>
-                  <a:srgbClr val="171923"/>
+                  <a:srgbClr val="CDD6F4"/>
                 </a:solidFill>
                 <a:effectLst/>
                 <a:uFillTx/>
@@ -10006,7 +10020,7 @@
             </a:r>
             <a:endParaRPr lang="en-US" sz="1100" b="0" u="none" strike="noStrike">
               <a:solidFill>
-                <a:srgbClr val="000000"/>
+                <a:srgbClr val="CDD6F4"/>
               </a:solidFill>
               <a:effectLst/>
               <a:uFillTx/>
@@ -10056,7 +10070,7 @@
             <a:r>
               <a:rPr lang="en-US" sz="1300" b="1" u="none" strike="noStrike">
                 <a:solidFill>
-                  <a:srgbClr val="E51D2A"/>
+                  <a:srgbClr val="89B4FA"/>
                 </a:solidFill>
                 <a:effectLst/>
                 <a:uFillTx/>
@@ -10066,7 +10080,7 @@
             </a:r>
             <a:endParaRPr lang="en-US" sz="1300" b="0" u="none" strike="noStrike">
               <a:solidFill>
-                <a:srgbClr val="000000"/>
+                <a:srgbClr val="CDD6F4"/>
               </a:solidFill>
               <a:effectLst/>
               <a:uFillTx/>
@@ -10116,17 +10130,17 @@
             <a:r>
               <a:rPr lang="en-US" sz="1100" b="0" u="none" strike="noStrike">
                 <a:solidFill>
-                  <a:srgbClr val="171923"/>
-                </a:solidFill>
-                <a:effectLst/>
-                <a:uFillTx/>
-                <a:latin typeface="Arial"/>
-              </a:rPr>
-              <a:t>Vũ Tiến Lập — Frontend &amp; QA Lead: Module Checkout, bắp nước, Bảng giá vé, Tin tức, Cụm rạp, Bộ test 56/56.</a:t>
+                  <a:srgbClr val="CDD6F4"/>
+                </a:solidFill>
+                <a:effectLst/>
+                <a:uFillTx/>
+                <a:latin typeface="Arial"/>
+              </a:rPr>
+              <a:t>Vũ Tiến Lập (PH65133) — Frontend &amp; QA Lead: Module Checkout, bắp nước, Bảng giá vé, Tin tức, Cụm rạp, Bộ test 56/56.</a:t>
             </a:r>
             <a:endParaRPr lang="en-US" sz="1100" b="0" u="none" strike="noStrike">
               <a:solidFill>
-                <a:srgbClr val="000000"/>
+                <a:srgbClr val="CDD6F4"/>
               </a:solidFill>
               <a:effectLst/>
               <a:uFillTx/>
@@ -10176,7 +10190,7 @@
             <a:r>
               <a:rPr lang="en-US" sz="1300" b="1" u="none" strike="noStrike">
                 <a:solidFill>
-                  <a:srgbClr val="E51D2A"/>
+                  <a:srgbClr val="89B4FA"/>
                 </a:solidFill>
                 <a:effectLst/>
                 <a:uFillTx/>
@@ -10186,7 +10200,7 @@
             </a:r>
             <a:endParaRPr lang="en-US" sz="1300" b="0" u="none" strike="noStrike">
               <a:solidFill>
-                <a:srgbClr val="000000"/>
+                <a:srgbClr val="CDD6F4"/>
               </a:solidFill>
               <a:effectLst/>
               <a:uFillTx/>
@@ -10236,17 +10250,17 @@
             <a:r>
               <a:rPr lang="en-US" sz="1100" b="0" u="none" strike="noStrike">
                 <a:solidFill>
-                  <a:srgbClr val="171923"/>
-                </a:solidFill>
-                <a:effectLst/>
-                <a:uFillTx/>
-                <a:latin typeface="Arial"/>
-              </a:rPr>
-              <a:t>Phạm Anh Duy — Feature Lead &amp; Integrator: Sơ đồ 164 ghế &amp; đếm ngược 5p, Hệ thống Voucher, Thẻ thành viên 3D, Cổng Admin QR.</a:t>
+                  <a:srgbClr val="CDD6F4"/>
+                </a:solidFill>
+                <a:effectLst/>
+                <a:uFillTx/>
+                <a:latin typeface="Arial"/>
+              </a:rPr>
+              <a:t>Phạm Anh Duy (PH65717) — Feature Lead &amp; Integrator: Sơ đồ 164 ghế &amp; đếm ngược 5p, Hệ thống Voucher, Thẻ thành viên 3D, Cổng Admin QR.</a:t>
             </a:r>
             <a:endParaRPr lang="en-US" sz="1100" b="0" u="none" strike="noStrike">
               <a:solidFill>
-                <a:srgbClr val="000000"/>
+                <a:srgbClr val="CDD6F4"/>
               </a:solidFill>
               <a:effectLst/>
               <a:uFillTx/>
@@ -10296,7 +10310,7 @@
             <a:r>
               <a:rPr lang="en-US" sz="900" b="1" u="none" strike="noStrike">
                 <a:solidFill>
-                  <a:srgbClr val="747985"/>
+                  <a:srgbClr val="A6ADC8"/>
                 </a:solidFill>
                 <a:effectLst/>
                 <a:uFillTx/>
@@ -10306,7 +10320,7 @@
             </a:r>
             <a:endParaRPr lang="en-US" sz="900" b="0" u="none" strike="noStrike">
               <a:solidFill>
-                <a:srgbClr val="000000"/>
+                <a:srgbClr val="CDD6F4"/>
               </a:solidFill>
               <a:effectLst/>
               <a:uFillTx/>
@@ -10353,7 +10367,7 @@
             <a:r>
               <a:rPr lang="en-US" sz="1100" b="1" u="sng" strike="noStrike">
                 <a:solidFill>
-                  <a:srgbClr val="E51D2A"/>
+                  <a:srgbClr val="89B4FA"/>
                 </a:solidFill>
                 <a:effectLst/>
                 <a:uFillTx/>
@@ -10365,7 +10379,7 @@
             <a:r>
               <a:rPr lang="en-US" sz="900" b="0" u="none" strike="noStrike">
                 <a:solidFill>
-                  <a:srgbClr val="747985"/>
+                  <a:srgbClr val="A6ADC8"/>
                 </a:solidFill>
                 <a:effectLst/>
                 <a:uFillTx/>
@@ -10375,7 +10389,7 @@
             </a:r>
             <a:endParaRPr lang="en-US" sz="900" b="0" u="none" strike="noStrike">
               <a:solidFill>
-                <a:srgbClr val="000000"/>
+                <a:srgbClr val="CDD6F4"/>
               </a:solidFill>
               <a:effectLst/>
               <a:uFillTx/>
@@ -10401,11 +10415,11 @@
             </a:avLst>
           </a:prstGeom>
           <a:solidFill>
-            <a:srgbClr val="FFFFFF"/>
+            <a:srgbClr val="313244"/>
           </a:solidFill>
           <a:ln w="12600">
             <a:solidFill>
-              <a:srgbClr val="E8E6E2"/>
+              <a:srgbClr val="45475A"/>
             </a:solidFill>
             <a:round/>
           </a:ln>
@@ -10423,7 +10437,7 @@
           <a:p>
             <a:endParaRPr lang="en-US" sz="1800" b="0" u="none" strike="noStrike">
               <a:solidFill>
-                <a:srgbClr val="000000"/>
+                <a:srgbClr val="CDD6F4"/>
               </a:solidFill>
               <a:effectLst/>
               <a:uFillTx/>
@@ -10473,7 +10487,7 @@
             <a:r>
               <a:rPr lang="en-US" sz="1400" b="1" u="none" spc="40" strike="noStrike">
                 <a:solidFill>
-                  <a:srgbClr val="171923"/>
+                  <a:srgbClr val="CDD6F4"/>
                 </a:solidFill>
                 <a:effectLst/>
                 <a:uFillTx/>
@@ -10483,7 +10497,7 @@
             </a:r>
             <a:endParaRPr lang="en-US" sz="1400" b="0" u="none" strike="noStrike">
               <a:solidFill>
-                <a:srgbClr val="000000"/>
+                <a:srgbClr val="CDD6F4"/>
               </a:solidFill>
               <a:effectLst/>
               <a:uFillTx/>
@@ -10533,7 +10547,7 @@
             <a:r>
               <a:rPr lang="en-US" sz="1300" b="1" u="none" strike="noStrike">
                 <a:solidFill>
-                  <a:srgbClr val="E51D2A"/>
+                  <a:srgbClr val="89B4FA"/>
                 </a:solidFill>
                 <a:effectLst/>
                 <a:uFillTx/>
@@ -10543,7 +10557,7 @@
             </a:r>
             <a:endParaRPr lang="en-US" sz="1300" b="0" u="none" strike="noStrike">
               <a:solidFill>
-                <a:srgbClr val="000000"/>
+                <a:srgbClr val="CDD6F4"/>
               </a:solidFill>
               <a:effectLst/>
               <a:uFillTx/>
@@ -10593,7 +10607,7 @@
             <a:r>
               <a:rPr lang="en-US" sz="1100" b="0" u="none" strike="noStrike">
                 <a:solidFill>
-                  <a:srgbClr val="171923"/>
+                  <a:srgbClr val="CDD6F4"/>
                 </a:solidFill>
                 <a:effectLst/>
                 <a:uFillTx/>
@@ -10603,7 +10617,7 @@
             </a:r>
             <a:endParaRPr lang="en-US" sz="1100" b="0" u="none" strike="noStrike">
               <a:solidFill>
-                <a:srgbClr val="000000"/>
+                <a:srgbClr val="CDD6F4"/>
               </a:solidFill>
               <a:effectLst/>
               <a:uFillTx/>
@@ -10653,7 +10667,7 @@
             <a:r>
               <a:rPr lang="en-US" sz="1300" b="1" u="none" strike="noStrike">
                 <a:solidFill>
-                  <a:srgbClr val="E51D2A"/>
+                  <a:srgbClr val="89B4FA"/>
                 </a:solidFill>
                 <a:effectLst/>
                 <a:uFillTx/>
@@ -10663,7 +10677,7 @@
             </a:r>
             <a:endParaRPr lang="en-US" sz="1300" b="0" u="none" strike="noStrike">
               <a:solidFill>
-                <a:srgbClr val="000000"/>
+                <a:srgbClr val="CDD6F4"/>
               </a:solidFill>
               <a:effectLst/>
               <a:uFillTx/>
@@ -10713,7 +10727,7 @@
             <a:r>
               <a:rPr lang="en-US" sz="1100" b="0" u="none" strike="noStrike">
                 <a:solidFill>
-                  <a:srgbClr val="171923"/>
+                  <a:srgbClr val="CDD6F4"/>
                 </a:solidFill>
                 <a:effectLst/>
                 <a:uFillTx/>
@@ -10723,7 +10737,7 @@
             </a:r>
             <a:endParaRPr lang="en-US" sz="1100" b="0" u="none" strike="noStrike">
               <a:solidFill>
-                <a:srgbClr val="000000"/>
+                <a:srgbClr val="CDD6F4"/>
               </a:solidFill>
               <a:effectLst/>
               <a:uFillTx/>
@@ -10773,7 +10787,7 @@
             <a:r>
               <a:rPr lang="en-US" sz="1400" b="1" u="none" spc="40" strike="noStrike">
                 <a:solidFill>
-                  <a:srgbClr val="171923"/>
+                  <a:srgbClr val="CDD6F4"/>
                 </a:solidFill>
                 <a:effectLst/>
                 <a:uFillTx/>
@@ -10783,7 +10797,7 @@
             </a:r>
             <a:endParaRPr lang="en-US" sz="1400" b="0" u="none" strike="noStrike">
               <a:solidFill>
-                <a:srgbClr val="000000"/>
+                <a:srgbClr val="CDD6F4"/>
               </a:solidFill>
               <a:effectLst/>
               <a:uFillTx/>
@@ -10830,7 +10844,7 @@
             <a:r>
               <a:rPr lang="en-US" sz="1300" b="1" u="none" strike="noStrike">
                 <a:solidFill>
-                  <a:srgbClr val="E51D2A"/>
+                  <a:srgbClr val="89B4FA"/>
                 </a:solidFill>
                 <a:effectLst/>
                 <a:uFillTx/>
@@ -10841,7 +10855,7 @@
             <a:r>
               <a:rPr lang="en-US" sz="1050" b="0" u="none" strike="noStrike">
                 <a:solidFill>
-                  <a:srgbClr val="171923"/>
+                  <a:srgbClr val="CDD6F4"/>
                 </a:solidFill>
                 <a:effectLst/>
                 <a:uFillTx/>
@@ -10851,7 +10865,7 @@
             </a:r>
             <a:endParaRPr lang="en-US" sz="1050" b="0" u="none" strike="noStrike">
               <a:solidFill>
-                <a:srgbClr val="000000"/>
+                <a:srgbClr val="CDD6F4"/>
               </a:solidFill>
               <a:effectLst/>
               <a:uFillTx/>
@@ -10870,7 +10884,7 @@
             <a:r>
               <a:rPr lang="en-US" sz="1300" b="1" u="none" strike="noStrike">
                 <a:solidFill>
-                  <a:srgbClr val="E51D2A"/>
+                  <a:srgbClr val="89B4FA"/>
                 </a:solidFill>
                 <a:effectLst/>
                 <a:uFillTx/>
@@ -10881,7 +10895,7 @@
             <a:r>
               <a:rPr lang="en-US" sz="1050" b="0" u="none" strike="noStrike">
                 <a:solidFill>
-                  <a:srgbClr val="171923"/>
+                  <a:srgbClr val="CDD6F4"/>
                 </a:solidFill>
                 <a:effectLst/>
                 <a:uFillTx/>
@@ -10891,7 +10905,7 @@
             </a:r>
             <a:endParaRPr lang="en-US" sz="1050" b="0" u="none" strike="noStrike">
               <a:solidFill>
-                <a:srgbClr val="000000"/>
+                <a:srgbClr val="CDD6F4"/>
               </a:solidFill>
               <a:effectLst/>
               <a:uFillTx/>
@@ -10910,7 +10924,7 @@
             <a:r>
               <a:rPr lang="en-US" sz="1300" b="1" u="none" strike="noStrike">
                 <a:solidFill>
-                  <a:srgbClr val="E51D2A"/>
+                  <a:srgbClr val="89B4FA"/>
                 </a:solidFill>
                 <a:effectLst/>
                 <a:uFillTx/>
@@ -10921,7 +10935,7 @@
             <a:r>
               <a:rPr lang="en-US" sz="1050" b="0" u="none" strike="noStrike">
                 <a:solidFill>
-                  <a:srgbClr val="171923"/>
+                  <a:srgbClr val="CDD6F4"/>
                 </a:solidFill>
                 <a:effectLst/>
                 <a:uFillTx/>
@@ -10931,7 +10945,7 @@
             </a:r>
             <a:endParaRPr lang="en-US" sz="1050" b="0" u="none" strike="noStrike">
               <a:solidFill>
-                <a:srgbClr val="000000"/>
+                <a:srgbClr val="CDD6F4"/>
               </a:solidFill>
               <a:effectLst/>
               <a:uFillTx/>

</xml_diff>